<commit_message>
Methodology deck: add top-5/bottom-5 by Ionic Score slide (live 59-book, analyst commentary)
Co-Authored-By: Claude Fable 5 <noreply@anthropic.com>
</commit_message>
<xml_diff>
--- a/Shreyas_Ionic_AMC/09_PRODUCT/reports/IONIC_SCORECARD_METHODOLOGY_DECK.pptx
+++ b/Shreyas_Ionic_AMC/09_PRODUCT/reports/IONIC_SCORECARD_METHODOLOGY_DECK.pptx
@@ -28,6 +28,7 @@
     <p:sldId id="276" r:id="rId27"/>
     <p:sldId id="277" r:id="rId28"/>
     <p:sldId id="278" r:id="rId29"/>
+    <p:sldId id="279" r:id="rId30"/>
   </p:sldIdLst>
   <p:sldSz cx="12191695" cy="6858000" type="screen4x3"/>
   <p:notesSz cx="6858000" cy="9144000"/>
@@ -12015,7 +12016,7 @@
                 </a:solidFill>
                 <a:latin typeface="Bahnschrift"/>
               </a:rPr>
-              <a:t>The controls matter as much as the formulas</a:t>
+              <a:t>The scores in practice</a:t>
             </a:r>
           </a:p>
         </p:txBody>
@@ -12050,7 +12051,7 @@
                 </a:solidFill>
                 <a:latin typeface="Georgia"/>
               </a:rPr>
-              <a:t>How we keep it honest</a:t>
+              <a:t>Highest and lowest Ionic Scores in the live 59-stock client book, with the analyst's read</a:t>
             </a:r>
           </a:p>
         </p:txBody>
@@ -12215,22 +12216,20 @@
       </p:sp>
       <p:sp>
         <p:nvSpPr>
-          <p:cNvPr id="10" name="Rounded Rectangle 9"/>
+          <p:cNvPr id="10" name="Oval 9"/>
           <p:cNvSpPr/>
           <p:nvPr/>
         </p:nvSpPr>
         <p:spPr>
           <a:xfrm>
             <a:off x="548640" y="1463040"/>
-            <a:ext cx="146304" cy="603504"/>
-          </a:xfrm>
-          <a:prstGeom prst="roundRect">
-            <a:avLst>
-              <a:gd name="adj" fmla="val 30000"/>
-            </a:avLst>
+            <a:ext cx="146304" cy="146304"/>
+          </a:xfrm>
+          <a:prstGeom prst="ellipse">
+            <a:avLst/>
           </a:prstGeom>
           <a:solidFill>
-            <a:srgbClr val="2563EB"/>
+            <a:srgbClr val="15803D"/>
           </a:solidFill>
           <a:ln>
             <a:noFill/>
@@ -12267,8 +12266,8 @@
         </p:nvSpPr>
         <p:spPr>
           <a:xfrm>
-            <a:off x="868680" y="1444752"/>
-            <a:ext cx="2834640" cy="640080"/>
+            <a:off x="777240" y="1362456"/>
+            <a:ext cx="7315200" cy="274320"/>
           </a:xfrm>
           <a:prstGeom prst="rect">
             <a:avLst/>
@@ -12276,77 +12275,630 @@
           <a:noFill/>
         </p:spPr>
         <p:txBody>
-          <a:bodyPr wrap="square" anchor="ctr">
+          <a:bodyPr wrap="square" anchor="t">
             <a:spAutoFit/>
           </a:bodyPr>
           <a:lstStyle/>
           <a:p>
             <a:pPr algn="l"/>
             <a:r>
-              <a:rPr sz="1350" b="1" i="0">
-                <a:solidFill>
-                  <a:srgbClr val="1E3A8A"/>
+              <a:rPr sz="1300" b="1" i="0">
+                <a:solidFill>
+                  <a:srgbClr val="15803D"/>
                 </a:solidFill>
                 <a:latin typeface="Bahnschrift"/>
               </a:rPr>
-              <a:t>Schema validation</a:t>
-            </a:r>
-          </a:p>
-        </p:txBody>
-      </p:sp>
-      <p:sp>
-        <p:nvSpPr>
-          <p:cNvPr id="12" name="TextBox 11"/>
-          <p:cNvSpPr txBox="1"/>
-          <p:nvPr/>
-        </p:nvSpPr>
-        <p:spPr>
-          <a:xfrm>
-            <a:off x="3794760" y="1444752"/>
-            <a:ext cx="7863840" cy="640080"/>
-          </a:xfrm>
-          <a:prstGeom prst="rect">
-            <a:avLst/>
-          </a:prstGeom>
-          <a:noFill/>
-        </p:spPr>
-        <p:txBody>
-          <a:bodyPr wrap="square" anchor="ctr">
-            <a:spAutoFit/>
-          </a:bodyPr>
-          <a:lstStyle/>
-          <a:p>
-            <a:pPr algn="l"/>
-            <a:r>
-              <a:rPr sz="1250" b="0" i="0">
-                <a:solidFill>
-                  <a:srgbClr val="111827"/>
-                </a:solidFill>
-                <a:latin typeface="Georgia"/>
-              </a:rPr>
-              <a:t>Every research file is checked for all fields and correct types before it counts.</a:t>
-            </a:r>
-          </a:p>
-        </p:txBody>
-      </p:sp>
-      <p:sp>
-        <p:nvSpPr>
-          <p:cNvPr id="13" name="Rounded Rectangle 12"/>
+              <a:t>Top 5 by Ionic Score</a:t>
+            </a:r>
+          </a:p>
+        </p:txBody>
+      </p:sp>
+      <p:graphicFrame>
+        <p:nvGraphicFramePr>
+          <p:cNvPr id="12" name="Table 11"/>
+          <p:cNvGraphicFramePr>
+            <a:graphicFrameLocks noGrp="1"/>
+          </p:cNvGraphicFramePr>
+          <p:nvPr/>
+        </p:nvGraphicFramePr>
+        <p:xfrm>
+          <a:off x="548640" y="1709928"/>
+          <a:ext cx="11091670" cy="1975104"/>
+        </p:xfrm>
+        <a:graphic>
+          <a:graphicData uri="http://schemas.openxmlformats.org/drawingml/2006/table">
+            <a:tbl>
+              <a:tblPr firstRow="0" bandRow="0"/>
+              <a:tblGrid>
+                <a:gridCol w="2716327"/>
+                <a:gridCol w="769626"/>
+                <a:gridCol w="769626"/>
+                <a:gridCol w="6836091"/>
+              </a:tblGrid>
+              <a:tr h="329184">
+                <a:tc>
+                  <a:txBody>
+                    <a:bodyPr wrap="square"/>
+                    <a:lstStyle/>
+                    <a:p>
+                      <a:pPr algn="l"/>
+                      <a:r>
+                        <a:rPr sz="1050" b="1" i="0">
+                          <a:solidFill>
+                            <a:srgbClr val="FFFFFF"/>
+                          </a:solidFill>
+                          <a:latin typeface="Bahnschrift"/>
+                        </a:rPr>
+                        <a:t>Holding</a:t>
+                      </a:r>
+                    </a:p>
+                  </a:txBody>
+                  <a:tcPr marL="73152" marR="54864" marT="18288" marB="18288" anchor="ctr">
+                    <a:solidFill>
+                      <a:srgbClr val="1E3A8A"/>
+                    </a:solidFill>
+                  </a:tcPr>
+                </a:tc>
+                <a:tc>
+                  <a:txBody>
+                    <a:bodyPr wrap="square"/>
+                    <a:lstStyle/>
+                    <a:p>
+                      <a:pPr algn="ctr"/>
+                      <a:r>
+                        <a:rPr sz="1050" b="1" i="0">
+                          <a:solidFill>
+                            <a:srgbClr val="FFFFFF"/>
+                          </a:solidFill>
+                          <a:latin typeface="Bahnschrift"/>
+                        </a:rPr>
+                        <a:t>Score</a:t>
+                      </a:r>
+                    </a:p>
+                  </a:txBody>
+                  <a:tcPr marL="73152" marR="54864" marT="18288" marB="18288" anchor="ctr">
+                    <a:solidFill>
+                      <a:srgbClr val="1E3A8A"/>
+                    </a:solidFill>
+                  </a:tcPr>
+                </a:tc>
+                <a:tc>
+                  <a:txBody>
+                    <a:bodyPr wrap="square"/>
+                    <a:lstStyle/>
+                    <a:p>
+                      <a:pPr algn="ctr"/>
+                      <a:r>
+                        <a:rPr sz="1050" b="1" i="0">
+                          <a:solidFill>
+                            <a:srgbClr val="FFFFFF"/>
+                          </a:solidFill>
+                          <a:latin typeface="Bahnschrift"/>
+                        </a:rPr>
+                        <a:t>Call</a:t>
+                      </a:r>
+                    </a:p>
+                  </a:txBody>
+                  <a:tcPr marL="73152" marR="54864" marT="18288" marB="18288" anchor="ctr">
+                    <a:solidFill>
+                      <a:srgbClr val="1E3A8A"/>
+                    </a:solidFill>
+                  </a:tcPr>
+                </a:tc>
+                <a:tc>
+                  <a:txBody>
+                    <a:bodyPr wrap="square"/>
+                    <a:lstStyle/>
+                    <a:p>
+                      <a:pPr algn="l"/>
+                      <a:r>
+                        <a:rPr sz="1050" b="1" i="0">
+                          <a:solidFill>
+                            <a:srgbClr val="FFFFFF"/>
+                          </a:solidFill>
+                          <a:latin typeface="Bahnschrift"/>
+                        </a:rPr>
+                        <a:t>What the analyst is seeing</a:t>
+                      </a:r>
+                    </a:p>
+                  </a:txBody>
+                  <a:tcPr marL="73152" marR="54864" marT="18288" marB="18288" anchor="ctr">
+                    <a:solidFill>
+                      <a:srgbClr val="1E3A8A"/>
+                    </a:solidFill>
+                  </a:tcPr>
+                </a:tc>
+              </a:tr>
+              <a:tr h="329184">
+                <a:tc>
+                  <a:txBody>
+                    <a:bodyPr wrap="square"/>
+                    <a:lstStyle/>
+                    <a:p>
+                      <a:pPr algn="l"/>
+                      <a:r>
+                        <a:rPr sz="1050" b="1" i="0">
+                          <a:solidFill>
+                            <a:srgbClr val="111827"/>
+                          </a:solidFill>
+                          <a:latin typeface="Georgia"/>
+                        </a:rPr>
+                        <a:t>Suzlon (SUZLON)</a:t>
+                      </a:r>
+                    </a:p>
+                  </a:txBody>
+                  <a:tcPr marL="73152" marR="54864" marT="18288" marB="18288" anchor="ctr">
+                    <a:solidFill>
+                      <a:srgbClr val="FFFFFF"/>
+                    </a:solidFill>
+                  </a:tcPr>
+                </a:tc>
+                <a:tc>
+                  <a:txBody>
+                    <a:bodyPr wrap="square"/>
+                    <a:lstStyle/>
+                    <a:p>
+                      <a:pPr algn="ctr"/>
+                      <a:r>
+                        <a:rPr sz="1050" b="0" i="0">
+                          <a:solidFill>
+                            <a:srgbClr val="111827"/>
+                          </a:solidFill>
+                          <a:latin typeface="Georgia"/>
+                        </a:rPr>
+                        <a:t>89.1</a:t>
+                      </a:r>
+                    </a:p>
+                  </a:txBody>
+                  <a:tcPr marL="73152" marR="54864" marT="18288" marB="18288" anchor="ctr">
+                    <a:solidFill>
+                      <a:srgbClr val="FFFFFF"/>
+                    </a:solidFill>
+                  </a:tcPr>
+                </a:tc>
+                <a:tc>
+                  <a:txBody>
+                    <a:bodyPr wrap="square"/>
+                    <a:lstStyle/>
+                    <a:p>
+                      <a:pPr algn="ctr"/>
+                      <a:r>
+                        <a:rPr sz="1050" b="0" i="0">
+                          <a:solidFill>
+                            <a:srgbClr val="15803D"/>
+                          </a:solidFill>
+                          <a:latin typeface="Georgia"/>
+                        </a:rPr>
+                        <a:t>Hold</a:t>
+                      </a:r>
+                    </a:p>
+                  </a:txBody>
+                  <a:tcPr marL="73152" marR="54864" marT="18288" marB="18288" anchor="ctr">
+                    <a:solidFill>
+                      <a:srgbClr val="FFFFFF"/>
+                    </a:solidFill>
+                  </a:tcPr>
+                </a:tc>
+                <a:tc>
+                  <a:txBody>
+                    <a:bodyPr wrap="square"/>
+                    <a:lstStyle/>
+                    <a:p>
+                      <a:pPr algn="l"/>
+                      <a:r>
+                        <a:rPr sz="1050" b="0" i="0">
+                          <a:solidFill>
+                            <a:srgbClr val="111827"/>
+                          </a:solidFill>
+                          <a:latin typeface="Georgia"/>
+                        </a:rPr>
+                        <a:t>Debt-free turnaround; 6.4 GW order book from near-zero, record FY26 deliveries.</a:t>
+                      </a:r>
+                    </a:p>
+                  </a:txBody>
+                  <a:tcPr marL="73152" marR="54864" marT="18288" marB="18288" anchor="ctr">
+                    <a:solidFill>
+                      <a:srgbClr val="FFFFFF"/>
+                    </a:solidFill>
+                  </a:tcPr>
+                </a:tc>
+              </a:tr>
+              <a:tr h="329184">
+                <a:tc>
+                  <a:txBody>
+                    <a:bodyPr wrap="square"/>
+                    <a:lstStyle/>
+                    <a:p>
+                      <a:pPr algn="l"/>
+                      <a:r>
+                        <a:rPr sz="1050" b="1" i="0">
+                          <a:solidFill>
+                            <a:srgbClr val="111827"/>
+                          </a:solidFill>
+                          <a:latin typeface="Georgia"/>
+                        </a:rPr>
+                        <a:t>Tata Motors CV (TMCV)</a:t>
+                      </a:r>
+                    </a:p>
+                  </a:txBody>
+                  <a:tcPr marL="73152" marR="54864" marT="18288" marB="18288" anchor="ctr">
+                    <a:solidFill>
+                      <a:srgbClr val="F3F4F6"/>
+                    </a:solidFill>
+                  </a:tcPr>
+                </a:tc>
+                <a:tc>
+                  <a:txBody>
+                    <a:bodyPr wrap="square"/>
+                    <a:lstStyle/>
+                    <a:p>
+                      <a:pPr algn="ctr"/>
+                      <a:r>
+                        <a:rPr sz="1050" b="0" i="0">
+                          <a:solidFill>
+                            <a:srgbClr val="111827"/>
+                          </a:solidFill>
+                          <a:latin typeface="Georgia"/>
+                        </a:rPr>
+                        <a:t>70.2</a:t>
+                      </a:r>
+                    </a:p>
+                  </a:txBody>
+                  <a:tcPr marL="73152" marR="54864" marT="18288" marB="18288" anchor="ctr">
+                    <a:solidFill>
+                      <a:srgbClr val="F3F4F6"/>
+                    </a:solidFill>
+                  </a:tcPr>
+                </a:tc>
+                <a:tc>
+                  <a:txBody>
+                    <a:bodyPr wrap="square"/>
+                    <a:lstStyle/>
+                    <a:p>
+                      <a:pPr algn="ctr"/>
+                      <a:r>
+                        <a:rPr sz="1050" b="0" i="0">
+                          <a:solidFill>
+                            <a:srgbClr val="15803D"/>
+                          </a:solidFill>
+                          <a:latin typeface="Georgia"/>
+                        </a:rPr>
+                        <a:t>Hold</a:t>
+                      </a:r>
+                    </a:p>
+                  </a:txBody>
+                  <a:tcPr marL="73152" marR="54864" marT="18288" marB="18288" anchor="ctr">
+                    <a:solidFill>
+                      <a:srgbClr val="F3F4F6"/>
+                    </a:solidFill>
+                  </a:tcPr>
+                </a:tc>
+                <a:tc>
+                  <a:txBody>
+                    <a:bodyPr wrap="square"/>
+                    <a:lstStyle/>
+                    <a:p>
+                      <a:pPr algn="l"/>
+                      <a:r>
+                        <a:rPr sz="1050" b="0" i="0">
+                          <a:solidFill>
+                            <a:srgbClr val="111827"/>
+                          </a:solidFill>
+                          <a:latin typeface="Georgia"/>
+                        </a:rPr>
+                        <a:t>Demerged CV maker executing: 11% revenue growth, margins up, share gains.</a:t>
+                      </a:r>
+                    </a:p>
+                  </a:txBody>
+                  <a:tcPr marL="73152" marR="54864" marT="18288" marB="18288" anchor="ctr">
+                    <a:solidFill>
+                      <a:srgbClr val="F3F4F6"/>
+                    </a:solidFill>
+                  </a:tcPr>
+                </a:tc>
+              </a:tr>
+              <a:tr h="329184">
+                <a:tc>
+                  <a:txBody>
+                    <a:bodyPr wrap="square"/>
+                    <a:lstStyle/>
+                    <a:p>
+                      <a:pPr algn="l"/>
+                      <a:r>
+                        <a:rPr sz="1050" b="1" i="0">
+                          <a:solidFill>
+                            <a:srgbClr val="111827"/>
+                          </a:solidFill>
+                          <a:latin typeface="Georgia"/>
+                        </a:rPr>
+                        <a:t>LIC (LICI)</a:t>
+                      </a:r>
+                    </a:p>
+                  </a:txBody>
+                  <a:tcPr marL="73152" marR="54864" marT="18288" marB="18288" anchor="ctr">
+                    <a:solidFill>
+                      <a:srgbClr val="FFFFFF"/>
+                    </a:solidFill>
+                  </a:tcPr>
+                </a:tc>
+                <a:tc>
+                  <a:txBody>
+                    <a:bodyPr wrap="square"/>
+                    <a:lstStyle/>
+                    <a:p>
+                      <a:pPr algn="ctr"/>
+                      <a:r>
+                        <a:rPr sz="1050" b="0" i="0">
+                          <a:solidFill>
+                            <a:srgbClr val="111827"/>
+                          </a:solidFill>
+                          <a:latin typeface="Georgia"/>
+                        </a:rPr>
+                        <a:t>69.4</a:t>
+                      </a:r>
+                    </a:p>
+                  </a:txBody>
+                  <a:tcPr marL="73152" marR="54864" marT="18288" marB="18288" anchor="ctr">
+                    <a:solidFill>
+                      <a:srgbClr val="FFFFFF"/>
+                    </a:solidFill>
+                  </a:tcPr>
+                </a:tc>
+                <a:tc>
+                  <a:txBody>
+                    <a:bodyPr wrap="square"/>
+                    <a:lstStyle/>
+                    <a:p>
+                      <a:pPr algn="ctr"/>
+                      <a:r>
+                        <a:rPr sz="1050" b="0" i="0">
+                          <a:solidFill>
+                            <a:srgbClr val="15803D"/>
+                          </a:solidFill>
+                          <a:latin typeface="Georgia"/>
+                        </a:rPr>
+                        <a:t>Hold</a:t>
+                      </a:r>
+                    </a:p>
+                  </a:txBody>
+                  <a:tcPr marL="73152" marR="54864" marT="18288" marB="18288" anchor="ctr">
+                    <a:solidFill>
+                      <a:srgbClr val="FFFFFF"/>
+                    </a:solidFill>
+                  </a:tcPr>
+                </a:tc>
+                <a:tc>
+                  <a:txBody>
+                    <a:bodyPr wrap="square"/>
+                    <a:lstStyle/>
+                    <a:p>
+                      <a:pPr algn="l"/>
+                      <a:r>
+                        <a:rPr sz="1050" b="0" i="0">
+                          <a:solidFill>
+                            <a:srgbClr val="111827"/>
+                          </a:solidFill>
+                          <a:latin typeface="Georgia"/>
+                        </a:rPr>
+                        <a:t>Real margin-quality gains; market share still slipping, but more slowly.</a:t>
+                      </a:r>
+                    </a:p>
+                  </a:txBody>
+                  <a:tcPr marL="73152" marR="54864" marT="18288" marB="18288" anchor="ctr">
+                    <a:solidFill>
+                      <a:srgbClr val="FFFFFF"/>
+                    </a:solidFill>
+                  </a:tcPr>
+                </a:tc>
+              </a:tr>
+              <a:tr h="329184">
+                <a:tc>
+                  <a:txBody>
+                    <a:bodyPr wrap="square"/>
+                    <a:lstStyle/>
+                    <a:p>
+                      <a:pPr algn="l"/>
+                      <a:r>
+                        <a:rPr sz="1050" b="1" i="0">
+                          <a:solidFill>
+                            <a:srgbClr val="111827"/>
+                          </a:solidFill>
+                          <a:latin typeface="Georgia"/>
+                        </a:rPr>
+                        <a:t>Motherson Wiring (MSUMI)</a:t>
+                      </a:r>
+                    </a:p>
+                  </a:txBody>
+                  <a:tcPr marL="73152" marR="54864" marT="18288" marB="18288" anchor="ctr">
+                    <a:solidFill>
+                      <a:srgbClr val="F3F4F6"/>
+                    </a:solidFill>
+                  </a:tcPr>
+                </a:tc>
+                <a:tc>
+                  <a:txBody>
+                    <a:bodyPr wrap="square"/>
+                    <a:lstStyle/>
+                    <a:p>
+                      <a:pPr algn="ctr"/>
+                      <a:r>
+                        <a:rPr sz="1050" b="0" i="0">
+                          <a:solidFill>
+                            <a:srgbClr val="111827"/>
+                          </a:solidFill>
+                          <a:latin typeface="Georgia"/>
+                        </a:rPr>
+                        <a:t>68.8</a:t>
+                      </a:r>
+                    </a:p>
+                  </a:txBody>
+                  <a:tcPr marL="73152" marR="54864" marT="18288" marB="18288" anchor="ctr">
+                    <a:solidFill>
+                      <a:srgbClr val="F3F4F6"/>
+                    </a:solidFill>
+                  </a:tcPr>
+                </a:tc>
+                <a:tc>
+                  <a:txBody>
+                    <a:bodyPr wrap="square"/>
+                    <a:lstStyle/>
+                    <a:p>
+                      <a:pPr algn="ctr"/>
+                      <a:r>
+                        <a:rPr sz="1050" b="0" i="0">
+                          <a:solidFill>
+                            <a:srgbClr val="15803D"/>
+                          </a:solidFill>
+                          <a:latin typeface="Georgia"/>
+                        </a:rPr>
+                        <a:t>Hold</a:t>
+                      </a:r>
+                    </a:p>
+                  </a:txBody>
+                  <a:tcPr marL="73152" marR="54864" marT="18288" marB="18288" anchor="ctr">
+                    <a:solidFill>
+                      <a:srgbClr val="F3F4F6"/>
+                    </a:solidFill>
+                  </a:tcPr>
+                </a:tc>
+                <a:tc>
+                  <a:txBody>
+                    <a:bodyPr wrap="square"/>
+                    <a:lstStyle/>
+                    <a:p>
+                      <a:pPr algn="l"/>
+                      <a:r>
+                        <a:rPr sz="1050" b="0" i="0">
+                          <a:solidFill>
+                            <a:srgbClr val="111827"/>
+                          </a:solidFill>
+                          <a:latin typeface="Georgia"/>
+                        </a:rPr>
+                        <a:t>Dominant wiring-harness supplier riding EV and SUV content growth.</a:t>
+                      </a:r>
+                    </a:p>
+                  </a:txBody>
+                  <a:tcPr marL="73152" marR="54864" marT="18288" marB="18288" anchor="ctr">
+                    <a:solidFill>
+                      <a:srgbClr val="F3F4F6"/>
+                    </a:solidFill>
+                  </a:tcPr>
+                </a:tc>
+              </a:tr>
+              <a:tr h="329184">
+                <a:tc>
+                  <a:txBody>
+                    <a:bodyPr wrap="square"/>
+                    <a:lstStyle/>
+                    <a:p>
+                      <a:pPr algn="l"/>
+                      <a:r>
+                        <a:rPr sz="1050" b="1" i="0">
+                          <a:solidFill>
+                            <a:srgbClr val="111827"/>
+                          </a:solidFill>
+                          <a:latin typeface="Georgia"/>
+                        </a:rPr>
+                        <a:t>Bandhan Bank (BANDHANBNK)</a:t>
+                      </a:r>
+                    </a:p>
+                  </a:txBody>
+                  <a:tcPr marL="73152" marR="54864" marT="18288" marB="18288" anchor="ctr">
+                    <a:solidFill>
+                      <a:srgbClr val="FFFFFF"/>
+                    </a:solidFill>
+                  </a:tcPr>
+                </a:tc>
+                <a:tc>
+                  <a:txBody>
+                    <a:bodyPr wrap="square"/>
+                    <a:lstStyle/>
+                    <a:p>
+                      <a:pPr algn="ctr"/>
+                      <a:r>
+                        <a:rPr sz="1050" b="0" i="0">
+                          <a:solidFill>
+                            <a:srgbClr val="111827"/>
+                          </a:solidFill>
+                          <a:latin typeface="Georgia"/>
+                        </a:rPr>
+                        <a:t>68.0</a:t>
+                      </a:r>
+                    </a:p>
+                  </a:txBody>
+                  <a:tcPr marL="73152" marR="54864" marT="18288" marB="18288" anchor="ctr">
+                    <a:solidFill>
+                      <a:srgbClr val="FFFFFF"/>
+                    </a:solidFill>
+                  </a:tcPr>
+                </a:tc>
+                <a:tc>
+                  <a:txBody>
+                    <a:bodyPr wrap="square"/>
+                    <a:lstStyle/>
+                    <a:p>
+                      <a:pPr algn="ctr"/>
+                      <a:r>
+                        <a:rPr sz="1050" b="0" i="0">
+                          <a:solidFill>
+                            <a:srgbClr val="15803D"/>
+                          </a:solidFill>
+                          <a:latin typeface="Georgia"/>
+                        </a:rPr>
+                        <a:t>Hold</a:t>
+                      </a:r>
+                    </a:p>
+                  </a:txBody>
+                  <a:tcPr marL="73152" marR="54864" marT="18288" marB="18288" anchor="ctr">
+                    <a:solidFill>
+                      <a:srgbClr val="FFFFFF"/>
+                    </a:solidFill>
+                  </a:tcPr>
+                </a:tc>
+                <a:tc>
+                  <a:txBody>
+                    <a:bodyPr wrap="square"/>
+                    <a:lstStyle/>
+                    <a:p>
+                      <a:pPr algn="l"/>
+                      <a:r>
+                        <a:rPr sz="1050" b="0" i="0">
+                          <a:solidFill>
+                            <a:srgbClr val="111827"/>
+                          </a:solidFill>
+                          <a:latin typeface="Georgia"/>
+                        </a:rPr>
+                        <a:t>Microfinance stress turning; a real pivot toward secured lending.</a:t>
+                      </a:r>
+                    </a:p>
+                  </a:txBody>
+                  <a:tcPr marL="73152" marR="54864" marT="18288" marB="18288" anchor="ctr">
+                    <a:solidFill>
+                      <a:srgbClr val="FFFFFF"/>
+                    </a:solidFill>
+                  </a:tcPr>
+                </a:tc>
+              </a:tr>
+            </a:tbl>
+          </a:graphicData>
+        </a:graphic>
+      </p:graphicFrame>
+      <p:sp>
+        <p:nvSpPr>
+          <p:cNvPr id="13" name="Oval 12"/>
           <p:cNvSpPr/>
           <p:nvPr/>
         </p:nvSpPr>
         <p:spPr>
           <a:xfrm>
-            <a:off x="548640" y="2121408"/>
-            <a:ext cx="146304" cy="603504"/>
-          </a:xfrm>
-          <a:prstGeom prst="roundRect">
-            <a:avLst>
-              <a:gd name="adj" fmla="val 30000"/>
-            </a:avLst>
+            <a:off x="548640" y="3931920"/>
+            <a:ext cx="146304" cy="146304"/>
+          </a:xfrm>
+          <a:prstGeom prst="ellipse">
+            <a:avLst/>
           </a:prstGeom>
           <a:solidFill>
-            <a:srgbClr val="2563EB"/>
+            <a:srgbClr val="B91C1C"/>
           </a:solidFill>
           <a:ln>
             <a:noFill/>
@@ -12383,542 +12935,8 @@
         </p:nvSpPr>
         <p:spPr>
           <a:xfrm>
-            <a:off x="868680" y="2103120"/>
-            <a:ext cx="2834640" cy="640080"/>
-          </a:xfrm>
-          <a:prstGeom prst="rect">
-            <a:avLst/>
-          </a:prstGeom>
-          <a:noFill/>
-        </p:spPr>
-        <p:txBody>
-          <a:bodyPr wrap="square" anchor="ctr">
-            <a:spAutoFit/>
-          </a:bodyPr>
-          <a:lstStyle/>
-          <a:p>
-            <a:pPr algn="l"/>
-            <a:r>
-              <a:rPr sz="1350" b="1" i="0">
-                <a:solidFill>
-                  <a:srgbClr val="1E3A8A"/>
-                </a:solidFill>
-                <a:latin typeface="Bahnschrift"/>
-              </a:rPr>
-              <a:t>Zero-tell style gate</a:t>
-            </a:r>
-          </a:p>
-        </p:txBody>
-      </p:sp>
-      <p:sp>
-        <p:nvSpPr>
-          <p:cNvPr id="15" name="TextBox 14"/>
-          <p:cNvSpPr txBox="1"/>
-          <p:nvPr/>
-        </p:nvSpPr>
-        <p:spPr>
-          <a:xfrm>
-            <a:off x="3794760" y="2103120"/>
-            <a:ext cx="7863840" cy="640080"/>
-          </a:xfrm>
-          <a:prstGeom prst="rect">
-            <a:avLst/>
-          </a:prstGeom>
-          <a:noFill/>
-        </p:spPr>
-        <p:txBody>
-          <a:bodyPr wrap="square" anchor="ctr">
-            <a:spAutoFit/>
-          </a:bodyPr>
-          <a:lstStyle/>
-          <a:p>
-            <a:pPr algn="l"/>
-            <a:r>
-              <a:rPr sz="1250" b="0" i="0">
-                <a:solidFill>
-                  <a:srgbClr val="111827"/>
-                </a:solidFill>
-                <a:latin typeface="Georgia"/>
-              </a:rPr>
-              <a:t>The builder refuses to ship a sheet containing AI writing tells or banned words.</a:t>
-            </a:r>
-          </a:p>
-        </p:txBody>
-      </p:sp>
-      <p:sp>
-        <p:nvSpPr>
-          <p:cNvPr id="16" name="Rounded Rectangle 15"/>
-          <p:cNvSpPr/>
-          <p:nvPr/>
-        </p:nvSpPr>
-        <p:spPr>
-          <a:xfrm>
-            <a:off x="548640" y="2779776"/>
-            <a:ext cx="146304" cy="603504"/>
-          </a:xfrm>
-          <a:prstGeom prst="roundRect">
-            <a:avLst>
-              <a:gd name="adj" fmla="val 30000"/>
-            </a:avLst>
-          </a:prstGeom>
-          <a:solidFill>
-            <a:srgbClr val="2563EB"/>
-          </a:solidFill>
-          <a:ln>
-            <a:noFill/>
-          </a:ln>
-          <a:effectLst/>
-        </p:spPr>
-        <p:style>
-          <a:lnRef idx="1">
-            <a:schemeClr val="accent1"/>
-          </a:lnRef>
-          <a:fillRef idx="3">
-            <a:schemeClr val="accent1"/>
-          </a:fillRef>
-          <a:effectRef idx="2">
-            <a:schemeClr val="accent1"/>
-          </a:effectRef>
-          <a:fontRef idx="minor">
-            <a:schemeClr val="lt1"/>
-          </a:fontRef>
-        </p:style>
-        <p:txBody>
-          <a:bodyPr rtlCol="0" anchor="ctr"/>
-          <a:lstStyle/>
-          <a:p>
-            <a:pPr algn="ctr"/>
-          </a:p>
-        </p:txBody>
-      </p:sp>
-      <p:sp>
-        <p:nvSpPr>
-          <p:cNvPr id="17" name="TextBox 16"/>
-          <p:cNvSpPr txBox="1"/>
-          <p:nvPr/>
-        </p:nvSpPr>
-        <p:spPr>
-          <a:xfrm>
-            <a:off x="868680" y="2761488"/>
-            <a:ext cx="2834640" cy="640080"/>
-          </a:xfrm>
-          <a:prstGeom prst="rect">
-            <a:avLst/>
-          </a:prstGeom>
-          <a:noFill/>
-        </p:spPr>
-        <p:txBody>
-          <a:bodyPr wrap="square" anchor="ctr">
-            <a:spAutoFit/>
-          </a:bodyPr>
-          <a:lstStyle/>
-          <a:p>
-            <a:pPr algn="l"/>
-            <a:r>
-              <a:rPr sz="1350" b="1" i="0">
-                <a:solidFill>
-                  <a:srgbClr val="1E3A8A"/>
-                </a:solidFill>
-                <a:latin typeface="Bahnschrift"/>
-              </a:rPr>
-              <a:t>Independent QA sweep</a:t>
-            </a:r>
-          </a:p>
-        </p:txBody>
-      </p:sp>
-      <p:sp>
-        <p:nvSpPr>
-          <p:cNvPr id="18" name="TextBox 17"/>
-          <p:cNvSpPr txBox="1"/>
-          <p:nvPr/>
-        </p:nvSpPr>
-        <p:spPr>
-          <a:xfrm>
-            <a:off x="3794760" y="2761488"/>
-            <a:ext cx="7863840" cy="640080"/>
-          </a:xfrm>
-          <a:prstGeom prst="rect">
-            <a:avLst/>
-          </a:prstGeom>
-          <a:noFill/>
-        </p:spPr>
-        <p:txBody>
-          <a:bodyPr wrap="square" anchor="ctr">
-            <a:spAutoFit/>
-          </a:bodyPr>
-          <a:lstStyle/>
-          <a:p>
-            <a:pPr algn="l"/>
-            <a:r>
-              <a:rPr sz="1250" b="0" i="0">
-                <a:solidFill>
-                  <a:srgbClr val="111827"/>
-                </a:solidFill>
-                <a:latin typeface="Georgia"/>
-              </a:rPr>
-              <a:t>A second agent audits each file: does the call match the reasoning, is the growth number calibrated, any Buy language, any pending-vs-done error.</a:t>
-            </a:r>
-          </a:p>
-        </p:txBody>
-      </p:sp>
-      <p:sp>
-        <p:nvSpPr>
-          <p:cNvPr id="19" name="Rounded Rectangle 18"/>
-          <p:cNvSpPr/>
-          <p:nvPr/>
-        </p:nvSpPr>
-        <p:spPr>
-          <a:xfrm>
-            <a:off x="548640" y="3438144"/>
-            <a:ext cx="146304" cy="603504"/>
-          </a:xfrm>
-          <a:prstGeom prst="roundRect">
-            <a:avLst>
-              <a:gd name="adj" fmla="val 30000"/>
-            </a:avLst>
-          </a:prstGeom>
-          <a:solidFill>
-            <a:srgbClr val="2563EB"/>
-          </a:solidFill>
-          <a:ln>
-            <a:noFill/>
-          </a:ln>
-          <a:effectLst/>
-        </p:spPr>
-        <p:style>
-          <a:lnRef idx="1">
-            <a:schemeClr val="accent1"/>
-          </a:lnRef>
-          <a:fillRef idx="3">
-            <a:schemeClr val="accent1"/>
-          </a:fillRef>
-          <a:effectRef idx="2">
-            <a:schemeClr val="accent1"/>
-          </a:effectRef>
-          <a:fontRef idx="minor">
-            <a:schemeClr val="lt1"/>
-          </a:fontRef>
-        </p:style>
-        <p:txBody>
-          <a:bodyPr rtlCol="0" anchor="ctr"/>
-          <a:lstStyle/>
-          <a:p>
-            <a:pPr algn="ctr"/>
-          </a:p>
-        </p:txBody>
-      </p:sp>
-      <p:sp>
-        <p:nvSpPr>
-          <p:cNvPr id="20" name="TextBox 19"/>
-          <p:cNvSpPr txBox="1"/>
-          <p:nvPr/>
-        </p:nvSpPr>
-        <p:spPr>
-          <a:xfrm>
-            <a:off x="868680" y="3419856"/>
-            <a:ext cx="2834640" cy="640080"/>
-          </a:xfrm>
-          <a:prstGeom prst="rect">
-            <a:avLst/>
-          </a:prstGeom>
-          <a:noFill/>
-        </p:spPr>
-        <p:txBody>
-          <a:bodyPr wrap="square" anchor="ctr">
-            <a:spAutoFit/>
-          </a:bodyPr>
-          <a:lstStyle/>
-          <a:p>
-            <a:pPr algn="l"/>
-            <a:r>
-              <a:rPr sz="1350" b="1" i="0">
-                <a:solidFill>
-                  <a:srgbClr val="1E3A8A"/>
-                </a:solidFill>
-                <a:latin typeface="Bahnschrift"/>
-              </a:rPr>
-              <a:t>Fact-check on claims</a:t>
-            </a:r>
-          </a:p>
-        </p:txBody>
-      </p:sp>
-      <p:sp>
-        <p:nvSpPr>
-          <p:cNvPr id="21" name="TextBox 20"/>
-          <p:cNvSpPr txBox="1"/>
-          <p:nvPr/>
-        </p:nvSpPr>
-        <p:spPr>
-          <a:xfrm>
-            <a:off x="3794760" y="3419856"/>
-            <a:ext cx="7863840" cy="640080"/>
-          </a:xfrm>
-          <a:prstGeom prst="rect">
-            <a:avLst/>
-          </a:prstGeom>
-          <a:noFill/>
-        </p:spPr>
-        <p:txBody>
-          <a:bodyPr wrap="square" anchor="ctr">
-            <a:spAutoFit/>
-          </a:bodyPr>
-          <a:lstStyle/>
-          <a:p>
-            <a:pPr algn="l"/>
-            <a:r>
-              <a:rPr sz="1250" b="0" i="0">
-                <a:solidFill>
-                  <a:srgbClr val="111827"/>
-                </a:solidFill>
-                <a:latin typeface="Georgia"/>
-              </a:rPr>
-              <a:t>Completed-versus-pending legal and deal claims are verified against primary sources.</a:t>
-            </a:r>
-          </a:p>
-        </p:txBody>
-      </p:sp>
-      <p:sp>
-        <p:nvSpPr>
-          <p:cNvPr id="22" name="Rounded Rectangle 21"/>
-          <p:cNvSpPr/>
-          <p:nvPr/>
-        </p:nvSpPr>
-        <p:spPr>
-          <a:xfrm>
-            <a:off x="548640" y="4096511"/>
-            <a:ext cx="146304" cy="603504"/>
-          </a:xfrm>
-          <a:prstGeom prst="roundRect">
-            <a:avLst>
-              <a:gd name="adj" fmla="val 30000"/>
-            </a:avLst>
-          </a:prstGeom>
-          <a:solidFill>
-            <a:srgbClr val="2563EB"/>
-          </a:solidFill>
-          <a:ln>
-            <a:noFill/>
-          </a:ln>
-          <a:effectLst/>
-        </p:spPr>
-        <p:style>
-          <a:lnRef idx="1">
-            <a:schemeClr val="accent1"/>
-          </a:lnRef>
-          <a:fillRef idx="3">
-            <a:schemeClr val="accent1"/>
-          </a:fillRef>
-          <a:effectRef idx="2">
-            <a:schemeClr val="accent1"/>
-          </a:effectRef>
-          <a:fontRef idx="minor">
-            <a:schemeClr val="lt1"/>
-          </a:fontRef>
-        </p:style>
-        <p:txBody>
-          <a:bodyPr rtlCol="0" anchor="ctr"/>
-          <a:lstStyle/>
-          <a:p>
-            <a:pPr algn="ctr"/>
-          </a:p>
-        </p:txBody>
-      </p:sp>
-      <p:sp>
-        <p:nvSpPr>
-          <p:cNvPr id="23" name="TextBox 22"/>
-          <p:cNvSpPr txBox="1"/>
-          <p:nvPr/>
-        </p:nvSpPr>
-        <p:spPr>
-          <a:xfrm>
-            <a:off x="868680" y="4078224"/>
-            <a:ext cx="2834640" cy="640080"/>
-          </a:xfrm>
-          <a:prstGeom prst="rect">
-            <a:avLst/>
-          </a:prstGeom>
-          <a:noFill/>
-        </p:spPr>
-        <p:txBody>
-          <a:bodyPr wrap="square" anchor="ctr">
-            <a:spAutoFit/>
-          </a:bodyPr>
-          <a:lstStyle/>
-          <a:p>
-            <a:pPr algn="l"/>
-            <a:r>
-              <a:rPr sz="1350" b="1" i="0">
-                <a:solidFill>
-                  <a:srgbClr val="1E3A8A"/>
-                </a:solidFill>
-                <a:latin typeface="Bahnschrift"/>
-              </a:rPr>
-              <a:t>Growth re-adjudication</a:t>
-            </a:r>
-          </a:p>
-        </p:txBody>
-      </p:sp>
-      <p:sp>
-        <p:nvSpPr>
-          <p:cNvPr id="24" name="TextBox 23"/>
-          <p:cNvSpPr txBox="1"/>
-          <p:nvPr/>
-        </p:nvSpPr>
-        <p:spPr>
-          <a:xfrm>
-            <a:off x="3794760" y="4078224"/>
-            <a:ext cx="7863840" cy="640080"/>
-          </a:xfrm>
-          <a:prstGeom prst="rect">
-            <a:avLst/>
-          </a:prstGeom>
-          <a:noFill/>
-        </p:spPr>
-        <p:txBody>
-          <a:bodyPr wrap="square" anchor="ctr">
-            <a:spAutoFit/>
-          </a:bodyPr>
-          <a:lstStyle/>
-          <a:p>
-            <a:pPr algn="l"/>
-            <a:r>
-              <a:rPr sz="1250" b="0" i="0">
-                <a:solidFill>
-                  <a:srgbClr val="111827"/>
-                </a:solidFill>
-                <a:latin typeface="Georgia"/>
-              </a:rPr>
-              <a:t>A flagged growth number goes back to the same analyst desk to defend or revise.</a:t>
-            </a:r>
-          </a:p>
-        </p:txBody>
-      </p:sp>
-      <p:sp>
-        <p:nvSpPr>
-          <p:cNvPr id="25" name="Rounded Rectangle 24"/>
-          <p:cNvSpPr/>
-          <p:nvPr/>
-        </p:nvSpPr>
-        <p:spPr>
-          <a:xfrm>
-            <a:off x="548640" y="4754879"/>
-            <a:ext cx="146304" cy="603504"/>
-          </a:xfrm>
-          <a:prstGeom prst="roundRect">
-            <a:avLst>
-              <a:gd name="adj" fmla="val 30000"/>
-            </a:avLst>
-          </a:prstGeom>
-          <a:solidFill>
-            <a:srgbClr val="2563EB"/>
-          </a:solidFill>
-          <a:ln>
-            <a:noFill/>
-          </a:ln>
-          <a:effectLst/>
-        </p:spPr>
-        <p:style>
-          <a:lnRef idx="1">
-            <a:schemeClr val="accent1"/>
-          </a:lnRef>
-          <a:fillRef idx="3">
-            <a:schemeClr val="accent1"/>
-          </a:fillRef>
-          <a:effectRef idx="2">
-            <a:schemeClr val="accent1"/>
-          </a:effectRef>
-          <a:fontRef idx="minor">
-            <a:schemeClr val="lt1"/>
-          </a:fontRef>
-        </p:style>
-        <p:txBody>
-          <a:bodyPr rtlCol="0" anchor="ctr"/>
-          <a:lstStyle/>
-          <a:p>
-            <a:pPr algn="ctr"/>
-          </a:p>
-        </p:txBody>
-      </p:sp>
-      <p:sp>
-        <p:nvSpPr>
-          <p:cNvPr id="26" name="TextBox 25"/>
-          <p:cNvSpPr txBox="1"/>
-          <p:nvPr/>
-        </p:nvSpPr>
-        <p:spPr>
-          <a:xfrm>
-            <a:off x="868680" y="4736592"/>
-            <a:ext cx="2834640" cy="640080"/>
-          </a:xfrm>
-          <a:prstGeom prst="rect">
-            <a:avLst/>
-          </a:prstGeom>
-          <a:noFill/>
-        </p:spPr>
-        <p:txBody>
-          <a:bodyPr wrap="square" anchor="ctr">
-            <a:spAutoFit/>
-          </a:bodyPr>
-          <a:lstStyle/>
-          <a:p>
-            <a:pPr algn="l"/>
-            <a:r>
-              <a:rPr sz="1350" b="1" i="0">
-                <a:solidFill>
-                  <a:srgbClr val="1E3A8A"/>
-                </a:solidFill>
-                <a:latin typeface="Bahnschrift"/>
-              </a:rPr>
-              <a:t>Human sign-off</a:t>
-            </a:r>
-          </a:p>
-        </p:txBody>
-      </p:sp>
-      <p:sp>
-        <p:nvSpPr>
-          <p:cNvPr id="27" name="TextBox 26"/>
-          <p:cNvSpPr txBox="1"/>
-          <p:nvPr/>
-        </p:nvSpPr>
-        <p:spPr>
-          <a:xfrm>
-            <a:off x="3794760" y="4736592"/>
-            <a:ext cx="7863840" cy="640080"/>
-          </a:xfrm>
-          <a:prstGeom prst="rect">
-            <a:avLst/>
-          </a:prstGeom>
-          <a:noFill/>
-        </p:spPr>
-        <p:txBody>
-          <a:bodyPr wrap="square" anchor="ctr">
-            <a:spAutoFit/>
-          </a:bodyPr>
-          <a:lstStyle/>
-          <a:p>
-            <a:pPr algn="l"/>
-            <a:r>
-              <a:rPr sz="1250" b="0" i="0">
-                <a:solidFill>
-                  <a:srgbClr val="111827"/>
-                </a:solidFill>
-                <a:latin typeface="Georgia"/>
-              </a:rPr>
-              <a:t>Nothing reaches a client without the Principal's approval.</a:t>
-            </a:r>
-          </a:p>
-        </p:txBody>
-      </p:sp>
-      <p:sp>
-        <p:nvSpPr>
-          <p:cNvPr id="28" name="TextBox 27"/>
-          <p:cNvSpPr txBox="1"/>
-          <p:nvPr/>
-        </p:nvSpPr>
-        <p:spPr>
-          <a:xfrm>
-            <a:off x="868680" y="5431535"/>
-            <a:ext cx="10789920" cy="457200"/>
+            <a:off x="777240" y="3831336"/>
+            <a:ext cx="7315200" cy="274320"/>
           </a:xfrm>
           <a:prstGeom prst="rect">
             <a:avLst/>
@@ -12933,13 +12951,638 @@
           <a:p>
             <a:pPr algn="l"/>
             <a:r>
-              <a:rPr sz="1200" b="0" i="1">
+              <a:rPr sz="1300" b="1" i="0">
+                <a:solidFill>
+                  <a:srgbClr val="B91C1C"/>
+                </a:solidFill>
+                <a:latin typeface="Bahnschrift"/>
+              </a:rPr>
+              <a:t>Bottom 5 by Ionic Score</a:t>
+            </a:r>
+          </a:p>
+        </p:txBody>
+      </p:sp>
+      <p:graphicFrame>
+        <p:nvGraphicFramePr>
+          <p:cNvPr id="15" name="Table 14"/>
+          <p:cNvGraphicFramePr>
+            <a:graphicFrameLocks noGrp="1"/>
+          </p:cNvGraphicFramePr>
+          <p:nvPr/>
+        </p:nvGraphicFramePr>
+        <p:xfrm>
+          <a:off x="548640" y="4178808"/>
+          <a:ext cx="11091670" cy="1975104"/>
+        </p:xfrm>
+        <a:graphic>
+          <a:graphicData uri="http://schemas.openxmlformats.org/drawingml/2006/table">
+            <a:tbl>
+              <a:tblPr firstRow="0" bandRow="0"/>
+              <a:tblGrid>
+                <a:gridCol w="2716327"/>
+                <a:gridCol w="769626"/>
+                <a:gridCol w="769626"/>
+                <a:gridCol w="6836091"/>
+              </a:tblGrid>
+              <a:tr h="329184">
+                <a:tc>
+                  <a:txBody>
+                    <a:bodyPr wrap="square"/>
+                    <a:lstStyle/>
+                    <a:p>
+                      <a:pPr algn="l"/>
+                      <a:r>
+                        <a:rPr sz="1050" b="1" i="0">
+                          <a:solidFill>
+                            <a:srgbClr val="FFFFFF"/>
+                          </a:solidFill>
+                          <a:latin typeface="Bahnschrift"/>
+                        </a:rPr>
+                        <a:t>Holding</a:t>
+                      </a:r>
+                    </a:p>
+                  </a:txBody>
+                  <a:tcPr marL="73152" marR="54864" marT="18288" marB="18288" anchor="ctr">
+                    <a:solidFill>
+                      <a:srgbClr val="1E3A8A"/>
+                    </a:solidFill>
+                  </a:tcPr>
+                </a:tc>
+                <a:tc>
+                  <a:txBody>
+                    <a:bodyPr wrap="square"/>
+                    <a:lstStyle/>
+                    <a:p>
+                      <a:pPr algn="ctr"/>
+                      <a:r>
+                        <a:rPr sz="1050" b="1" i="0">
+                          <a:solidFill>
+                            <a:srgbClr val="FFFFFF"/>
+                          </a:solidFill>
+                          <a:latin typeface="Bahnschrift"/>
+                        </a:rPr>
+                        <a:t>Score</a:t>
+                      </a:r>
+                    </a:p>
+                  </a:txBody>
+                  <a:tcPr marL="73152" marR="54864" marT="18288" marB="18288" anchor="ctr">
+                    <a:solidFill>
+                      <a:srgbClr val="1E3A8A"/>
+                    </a:solidFill>
+                  </a:tcPr>
+                </a:tc>
+                <a:tc>
+                  <a:txBody>
+                    <a:bodyPr wrap="square"/>
+                    <a:lstStyle/>
+                    <a:p>
+                      <a:pPr algn="ctr"/>
+                      <a:r>
+                        <a:rPr sz="1050" b="1" i="0">
+                          <a:solidFill>
+                            <a:srgbClr val="FFFFFF"/>
+                          </a:solidFill>
+                          <a:latin typeface="Bahnschrift"/>
+                        </a:rPr>
+                        <a:t>Call</a:t>
+                      </a:r>
+                    </a:p>
+                  </a:txBody>
+                  <a:tcPr marL="73152" marR="54864" marT="18288" marB="18288" anchor="ctr">
+                    <a:solidFill>
+                      <a:srgbClr val="1E3A8A"/>
+                    </a:solidFill>
+                  </a:tcPr>
+                </a:tc>
+                <a:tc>
+                  <a:txBody>
+                    <a:bodyPr wrap="square"/>
+                    <a:lstStyle/>
+                    <a:p>
+                      <a:pPr algn="l"/>
+                      <a:r>
+                        <a:rPr sz="1050" b="1" i="0">
+                          <a:solidFill>
+                            <a:srgbClr val="FFFFFF"/>
+                          </a:solidFill>
+                          <a:latin typeface="Bahnschrift"/>
+                        </a:rPr>
+                        <a:t>What the analyst is seeing</a:t>
+                      </a:r>
+                    </a:p>
+                  </a:txBody>
+                  <a:tcPr marL="73152" marR="54864" marT="18288" marB="18288" anchor="ctr">
+                    <a:solidFill>
+                      <a:srgbClr val="1E3A8A"/>
+                    </a:solidFill>
+                  </a:tcPr>
+                </a:tc>
+              </a:tr>
+              <a:tr h="329184">
+                <a:tc>
+                  <a:txBody>
+                    <a:bodyPr wrap="square"/>
+                    <a:lstStyle/>
+                    <a:p>
+                      <a:pPr algn="l"/>
+                      <a:r>
+                        <a:rPr sz="1050" b="1" i="0">
+                          <a:solidFill>
+                            <a:srgbClr val="111827"/>
+                          </a:solidFill>
+                          <a:latin typeface="Georgia"/>
+                        </a:rPr>
+                        <a:t>Tata Power (TATAPOWER)</a:t>
+                      </a:r>
+                    </a:p>
+                  </a:txBody>
+                  <a:tcPr marL="73152" marR="54864" marT="18288" marB="18288" anchor="ctr">
+                    <a:solidFill>
+                      <a:srgbClr val="FFFFFF"/>
+                    </a:solidFill>
+                  </a:tcPr>
+                </a:tc>
+                <a:tc>
+                  <a:txBody>
+                    <a:bodyPr wrap="square"/>
+                    <a:lstStyle/>
+                    <a:p>
+                      <a:pPr algn="ctr"/>
+                      <a:r>
+                        <a:rPr sz="1050" b="0" i="0">
+                          <a:solidFill>
+                            <a:srgbClr val="111827"/>
+                          </a:solidFill>
+                          <a:latin typeface="Georgia"/>
+                        </a:rPr>
+                        <a:t>25.5</a:t>
+                      </a:r>
+                    </a:p>
+                  </a:txBody>
+                  <a:tcPr marL="73152" marR="54864" marT="18288" marB="18288" anchor="ctr">
+                    <a:solidFill>
+                      <a:srgbClr val="FFFFFF"/>
+                    </a:solidFill>
+                  </a:tcPr>
+                </a:tc>
+                <a:tc>
+                  <a:txBody>
+                    <a:bodyPr wrap="square"/>
+                    <a:lstStyle/>
+                    <a:p>
+                      <a:pPr algn="ctr"/>
+                      <a:r>
+                        <a:rPr sz="1050" b="0" i="0">
+                          <a:solidFill>
+                            <a:srgbClr val="B91C1C"/>
+                          </a:solidFill>
+                          <a:latin typeface="Georgia"/>
+                        </a:rPr>
+                        <a:t>Sell</a:t>
+                      </a:r>
+                    </a:p>
+                  </a:txBody>
+                  <a:tcPr marL="73152" marR="54864" marT="18288" marB="18288" anchor="ctr">
+                    <a:solidFill>
+                      <a:srgbClr val="FFFFFF"/>
+                    </a:solidFill>
+                  </a:tcPr>
+                </a:tc>
+                <a:tc>
+                  <a:txBody>
+                    <a:bodyPr wrap="square"/>
+                    <a:lstStyle/>
+                    <a:p>
+                      <a:pPr algn="l"/>
+                      <a:r>
+                        <a:rPr sz="1050" b="0" i="0">
+                          <a:solidFill>
+                            <a:srgbClr val="111827"/>
+                          </a:solidFill>
+                          <a:latin typeface="Georgia"/>
+                        </a:rPr>
+                        <a:t>Full price against modest returns; the FY26 revenue dip was a one-off.</a:t>
+                      </a:r>
+                    </a:p>
+                  </a:txBody>
+                  <a:tcPr marL="73152" marR="54864" marT="18288" marB="18288" anchor="ctr">
+                    <a:solidFill>
+                      <a:srgbClr val="FFFFFF"/>
+                    </a:solidFill>
+                  </a:tcPr>
+                </a:tc>
+              </a:tr>
+              <a:tr h="329184">
+                <a:tc>
+                  <a:txBody>
+                    <a:bodyPr wrap="square"/>
+                    <a:lstStyle/>
+                    <a:p>
+                      <a:pPr algn="l"/>
+                      <a:r>
+                        <a:rPr sz="1050" b="1" i="0">
+                          <a:solidFill>
+                            <a:srgbClr val="111827"/>
+                          </a:solidFill>
+                          <a:latin typeface="Georgia"/>
+                        </a:rPr>
+                        <a:t>Deepak Nitrite (DEEPAKNTR)</a:t>
+                      </a:r>
+                    </a:p>
+                  </a:txBody>
+                  <a:tcPr marL="73152" marR="54864" marT="18288" marB="18288" anchor="ctr">
+                    <a:solidFill>
+                      <a:srgbClr val="F3F4F6"/>
+                    </a:solidFill>
+                  </a:tcPr>
+                </a:tc>
+                <a:tc>
+                  <a:txBody>
+                    <a:bodyPr wrap="square"/>
+                    <a:lstStyle/>
+                    <a:p>
+                      <a:pPr algn="ctr"/>
+                      <a:r>
+                        <a:rPr sz="1050" b="0" i="0">
+                          <a:solidFill>
+                            <a:srgbClr val="111827"/>
+                          </a:solidFill>
+                          <a:latin typeface="Georgia"/>
+                        </a:rPr>
+                        <a:t>28.1</a:t>
+                      </a:r>
+                    </a:p>
+                  </a:txBody>
+                  <a:tcPr marL="73152" marR="54864" marT="18288" marB="18288" anchor="ctr">
+                    <a:solidFill>
+                      <a:srgbClr val="F3F4F6"/>
+                    </a:solidFill>
+                  </a:tcPr>
+                </a:tc>
+                <a:tc>
+                  <a:txBody>
+                    <a:bodyPr wrap="square"/>
+                    <a:lstStyle/>
+                    <a:p>
+                      <a:pPr algn="ctr"/>
+                      <a:r>
+                        <a:rPr sz="1050" b="0" i="0">
+                          <a:solidFill>
+                            <a:srgbClr val="B91C1C"/>
+                          </a:solidFill>
+                          <a:latin typeface="Georgia"/>
+                        </a:rPr>
+                        <a:t>Sell</a:t>
+                      </a:r>
+                    </a:p>
+                  </a:txBody>
+                  <a:tcPr marL="73152" marR="54864" marT="18288" marB="18288" anchor="ctr">
+                    <a:solidFill>
+                      <a:srgbClr val="F3F4F6"/>
+                    </a:solidFill>
+                  </a:tcPr>
+                </a:tc>
+                <a:tc>
+                  <a:txBody>
+                    <a:bodyPr wrap="square"/>
+                    <a:lstStyle/>
+                    <a:p>
+                      <a:pPr algn="l"/>
+                      <a:r>
+                        <a:rPr sz="1050" b="0" i="0">
+                          <a:solidFill>
+                            <a:srgbClr val="111827"/>
+                          </a:solidFill>
+                          <a:latin typeface="Georgia"/>
+                        </a:rPr>
+                        <a:t>Commodity chemicals downcycle; peak margins and returns roughly halved.</a:t>
+                      </a:r>
+                    </a:p>
+                  </a:txBody>
+                  <a:tcPr marL="73152" marR="54864" marT="18288" marB="18288" anchor="ctr">
+                    <a:solidFill>
+                      <a:srgbClr val="F3F4F6"/>
+                    </a:solidFill>
+                  </a:tcPr>
+                </a:tc>
+              </a:tr>
+              <a:tr h="329184">
+                <a:tc>
+                  <a:txBody>
+                    <a:bodyPr wrap="square"/>
+                    <a:lstStyle/>
+                    <a:p>
+                      <a:pPr algn="l"/>
+                      <a:r>
+                        <a:rPr sz="1050" b="1" i="0">
+                          <a:solidFill>
+                            <a:srgbClr val="111827"/>
+                          </a:solidFill>
+                          <a:latin typeface="Georgia"/>
+                        </a:rPr>
+                        <a:t>Reliance (RELIANCE)</a:t>
+                      </a:r>
+                    </a:p>
+                  </a:txBody>
+                  <a:tcPr marL="73152" marR="54864" marT="18288" marB="18288" anchor="ctr">
+                    <a:solidFill>
+                      <a:srgbClr val="FFFFFF"/>
+                    </a:solidFill>
+                  </a:tcPr>
+                </a:tc>
+                <a:tc>
+                  <a:txBody>
+                    <a:bodyPr wrap="square"/>
+                    <a:lstStyle/>
+                    <a:p>
+                      <a:pPr algn="ctr"/>
+                      <a:r>
+                        <a:rPr sz="1050" b="0" i="0">
+                          <a:solidFill>
+                            <a:srgbClr val="111827"/>
+                          </a:solidFill>
+                          <a:latin typeface="Georgia"/>
+                        </a:rPr>
+                        <a:t>30.3</a:t>
+                      </a:r>
+                    </a:p>
+                  </a:txBody>
+                  <a:tcPr marL="73152" marR="54864" marT="18288" marB="18288" anchor="ctr">
+                    <a:solidFill>
+                      <a:srgbClr val="FFFFFF"/>
+                    </a:solidFill>
+                  </a:tcPr>
+                </a:tc>
+                <a:tc>
+                  <a:txBody>
+                    <a:bodyPr wrap="square"/>
+                    <a:lstStyle/>
+                    <a:p>
+                      <a:pPr algn="ctr"/>
+                      <a:r>
+                        <a:rPr sz="1050" b="0" i="0">
+                          <a:solidFill>
+                            <a:srgbClr val="15803D"/>
+                          </a:solidFill>
+                          <a:latin typeface="Georgia"/>
+                        </a:rPr>
+                        <a:t>Hold</a:t>
+                      </a:r>
+                    </a:p>
+                  </a:txBody>
+                  <a:tcPr marL="73152" marR="54864" marT="18288" marB="18288" anchor="ctr">
+                    <a:solidFill>
+                      <a:srgbClr val="FFFFFF"/>
+                    </a:solidFill>
+                  </a:tcPr>
+                </a:tc>
+                <a:tc>
+                  <a:txBody>
+                    <a:bodyPr wrap="square"/>
+                    <a:lstStyle/>
+                    <a:p>
+                      <a:pPr algn="l"/>
+                      <a:r>
+                        <a:rPr sz="1050" b="0" i="0">
+                          <a:solidFill>
+                            <a:srgbClr val="111827"/>
+                          </a:solidFill>
+                          <a:latin typeface="Georgia"/>
+                        </a:rPr>
+                        <a:t>Held on a low score; strong operating profit, reported profit hit by depreciation.</a:t>
+                      </a:r>
+                    </a:p>
+                  </a:txBody>
+                  <a:tcPr marL="73152" marR="54864" marT="18288" marB="18288" anchor="ctr">
+                    <a:solidFill>
+                      <a:srgbClr val="FFFFFF"/>
+                    </a:solidFill>
+                  </a:tcPr>
+                </a:tc>
+              </a:tr>
+              <a:tr h="329184">
+                <a:tc>
+                  <a:txBody>
+                    <a:bodyPr wrap="square"/>
+                    <a:lstStyle/>
+                    <a:p>
+                      <a:pPr algn="l"/>
+                      <a:r>
+                        <a:rPr sz="1050" b="1" i="0">
+                          <a:solidFill>
+                            <a:srgbClr val="111827"/>
+                          </a:solidFill>
+                          <a:latin typeface="Georgia"/>
+                        </a:rPr>
+                        <a:t>Cochin Shipyard (COCHINSHIP)</a:t>
+                      </a:r>
+                    </a:p>
+                  </a:txBody>
+                  <a:tcPr marL="73152" marR="54864" marT="18288" marB="18288" anchor="ctr">
+                    <a:solidFill>
+                      <a:srgbClr val="F3F4F6"/>
+                    </a:solidFill>
+                  </a:tcPr>
+                </a:tc>
+                <a:tc>
+                  <a:txBody>
+                    <a:bodyPr wrap="square"/>
+                    <a:lstStyle/>
+                    <a:p>
+                      <a:pPr algn="ctr"/>
+                      <a:r>
+                        <a:rPr sz="1050" b="0" i="0">
+                          <a:solidFill>
+                            <a:srgbClr val="111827"/>
+                          </a:solidFill>
+                          <a:latin typeface="Georgia"/>
+                        </a:rPr>
+                        <a:t>32.0</a:t>
+                      </a:r>
+                    </a:p>
+                  </a:txBody>
+                  <a:tcPr marL="73152" marR="54864" marT="18288" marB="18288" anchor="ctr">
+                    <a:solidFill>
+                      <a:srgbClr val="F3F4F6"/>
+                    </a:solidFill>
+                  </a:tcPr>
+                </a:tc>
+                <a:tc>
+                  <a:txBody>
+                    <a:bodyPr wrap="square"/>
+                    <a:lstStyle/>
+                    <a:p>
+                      <a:pPr algn="ctr"/>
+                      <a:r>
+                        <a:rPr sz="1050" b="0" i="0">
+                          <a:solidFill>
+                            <a:srgbClr val="B91C1C"/>
+                          </a:solidFill>
+                          <a:latin typeface="Georgia"/>
+                        </a:rPr>
+                        <a:t>Sell</a:t>
+                      </a:r>
+                    </a:p>
+                  </a:txBody>
+                  <a:tcPr marL="73152" marR="54864" marT="18288" marB="18288" anchor="ctr">
+                    <a:solidFill>
+                      <a:srgbClr val="F3F4F6"/>
+                    </a:solidFill>
+                  </a:tcPr>
+                </a:tc>
+                <a:tc>
+                  <a:txBody>
+                    <a:bodyPr wrap="square"/>
+                    <a:lstStyle/>
+                    <a:p>
+                      <a:pPr algn="l"/>
+                      <a:r>
+                        <a:rPr sz="1050" b="0" i="0">
+                          <a:solidFill>
+                            <a:srgbClr val="111827"/>
+                          </a:solidFill>
+                          <a:latin typeface="Georgia"/>
+                        </a:rPr>
+                        <a:t>Growth stepped down sharply off a high base; margins normalizing.</a:t>
+                      </a:r>
+                    </a:p>
+                  </a:txBody>
+                  <a:tcPr marL="73152" marR="54864" marT="18288" marB="18288" anchor="ctr">
+                    <a:solidFill>
+                      <a:srgbClr val="F3F4F6"/>
+                    </a:solidFill>
+                  </a:tcPr>
+                </a:tc>
+              </a:tr>
+              <a:tr h="329184">
+                <a:tc>
+                  <a:txBody>
+                    <a:bodyPr wrap="square"/>
+                    <a:lstStyle/>
+                    <a:p>
+                      <a:pPr algn="l"/>
+                      <a:r>
+                        <a:rPr sz="1050" b="1" i="0">
+                          <a:solidFill>
+                            <a:srgbClr val="111827"/>
+                          </a:solidFill>
+                          <a:latin typeface="Georgia"/>
+                        </a:rPr>
+                        <a:t>Asian Paints (ASIANPAINT)</a:t>
+                      </a:r>
+                    </a:p>
+                  </a:txBody>
+                  <a:tcPr marL="73152" marR="54864" marT="18288" marB="18288" anchor="ctr">
+                    <a:solidFill>
+                      <a:srgbClr val="FFFFFF"/>
+                    </a:solidFill>
+                  </a:tcPr>
+                </a:tc>
+                <a:tc>
+                  <a:txBody>
+                    <a:bodyPr wrap="square"/>
+                    <a:lstStyle/>
+                    <a:p>
+                      <a:pPr algn="ctr"/>
+                      <a:r>
+                        <a:rPr sz="1050" b="0" i="0">
+                          <a:solidFill>
+                            <a:srgbClr val="111827"/>
+                          </a:solidFill>
+                          <a:latin typeface="Georgia"/>
+                        </a:rPr>
+                        <a:t>32.5</a:t>
+                      </a:r>
+                    </a:p>
+                  </a:txBody>
+                  <a:tcPr marL="73152" marR="54864" marT="18288" marB="18288" anchor="ctr">
+                    <a:solidFill>
+                      <a:srgbClr val="FFFFFF"/>
+                    </a:solidFill>
+                  </a:tcPr>
+                </a:tc>
+                <a:tc>
+                  <a:txBody>
+                    <a:bodyPr wrap="square"/>
+                    <a:lstStyle/>
+                    <a:p>
+                      <a:pPr algn="ctr"/>
+                      <a:r>
+                        <a:rPr sz="1050" b="0" i="0">
+                          <a:solidFill>
+                            <a:srgbClr val="B91C1C"/>
+                          </a:solidFill>
+                          <a:latin typeface="Georgia"/>
+                        </a:rPr>
+                        <a:t>Sell</a:t>
+                      </a:r>
+                    </a:p>
+                  </a:txBody>
+                  <a:tcPr marL="73152" marR="54864" marT="18288" marB="18288" anchor="ctr">
+                    <a:solidFill>
+                      <a:srgbClr val="FFFFFF"/>
+                    </a:solidFill>
+                  </a:tcPr>
+                </a:tc>
+                <a:tc>
+                  <a:txBody>
+                    <a:bodyPr wrap="square"/>
+                    <a:lstStyle/>
+                    <a:p>
+                      <a:pPr algn="l"/>
+                      <a:r>
+                        <a:rPr sz="1050" b="0" i="0">
+                          <a:solidFill>
+                            <a:srgbClr val="111827"/>
+                          </a:solidFill>
+                          <a:latin typeface="Georgia"/>
+                        </a:rPr>
+                        <a:t>Recovery is largely an easy base effect; new-entrant competition caps upside.</a:t>
+                      </a:r>
+                    </a:p>
+                  </a:txBody>
+                  <a:tcPr marL="73152" marR="54864" marT="18288" marB="18288" anchor="ctr">
+                    <a:solidFill>
+                      <a:srgbClr val="FFFFFF"/>
+                    </a:solidFill>
+                  </a:tcPr>
+                </a:tc>
+              </a:tr>
+            </a:tbl>
+          </a:graphicData>
+        </a:graphic>
+      </p:graphicFrame>
+      <p:sp>
+        <p:nvSpPr>
+          <p:cNvPr id="16" name="TextBox 15"/>
+          <p:cNvSpPr txBox="1"/>
+          <p:nvPr/>
+        </p:nvSpPr>
+        <p:spPr>
+          <a:xfrm>
+            <a:off x="548640" y="6281928"/>
+            <a:ext cx="11064240" cy="320040"/>
+          </a:xfrm>
+          <a:prstGeom prst="rect">
+            <a:avLst/>
+          </a:prstGeom>
+          <a:noFill/>
+        </p:spPr>
+        <p:txBody>
+          <a:bodyPr wrap="square" anchor="t">
+            <a:spAutoFit/>
+          </a:bodyPr>
+          <a:lstStyle/>
+          <a:p>
+            <a:pPr algn="l"/>
+            <a:r>
+              <a:rPr sz="1050" b="0" i="1">
                 <a:solidFill>
                   <a:srgbClr val="6B7280"/>
                 </a:solidFill>
                 <a:latin typeface="Georgia"/>
               </a:rPr>
-              <a:t>In the Nifty-100 build, this layer caught three overstated legal claims and pulled three growth numbers down a full band before they touched a score.</a:t>
+              <a:t>Reliance shows the analyst override at work: a low model score we deliberately Hold on forward optionality. The score informs the call, it does not dictate it.</a:t>
             </a:r>
           </a:p>
         </p:txBody>
@@ -13080,7 +13723,7 @@
                 </a:solidFill>
                 <a:latin typeface="Bahnschrift"/>
               </a:rPr>
-              <a:t>Coverage to date and the road ahead</a:t>
+              <a:t>The controls matter as much as the formulas</a:t>
             </a:r>
           </a:p>
         </p:txBody>
@@ -13115,7 +13758,7 @@
                 </a:solidFill>
                 <a:latin typeface="Georgia"/>
               </a:rPr>
-              <a:t>Where we are, and what is next</a:t>
+              <a:t>How we keep it honest</a:t>
             </a:r>
           </a:p>
         </p:txBody>
@@ -13274,6 +13917,1071 @@
                 <a:latin typeface="Georgia"/>
               </a:rPr>
               <a:t>18</a:t>
+            </a:r>
+          </a:p>
+        </p:txBody>
+      </p:sp>
+      <p:sp>
+        <p:nvSpPr>
+          <p:cNvPr id="10" name="Rounded Rectangle 9"/>
+          <p:cNvSpPr/>
+          <p:nvPr/>
+        </p:nvSpPr>
+        <p:spPr>
+          <a:xfrm>
+            <a:off x="548640" y="1463040"/>
+            <a:ext cx="146304" cy="603504"/>
+          </a:xfrm>
+          <a:prstGeom prst="roundRect">
+            <a:avLst>
+              <a:gd name="adj" fmla="val 30000"/>
+            </a:avLst>
+          </a:prstGeom>
+          <a:solidFill>
+            <a:srgbClr val="2563EB"/>
+          </a:solidFill>
+          <a:ln>
+            <a:noFill/>
+          </a:ln>
+          <a:effectLst/>
+        </p:spPr>
+        <p:style>
+          <a:lnRef idx="1">
+            <a:schemeClr val="accent1"/>
+          </a:lnRef>
+          <a:fillRef idx="3">
+            <a:schemeClr val="accent1"/>
+          </a:fillRef>
+          <a:effectRef idx="2">
+            <a:schemeClr val="accent1"/>
+          </a:effectRef>
+          <a:fontRef idx="minor">
+            <a:schemeClr val="lt1"/>
+          </a:fontRef>
+        </p:style>
+        <p:txBody>
+          <a:bodyPr rtlCol="0" anchor="ctr"/>
+          <a:lstStyle/>
+          <a:p>
+            <a:pPr algn="ctr"/>
+          </a:p>
+        </p:txBody>
+      </p:sp>
+      <p:sp>
+        <p:nvSpPr>
+          <p:cNvPr id="11" name="TextBox 10"/>
+          <p:cNvSpPr txBox="1"/>
+          <p:nvPr/>
+        </p:nvSpPr>
+        <p:spPr>
+          <a:xfrm>
+            <a:off x="868680" y="1444752"/>
+            <a:ext cx="2834640" cy="640080"/>
+          </a:xfrm>
+          <a:prstGeom prst="rect">
+            <a:avLst/>
+          </a:prstGeom>
+          <a:noFill/>
+        </p:spPr>
+        <p:txBody>
+          <a:bodyPr wrap="square" anchor="ctr">
+            <a:spAutoFit/>
+          </a:bodyPr>
+          <a:lstStyle/>
+          <a:p>
+            <a:pPr algn="l"/>
+            <a:r>
+              <a:rPr sz="1350" b="1" i="0">
+                <a:solidFill>
+                  <a:srgbClr val="1E3A8A"/>
+                </a:solidFill>
+                <a:latin typeface="Bahnschrift"/>
+              </a:rPr>
+              <a:t>Schema validation</a:t>
+            </a:r>
+          </a:p>
+        </p:txBody>
+      </p:sp>
+      <p:sp>
+        <p:nvSpPr>
+          <p:cNvPr id="12" name="TextBox 11"/>
+          <p:cNvSpPr txBox="1"/>
+          <p:nvPr/>
+        </p:nvSpPr>
+        <p:spPr>
+          <a:xfrm>
+            <a:off x="3794760" y="1444752"/>
+            <a:ext cx="7863840" cy="640080"/>
+          </a:xfrm>
+          <a:prstGeom prst="rect">
+            <a:avLst/>
+          </a:prstGeom>
+          <a:noFill/>
+        </p:spPr>
+        <p:txBody>
+          <a:bodyPr wrap="square" anchor="ctr">
+            <a:spAutoFit/>
+          </a:bodyPr>
+          <a:lstStyle/>
+          <a:p>
+            <a:pPr algn="l"/>
+            <a:r>
+              <a:rPr sz="1250" b="0" i="0">
+                <a:solidFill>
+                  <a:srgbClr val="111827"/>
+                </a:solidFill>
+                <a:latin typeface="Georgia"/>
+              </a:rPr>
+              <a:t>Every research file is checked for all fields and correct types before it counts.</a:t>
+            </a:r>
+          </a:p>
+        </p:txBody>
+      </p:sp>
+      <p:sp>
+        <p:nvSpPr>
+          <p:cNvPr id="13" name="Rounded Rectangle 12"/>
+          <p:cNvSpPr/>
+          <p:nvPr/>
+        </p:nvSpPr>
+        <p:spPr>
+          <a:xfrm>
+            <a:off x="548640" y="2121408"/>
+            <a:ext cx="146304" cy="603504"/>
+          </a:xfrm>
+          <a:prstGeom prst="roundRect">
+            <a:avLst>
+              <a:gd name="adj" fmla="val 30000"/>
+            </a:avLst>
+          </a:prstGeom>
+          <a:solidFill>
+            <a:srgbClr val="2563EB"/>
+          </a:solidFill>
+          <a:ln>
+            <a:noFill/>
+          </a:ln>
+          <a:effectLst/>
+        </p:spPr>
+        <p:style>
+          <a:lnRef idx="1">
+            <a:schemeClr val="accent1"/>
+          </a:lnRef>
+          <a:fillRef idx="3">
+            <a:schemeClr val="accent1"/>
+          </a:fillRef>
+          <a:effectRef idx="2">
+            <a:schemeClr val="accent1"/>
+          </a:effectRef>
+          <a:fontRef idx="minor">
+            <a:schemeClr val="lt1"/>
+          </a:fontRef>
+        </p:style>
+        <p:txBody>
+          <a:bodyPr rtlCol="0" anchor="ctr"/>
+          <a:lstStyle/>
+          <a:p>
+            <a:pPr algn="ctr"/>
+          </a:p>
+        </p:txBody>
+      </p:sp>
+      <p:sp>
+        <p:nvSpPr>
+          <p:cNvPr id="14" name="TextBox 13"/>
+          <p:cNvSpPr txBox="1"/>
+          <p:nvPr/>
+        </p:nvSpPr>
+        <p:spPr>
+          <a:xfrm>
+            <a:off x="868680" y="2103120"/>
+            <a:ext cx="2834640" cy="640080"/>
+          </a:xfrm>
+          <a:prstGeom prst="rect">
+            <a:avLst/>
+          </a:prstGeom>
+          <a:noFill/>
+        </p:spPr>
+        <p:txBody>
+          <a:bodyPr wrap="square" anchor="ctr">
+            <a:spAutoFit/>
+          </a:bodyPr>
+          <a:lstStyle/>
+          <a:p>
+            <a:pPr algn="l"/>
+            <a:r>
+              <a:rPr sz="1350" b="1" i="0">
+                <a:solidFill>
+                  <a:srgbClr val="1E3A8A"/>
+                </a:solidFill>
+                <a:latin typeface="Bahnschrift"/>
+              </a:rPr>
+              <a:t>Zero-tell style gate</a:t>
+            </a:r>
+          </a:p>
+        </p:txBody>
+      </p:sp>
+      <p:sp>
+        <p:nvSpPr>
+          <p:cNvPr id="15" name="TextBox 14"/>
+          <p:cNvSpPr txBox="1"/>
+          <p:nvPr/>
+        </p:nvSpPr>
+        <p:spPr>
+          <a:xfrm>
+            <a:off x="3794760" y="2103120"/>
+            <a:ext cx="7863840" cy="640080"/>
+          </a:xfrm>
+          <a:prstGeom prst="rect">
+            <a:avLst/>
+          </a:prstGeom>
+          <a:noFill/>
+        </p:spPr>
+        <p:txBody>
+          <a:bodyPr wrap="square" anchor="ctr">
+            <a:spAutoFit/>
+          </a:bodyPr>
+          <a:lstStyle/>
+          <a:p>
+            <a:pPr algn="l"/>
+            <a:r>
+              <a:rPr sz="1250" b="0" i="0">
+                <a:solidFill>
+                  <a:srgbClr val="111827"/>
+                </a:solidFill>
+                <a:latin typeface="Georgia"/>
+              </a:rPr>
+              <a:t>The builder refuses to ship a sheet containing AI writing tells or banned words.</a:t>
+            </a:r>
+          </a:p>
+        </p:txBody>
+      </p:sp>
+      <p:sp>
+        <p:nvSpPr>
+          <p:cNvPr id="16" name="Rounded Rectangle 15"/>
+          <p:cNvSpPr/>
+          <p:nvPr/>
+        </p:nvSpPr>
+        <p:spPr>
+          <a:xfrm>
+            <a:off x="548640" y="2779776"/>
+            <a:ext cx="146304" cy="603504"/>
+          </a:xfrm>
+          <a:prstGeom prst="roundRect">
+            <a:avLst>
+              <a:gd name="adj" fmla="val 30000"/>
+            </a:avLst>
+          </a:prstGeom>
+          <a:solidFill>
+            <a:srgbClr val="2563EB"/>
+          </a:solidFill>
+          <a:ln>
+            <a:noFill/>
+          </a:ln>
+          <a:effectLst/>
+        </p:spPr>
+        <p:style>
+          <a:lnRef idx="1">
+            <a:schemeClr val="accent1"/>
+          </a:lnRef>
+          <a:fillRef idx="3">
+            <a:schemeClr val="accent1"/>
+          </a:fillRef>
+          <a:effectRef idx="2">
+            <a:schemeClr val="accent1"/>
+          </a:effectRef>
+          <a:fontRef idx="minor">
+            <a:schemeClr val="lt1"/>
+          </a:fontRef>
+        </p:style>
+        <p:txBody>
+          <a:bodyPr rtlCol="0" anchor="ctr"/>
+          <a:lstStyle/>
+          <a:p>
+            <a:pPr algn="ctr"/>
+          </a:p>
+        </p:txBody>
+      </p:sp>
+      <p:sp>
+        <p:nvSpPr>
+          <p:cNvPr id="17" name="TextBox 16"/>
+          <p:cNvSpPr txBox="1"/>
+          <p:nvPr/>
+        </p:nvSpPr>
+        <p:spPr>
+          <a:xfrm>
+            <a:off x="868680" y="2761488"/>
+            <a:ext cx="2834640" cy="640080"/>
+          </a:xfrm>
+          <a:prstGeom prst="rect">
+            <a:avLst/>
+          </a:prstGeom>
+          <a:noFill/>
+        </p:spPr>
+        <p:txBody>
+          <a:bodyPr wrap="square" anchor="ctr">
+            <a:spAutoFit/>
+          </a:bodyPr>
+          <a:lstStyle/>
+          <a:p>
+            <a:pPr algn="l"/>
+            <a:r>
+              <a:rPr sz="1350" b="1" i="0">
+                <a:solidFill>
+                  <a:srgbClr val="1E3A8A"/>
+                </a:solidFill>
+                <a:latin typeface="Bahnschrift"/>
+              </a:rPr>
+              <a:t>Independent QA sweep</a:t>
+            </a:r>
+          </a:p>
+        </p:txBody>
+      </p:sp>
+      <p:sp>
+        <p:nvSpPr>
+          <p:cNvPr id="18" name="TextBox 17"/>
+          <p:cNvSpPr txBox="1"/>
+          <p:nvPr/>
+        </p:nvSpPr>
+        <p:spPr>
+          <a:xfrm>
+            <a:off x="3794760" y="2761488"/>
+            <a:ext cx="7863840" cy="640080"/>
+          </a:xfrm>
+          <a:prstGeom prst="rect">
+            <a:avLst/>
+          </a:prstGeom>
+          <a:noFill/>
+        </p:spPr>
+        <p:txBody>
+          <a:bodyPr wrap="square" anchor="ctr">
+            <a:spAutoFit/>
+          </a:bodyPr>
+          <a:lstStyle/>
+          <a:p>
+            <a:pPr algn="l"/>
+            <a:r>
+              <a:rPr sz="1250" b="0" i="0">
+                <a:solidFill>
+                  <a:srgbClr val="111827"/>
+                </a:solidFill>
+                <a:latin typeface="Georgia"/>
+              </a:rPr>
+              <a:t>A second agent audits each file: does the call match the reasoning, is the growth number calibrated, any Buy language, any pending-vs-done error.</a:t>
+            </a:r>
+          </a:p>
+        </p:txBody>
+      </p:sp>
+      <p:sp>
+        <p:nvSpPr>
+          <p:cNvPr id="19" name="Rounded Rectangle 18"/>
+          <p:cNvSpPr/>
+          <p:nvPr/>
+        </p:nvSpPr>
+        <p:spPr>
+          <a:xfrm>
+            <a:off x="548640" y="3438144"/>
+            <a:ext cx="146304" cy="603504"/>
+          </a:xfrm>
+          <a:prstGeom prst="roundRect">
+            <a:avLst>
+              <a:gd name="adj" fmla="val 30000"/>
+            </a:avLst>
+          </a:prstGeom>
+          <a:solidFill>
+            <a:srgbClr val="2563EB"/>
+          </a:solidFill>
+          <a:ln>
+            <a:noFill/>
+          </a:ln>
+          <a:effectLst/>
+        </p:spPr>
+        <p:style>
+          <a:lnRef idx="1">
+            <a:schemeClr val="accent1"/>
+          </a:lnRef>
+          <a:fillRef idx="3">
+            <a:schemeClr val="accent1"/>
+          </a:fillRef>
+          <a:effectRef idx="2">
+            <a:schemeClr val="accent1"/>
+          </a:effectRef>
+          <a:fontRef idx="minor">
+            <a:schemeClr val="lt1"/>
+          </a:fontRef>
+        </p:style>
+        <p:txBody>
+          <a:bodyPr rtlCol="0" anchor="ctr"/>
+          <a:lstStyle/>
+          <a:p>
+            <a:pPr algn="ctr"/>
+          </a:p>
+        </p:txBody>
+      </p:sp>
+      <p:sp>
+        <p:nvSpPr>
+          <p:cNvPr id="20" name="TextBox 19"/>
+          <p:cNvSpPr txBox="1"/>
+          <p:nvPr/>
+        </p:nvSpPr>
+        <p:spPr>
+          <a:xfrm>
+            <a:off x="868680" y="3419856"/>
+            <a:ext cx="2834640" cy="640080"/>
+          </a:xfrm>
+          <a:prstGeom prst="rect">
+            <a:avLst/>
+          </a:prstGeom>
+          <a:noFill/>
+        </p:spPr>
+        <p:txBody>
+          <a:bodyPr wrap="square" anchor="ctr">
+            <a:spAutoFit/>
+          </a:bodyPr>
+          <a:lstStyle/>
+          <a:p>
+            <a:pPr algn="l"/>
+            <a:r>
+              <a:rPr sz="1350" b="1" i="0">
+                <a:solidFill>
+                  <a:srgbClr val="1E3A8A"/>
+                </a:solidFill>
+                <a:latin typeface="Bahnschrift"/>
+              </a:rPr>
+              <a:t>Fact-check on claims</a:t>
+            </a:r>
+          </a:p>
+        </p:txBody>
+      </p:sp>
+      <p:sp>
+        <p:nvSpPr>
+          <p:cNvPr id="21" name="TextBox 20"/>
+          <p:cNvSpPr txBox="1"/>
+          <p:nvPr/>
+        </p:nvSpPr>
+        <p:spPr>
+          <a:xfrm>
+            <a:off x="3794760" y="3419856"/>
+            <a:ext cx="7863840" cy="640080"/>
+          </a:xfrm>
+          <a:prstGeom prst="rect">
+            <a:avLst/>
+          </a:prstGeom>
+          <a:noFill/>
+        </p:spPr>
+        <p:txBody>
+          <a:bodyPr wrap="square" anchor="ctr">
+            <a:spAutoFit/>
+          </a:bodyPr>
+          <a:lstStyle/>
+          <a:p>
+            <a:pPr algn="l"/>
+            <a:r>
+              <a:rPr sz="1250" b="0" i="0">
+                <a:solidFill>
+                  <a:srgbClr val="111827"/>
+                </a:solidFill>
+                <a:latin typeface="Georgia"/>
+              </a:rPr>
+              <a:t>Completed-versus-pending legal and deal claims are verified against primary sources.</a:t>
+            </a:r>
+          </a:p>
+        </p:txBody>
+      </p:sp>
+      <p:sp>
+        <p:nvSpPr>
+          <p:cNvPr id="22" name="Rounded Rectangle 21"/>
+          <p:cNvSpPr/>
+          <p:nvPr/>
+        </p:nvSpPr>
+        <p:spPr>
+          <a:xfrm>
+            <a:off x="548640" y="4096511"/>
+            <a:ext cx="146304" cy="603504"/>
+          </a:xfrm>
+          <a:prstGeom prst="roundRect">
+            <a:avLst>
+              <a:gd name="adj" fmla="val 30000"/>
+            </a:avLst>
+          </a:prstGeom>
+          <a:solidFill>
+            <a:srgbClr val="2563EB"/>
+          </a:solidFill>
+          <a:ln>
+            <a:noFill/>
+          </a:ln>
+          <a:effectLst/>
+        </p:spPr>
+        <p:style>
+          <a:lnRef idx="1">
+            <a:schemeClr val="accent1"/>
+          </a:lnRef>
+          <a:fillRef idx="3">
+            <a:schemeClr val="accent1"/>
+          </a:fillRef>
+          <a:effectRef idx="2">
+            <a:schemeClr val="accent1"/>
+          </a:effectRef>
+          <a:fontRef idx="minor">
+            <a:schemeClr val="lt1"/>
+          </a:fontRef>
+        </p:style>
+        <p:txBody>
+          <a:bodyPr rtlCol="0" anchor="ctr"/>
+          <a:lstStyle/>
+          <a:p>
+            <a:pPr algn="ctr"/>
+          </a:p>
+        </p:txBody>
+      </p:sp>
+      <p:sp>
+        <p:nvSpPr>
+          <p:cNvPr id="23" name="TextBox 22"/>
+          <p:cNvSpPr txBox="1"/>
+          <p:nvPr/>
+        </p:nvSpPr>
+        <p:spPr>
+          <a:xfrm>
+            <a:off x="868680" y="4078224"/>
+            <a:ext cx="2834640" cy="640080"/>
+          </a:xfrm>
+          <a:prstGeom prst="rect">
+            <a:avLst/>
+          </a:prstGeom>
+          <a:noFill/>
+        </p:spPr>
+        <p:txBody>
+          <a:bodyPr wrap="square" anchor="ctr">
+            <a:spAutoFit/>
+          </a:bodyPr>
+          <a:lstStyle/>
+          <a:p>
+            <a:pPr algn="l"/>
+            <a:r>
+              <a:rPr sz="1350" b="1" i="0">
+                <a:solidFill>
+                  <a:srgbClr val="1E3A8A"/>
+                </a:solidFill>
+                <a:latin typeface="Bahnschrift"/>
+              </a:rPr>
+              <a:t>Growth re-adjudication</a:t>
+            </a:r>
+          </a:p>
+        </p:txBody>
+      </p:sp>
+      <p:sp>
+        <p:nvSpPr>
+          <p:cNvPr id="24" name="TextBox 23"/>
+          <p:cNvSpPr txBox="1"/>
+          <p:nvPr/>
+        </p:nvSpPr>
+        <p:spPr>
+          <a:xfrm>
+            <a:off x="3794760" y="4078224"/>
+            <a:ext cx="7863840" cy="640080"/>
+          </a:xfrm>
+          <a:prstGeom prst="rect">
+            <a:avLst/>
+          </a:prstGeom>
+          <a:noFill/>
+        </p:spPr>
+        <p:txBody>
+          <a:bodyPr wrap="square" anchor="ctr">
+            <a:spAutoFit/>
+          </a:bodyPr>
+          <a:lstStyle/>
+          <a:p>
+            <a:pPr algn="l"/>
+            <a:r>
+              <a:rPr sz="1250" b="0" i="0">
+                <a:solidFill>
+                  <a:srgbClr val="111827"/>
+                </a:solidFill>
+                <a:latin typeface="Georgia"/>
+              </a:rPr>
+              <a:t>A flagged growth number goes back to the same analyst desk to defend or revise.</a:t>
+            </a:r>
+          </a:p>
+        </p:txBody>
+      </p:sp>
+      <p:sp>
+        <p:nvSpPr>
+          <p:cNvPr id="25" name="Rounded Rectangle 24"/>
+          <p:cNvSpPr/>
+          <p:nvPr/>
+        </p:nvSpPr>
+        <p:spPr>
+          <a:xfrm>
+            <a:off x="548640" y="4754879"/>
+            <a:ext cx="146304" cy="603504"/>
+          </a:xfrm>
+          <a:prstGeom prst="roundRect">
+            <a:avLst>
+              <a:gd name="adj" fmla="val 30000"/>
+            </a:avLst>
+          </a:prstGeom>
+          <a:solidFill>
+            <a:srgbClr val="2563EB"/>
+          </a:solidFill>
+          <a:ln>
+            <a:noFill/>
+          </a:ln>
+          <a:effectLst/>
+        </p:spPr>
+        <p:style>
+          <a:lnRef idx="1">
+            <a:schemeClr val="accent1"/>
+          </a:lnRef>
+          <a:fillRef idx="3">
+            <a:schemeClr val="accent1"/>
+          </a:fillRef>
+          <a:effectRef idx="2">
+            <a:schemeClr val="accent1"/>
+          </a:effectRef>
+          <a:fontRef idx="minor">
+            <a:schemeClr val="lt1"/>
+          </a:fontRef>
+        </p:style>
+        <p:txBody>
+          <a:bodyPr rtlCol="0" anchor="ctr"/>
+          <a:lstStyle/>
+          <a:p>
+            <a:pPr algn="ctr"/>
+          </a:p>
+        </p:txBody>
+      </p:sp>
+      <p:sp>
+        <p:nvSpPr>
+          <p:cNvPr id="26" name="TextBox 25"/>
+          <p:cNvSpPr txBox="1"/>
+          <p:nvPr/>
+        </p:nvSpPr>
+        <p:spPr>
+          <a:xfrm>
+            <a:off x="868680" y="4736592"/>
+            <a:ext cx="2834640" cy="640080"/>
+          </a:xfrm>
+          <a:prstGeom prst="rect">
+            <a:avLst/>
+          </a:prstGeom>
+          <a:noFill/>
+        </p:spPr>
+        <p:txBody>
+          <a:bodyPr wrap="square" anchor="ctr">
+            <a:spAutoFit/>
+          </a:bodyPr>
+          <a:lstStyle/>
+          <a:p>
+            <a:pPr algn="l"/>
+            <a:r>
+              <a:rPr sz="1350" b="1" i="0">
+                <a:solidFill>
+                  <a:srgbClr val="1E3A8A"/>
+                </a:solidFill>
+                <a:latin typeface="Bahnschrift"/>
+              </a:rPr>
+              <a:t>Human sign-off</a:t>
+            </a:r>
+          </a:p>
+        </p:txBody>
+      </p:sp>
+      <p:sp>
+        <p:nvSpPr>
+          <p:cNvPr id="27" name="TextBox 26"/>
+          <p:cNvSpPr txBox="1"/>
+          <p:nvPr/>
+        </p:nvSpPr>
+        <p:spPr>
+          <a:xfrm>
+            <a:off x="3794760" y="4736592"/>
+            <a:ext cx="7863840" cy="640080"/>
+          </a:xfrm>
+          <a:prstGeom prst="rect">
+            <a:avLst/>
+          </a:prstGeom>
+          <a:noFill/>
+        </p:spPr>
+        <p:txBody>
+          <a:bodyPr wrap="square" anchor="ctr">
+            <a:spAutoFit/>
+          </a:bodyPr>
+          <a:lstStyle/>
+          <a:p>
+            <a:pPr algn="l"/>
+            <a:r>
+              <a:rPr sz="1250" b="0" i="0">
+                <a:solidFill>
+                  <a:srgbClr val="111827"/>
+                </a:solidFill>
+                <a:latin typeface="Georgia"/>
+              </a:rPr>
+              <a:t>Nothing reaches a client without the Principal's approval.</a:t>
+            </a:r>
+          </a:p>
+        </p:txBody>
+      </p:sp>
+      <p:sp>
+        <p:nvSpPr>
+          <p:cNvPr id="28" name="TextBox 27"/>
+          <p:cNvSpPr txBox="1"/>
+          <p:nvPr/>
+        </p:nvSpPr>
+        <p:spPr>
+          <a:xfrm>
+            <a:off x="868680" y="5431535"/>
+            <a:ext cx="10789920" cy="457200"/>
+          </a:xfrm>
+          <a:prstGeom prst="rect">
+            <a:avLst/>
+          </a:prstGeom>
+          <a:noFill/>
+        </p:spPr>
+        <p:txBody>
+          <a:bodyPr wrap="square" anchor="t">
+            <a:spAutoFit/>
+          </a:bodyPr>
+          <a:lstStyle/>
+          <a:p>
+            <a:pPr algn="l"/>
+            <a:r>
+              <a:rPr sz="1200" b="0" i="1">
+                <a:solidFill>
+                  <a:srgbClr val="6B7280"/>
+                </a:solidFill>
+                <a:latin typeface="Georgia"/>
+              </a:rPr>
+              <a:t>In the Nifty-100 build, this layer caught three overstated legal claims and pulled three growth numbers down a full band before they touched a score.</a:t>
+            </a:r>
+          </a:p>
+        </p:txBody>
+      </p:sp>
+    </p:spTree>
+  </p:cSld>
+  <p:clrMapOvr>
+    <a:masterClrMapping/>
+  </p:clrMapOvr>
+</p:sld>
+</file>
+
+<file path=ppt/slides/slide23.xml><?xml version="1.0" encoding="utf-8"?>
+<p:sld xmlns:a="http://schemas.openxmlformats.org/drawingml/2006/main" xmlns:p="http://schemas.openxmlformats.org/presentationml/2006/main" xmlns:r="http://schemas.openxmlformats.org/officeDocument/2006/relationships">
+  <p:cSld>
+    <p:spTree>
+      <p:nvGrpSpPr>
+        <p:cNvPr id="1" name=""/>
+        <p:cNvGrpSpPr/>
+        <p:nvPr/>
+      </p:nvGrpSpPr>
+      <p:grpSpPr/>
+      <p:sp>
+        <p:nvSpPr>
+          <p:cNvPr id="2" name="Rectangle 1"/>
+          <p:cNvSpPr/>
+          <p:nvPr/>
+        </p:nvSpPr>
+        <p:spPr>
+          <a:xfrm>
+            <a:off x="0" y="0"/>
+            <a:ext cx="12191695" cy="6858000"/>
+          </a:xfrm>
+          <a:prstGeom prst="rect">
+            <a:avLst/>
+          </a:prstGeom>
+          <a:solidFill>
+            <a:srgbClr val="FFFFFF"/>
+          </a:solidFill>
+          <a:ln>
+            <a:noFill/>
+          </a:ln>
+          <a:effectLst/>
+        </p:spPr>
+        <p:style>
+          <a:lnRef idx="1">
+            <a:schemeClr val="accent1"/>
+          </a:lnRef>
+          <a:fillRef idx="3">
+            <a:schemeClr val="accent1"/>
+          </a:fillRef>
+          <a:effectRef idx="2">
+            <a:schemeClr val="accent1"/>
+          </a:effectRef>
+          <a:fontRef idx="minor">
+            <a:schemeClr val="lt1"/>
+          </a:fontRef>
+        </p:style>
+        <p:txBody>
+          <a:bodyPr rtlCol="0" anchor="ctr"/>
+          <a:lstStyle/>
+          <a:p>
+            <a:pPr algn="ctr"/>
+          </a:p>
+        </p:txBody>
+      </p:sp>
+      <p:sp>
+        <p:nvSpPr>
+          <p:cNvPr id="3" name="Rectangle 2"/>
+          <p:cNvSpPr/>
+          <p:nvPr/>
+        </p:nvSpPr>
+        <p:spPr>
+          <a:xfrm>
+            <a:off x="0" y="0"/>
+            <a:ext cx="12191695" cy="128016"/>
+          </a:xfrm>
+          <a:prstGeom prst="rect">
+            <a:avLst/>
+          </a:prstGeom>
+          <a:solidFill>
+            <a:srgbClr val="2563EB"/>
+          </a:solidFill>
+          <a:ln>
+            <a:noFill/>
+          </a:ln>
+          <a:effectLst/>
+        </p:spPr>
+        <p:style>
+          <a:lnRef idx="1">
+            <a:schemeClr val="accent1"/>
+          </a:lnRef>
+          <a:fillRef idx="3">
+            <a:schemeClr val="accent1"/>
+          </a:fillRef>
+          <a:effectRef idx="2">
+            <a:schemeClr val="accent1"/>
+          </a:effectRef>
+          <a:fontRef idx="minor">
+            <a:schemeClr val="lt1"/>
+          </a:fontRef>
+        </p:style>
+        <p:txBody>
+          <a:bodyPr rtlCol="0" anchor="ctr"/>
+          <a:lstStyle/>
+          <a:p>
+            <a:pPr algn="ctr"/>
+          </a:p>
+        </p:txBody>
+      </p:sp>
+      <p:sp>
+        <p:nvSpPr>
+          <p:cNvPr id="4" name="TextBox 3"/>
+          <p:cNvSpPr txBox="1"/>
+          <p:nvPr/>
+        </p:nvSpPr>
+        <p:spPr>
+          <a:xfrm>
+            <a:off x="548640" y="310896"/>
+            <a:ext cx="11064240" cy="640080"/>
+          </a:xfrm>
+          <a:prstGeom prst="rect">
+            <a:avLst/>
+          </a:prstGeom>
+          <a:noFill/>
+        </p:spPr>
+        <p:txBody>
+          <a:bodyPr wrap="square" anchor="t">
+            <a:spAutoFit/>
+          </a:bodyPr>
+          <a:lstStyle/>
+          <a:p>
+            <a:pPr algn="l"/>
+            <a:r>
+              <a:rPr sz="2500" b="1" i="0">
+                <a:solidFill>
+                  <a:srgbClr val="1E3A8A"/>
+                </a:solidFill>
+                <a:latin typeface="Bahnschrift"/>
+              </a:rPr>
+              <a:t>Coverage to date and the road ahead</a:t>
+            </a:r>
+          </a:p>
+        </p:txBody>
+      </p:sp>
+      <p:sp>
+        <p:nvSpPr>
+          <p:cNvPr id="5" name="TextBox 4"/>
+          <p:cNvSpPr txBox="1"/>
+          <p:nvPr/>
+        </p:nvSpPr>
+        <p:spPr>
+          <a:xfrm>
+            <a:off x="566928" y="841248"/>
+            <a:ext cx="11064240" cy="274320"/>
+          </a:xfrm>
+          <a:prstGeom prst="rect">
+            <a:avLst/>
+          </a:prstGeom>
+          <a:noFill/>
+        </p:spPr>
+        <p:txBody>
+          <a:bodyPr wrap="square" anchor="t">
+            <a:spAutoFit/>
+          </a:bodyPr>
+          <a:lstStyle/>
+          <a:p>
+            <a:pPr algn="l"/>
+            <a:r>
+              <a:rPr sz="1150" b="0" i="1">
+                <a:solidFill>
+                  <a:srgbClr val="6B7280"/>
+                </a:solidFill>
+                <a:latin typeface="Georgia"/>
+              </a:rPr>
+              <a:t>Where we are, and what is next</a:t>
+            </a:r>
+          </a:p>
+        </p:txBody>
+      </p:sp>
+      <p:sp>
+        <p:nvSpPr>
+          <p:cNvPr id="6" name="Rectangle 5"/>
+          <p:cNvSpPr/>
+          <p:nvPr/>
+        </p:nvSpPr>
+        <p:spPr>
+          <a:xfrm>
+            <a:off x="548640" y="1170432"/>
+            <a:ext cx="11091672" cy="25603"/>
+          </a:xfrm>
+          <a:prstGeom prst="rect">
+            <a:avLst/>
+          </a:prstGeom>
+          <a:solidFill>
+            <a:srgbClr val="2563EB"/>
+          </a:solidFill>
+          <a:ln>
+            <a:noFill/>
+          </a:ln>
+          <a:effectLst/>
+        </p:spPr>
+        <p:style>
+          <a:lnRef idx="1">
+            <a:schemeClr val="accent1"/>
+          </a:lnRef>
+          <a:fillRef idx="3">
+            <a:schemeClr val="accent1"/>
+          </a:fillRef>
+          <a:effectRef idx="2">
+            <a:schemeClr val="accent1"/>
+          </a:effectRef>
+          <a:fontRef idx="minor">
+            <a:schemeClr val="lt1"/>
+          </a:fontRef>
+        </p:style>
+        <p:txBody>
+          <a:bodyPr rtlCol="0" anchor="ctr"/>
+          <a:lstStyle/>
+          <a:p>
+            <a:pPr algn="ctr"/>
+          </a:p>
+        </p:txBody>
+      </p:sp>
+      <p:sp>
+        <p:nvSpPr>
+          <p:cNvPr id="7" name="Rectangle 6"/>
+          <p:cNvSpPr/>
+          <p:nvPr/>
+        </p:nvSpPr>
+        <p:spPr>
+          <a:xfrm>
+            <a:off x="0" y="6656832"/>
+            <a:ext cx="12191695" cy="201168"/>
+          </a:xfrm>
+          <a:prstGeom prst="rect">
+            <a:avLst/>
+          </a:prstGeom>
+          <a:solidFill>
+            <a:srgbClr val="F3F4F6"/>
+          </a:solidFill>
+          <a:ln>
+            <a:noFill/>
+          </a:ln>
+          <a:effectLst/>
+        </p:spPr>
+        <p:style>
+          <a:lnRef idx="1">
+            <a:schemeClr val="accent1"/>
+          </a:lnRef>
+          <a:fillRef idx="3">
+            <a:schemeClr val="accent1"/>
+          </a:fillRef>
+          <a:effectRef idx="2">
+            <a:schemeClr val="accent1"/>
+          </a:effectRef>
+          <a:fontRef idx="minor">
+            <a:schemeClr val="lt1"/>
+          </a:fontRef>
+        </p:style>
+        <p:txBody>
+          <a:bodyPr rtlCol="0" anchor="ctr"/>
+          <a:lstStyle/>
+          <a:p>
+            <a:pPr algn="ctr"/>
+          </a:p>
+        </p:txBody>
+      </p:sp>
+      <p:sp>
+        <p:nvSpPr>
+          <p:cNvPr id="8" name="TextBox 7"/>
+          <p:cNvSpPr txBox="1"/>
+          <p:nvPr/>
+        </p:nvSpPr>
+        <p:spPr>
+          <a:xfrm>
+            <a:off x="548640" y="6656832"/>
+            <a:ext cx="8229600" cy="201168"/>
+          </a:xfrm>
+          <a:prstGeom prst="rect">
+            <a:avLst/>
+          </a:prstGeom>
+          <a:noFill/>
+        </p:spPr>
+        <p:txBody>
+          <a:bodyPr wrap="square" anchor="ctr">
+            <a:spAutoFit/>
+          </a:bodyPr>
+          <a:lstStyle/>
+          <a:p>
+            <a:pPr algn="l"/>
+            <a:r>
+              <a:rPr sz="800" b="0" i="0">
+                <a:solidFill>
+                  <a:srgbClr val="6B7280"/>
+                </a:solidFill>
+                <a:latin typeface="Georgia"/>
+              </a:rPr>
+              <a:t>Ionic Wealth · Stock Scorecard: Methodology &amp; Workflow · Internal, for team review</a:t>
+            </a:r>
+          </a:p>
+        </p:txBody>
+      </p:sp>
+      <p:sp>
+        <p:nvSpPr>
+          <p:cNvPr id="9" name="TextBox 8"/>
+          <p:cNvSpPr txBox="1"/>
+          <p:nvPr/>
+        </p:nvSpPr>
+        <p:spPr>
+          <a:xfrm>
+            <a:off x="10515600" y="6656832"/>
+            <a:ext cx="1097280" cy="201168"/>
+          </a:xfrm>
+          <a:prstGeom prst="rect">
+            <a:avLst/>
+          </a:prstGeom>
+          <a:noFill/>
+        </p:spPr>
+        <p:txBody>
+          <a:bodyPr wrap="square" anchor="ctr">
+            <a:spAutoFit/>
+          </a:bodyPr>
+          <a:lstStyle/>
+          <a:p>
+            <a:pPr algn="r"/>
+            <a:r>
+              <a:rPr sz="800" b="0" i="0">
+                <a:solidFill>
+                  <a:srgbClr val="6B7280"/>
+                </a:solidFill>
+                <a:latin typeface="Georgia"/>
+              </a:rPr>
+              <a:t>19</a:t>
             </a:r>
           </a:p>
         </p:txBody>
@@ -14045,7 +15753,7 @@
 </p:sld>
 </file>
 
-<file path=ppt/slides/slide23.xml><?xml version="1.0" encoding="utf-8"?>
+<file path=ppt/slides/slide24.xml><?xml version="1.0" encoding="utf-8"?>
 <p:sld xmlns:a="http://schemas.openxmlformats.org/drawingml/2006/main" xmlns:p="http://schemas.openxmlformats.org/presentationml/2006/main" xmlns:r="http://schemas.openxmlformats.org/officeDocument/2006/relationships">
   <p:cSld>
     <p:spTree>

</xml_diff>

<commit_message>
PIT quant-only backtest (do b): v1 red-teamed + corrected v2 on mandated PIT sources; directionally + but not significant
Co-Authored-By: Claude Fable 5 <noreply@anthropic.com>
</commit_message>
<xml_diff>
--- a/Shreyas_Ionic_AMC/09_PRODUCT/reports/IONIC_SCORECARD_METHODOLOGY_DECK.pptx
+++ b/Shreyas_Ionic_AMC/09_PRODUCT/reports/IONIC_SCORECARD_METHODOLOGY_DECK.pptx
@@ -5,32 +5,32 @@
     <p:sldMasterId id="2147483648" r:id="rId1"/>
   </p:sldMasterIdLst>
   <p:sldIdLst>
-    <p:sldId id="256" r:id="rId7"/>
-    <p:sldId id="257" r:id="rId8"/>
-    <p:sldId id="258" r:id="rId9"/>
-    <p:sldId id="259" r:id="rId10"/>
-    <p:sldId id="260" r:id="rId11"/>
-    <p:sldId id="261" r:id="rId12"/>
-    <p:sldId id="262" r:id="rId13"/>
-    <p:sldId id="263" r:id="rId14"/>
-    <p:sldId id="264" r:id="rId15"/>
-    <p:sldId id="265" r:id="rId16"/>
-    <p:sldId id="266" r:id="rId17"/>
-    <p:sldId id="267" r:id="rId18"/>
-    <p:sldId id="268" r:id="rId19"/>
-    <p:sldId id="269" r:id="rId20"/>
-    <p:sldId id="270" r:id="rId21"/>
-    <p:sldId id="271" r:id="rId22"/>
-    <p:sldId id="272" r:id="rId23"/>
-    <p:sldId id="273" r:id="rId24"/>
-    <p:sldId id="274" r:id="rId25"/>
-    <p:sldId id="275" r:id="rId26"/>
-    <p:sldId id="276" r:id="rId27"/>
-    <p:sldId id="277" r:id="rId28"/>
-    <p:sldId id="278" r:id="rId29"/>
-    <p:sldId id="279" r:id="rId30"/>
+    <p:sldId id="256" r:id="rId2"/>
+    <p:sldId id="257" r:id="rId3"/>
+    <p:sldId id="258" r:id="rId4"/>
+    <p:sldId id="259" r:id="rId5"/>
+    <p:sldId id="260" r:id="rId6"/>
+    <p:sldId id="261" r:id="rId7"/>
+    <p:sldId id="262" r:id="rId8"/>
+    <p:sldId id="263" r:id="rId9"/>
+    <p:sldId id="264" r:id="rId10"/>
+    <p:sldId id="265" r:id="rId11"/>
+    <p:sldId id="266" r:id="rId12"/>
+    <p:sldId id="267" r:id="rId13"/>
+    <p:sldId id="268" r:id="rId14"/>
+    <p:sldId id="269" r:id="rId15"/>
+    <p:sldId id="270" r:id="rId16"/>
+    <p:sldId id="271" r:id="rId17"/>
+    <p:sldId id="272" r:id="rId18"/>
+    <p:sldId id="273" r:id="rId19"/>
+    <p:sldId id="274" r:id="rId20"/>
+    <p:sldId id="275" r:id="rId21"/>
+    <p:sldId id="276" r:id="rId22"/>
+    <p:sldId id="277" r:id="rId23"/>
+    <p:sldId id="278" r:id="rId24"/>
+    <p:sldId id="279" r:id="rId25"/>
   </p:sldIdLst>
-  <p:sldSz cx="12191695" cy="6858000" type="screen4x3"/>
+  <p:sldSz cx="12192000" cy="6858000"/>
   <p:notesSz cx="6858000" cy="9144000"/>
   <p:defaultTextStyle>
     <a:defPPr>
@@ -127,7 +127,75 @@
       </a:defRPr>
     </a:lvl9pPr>
   </p:defaultTextStyle>
+  <p:extLst>
+    <p:ext uri="{EFAFB233-063F-42B5-8137-9DF3F51BA10A}">
+      <p15:sldGuideLst xmlns:p15="http://schemas.microsoft.com/office/powerpoint/2012/main">
+        <p15:guide id="1" orient="horz" pos="2160">
+          <p15:clr>
+            <a:srgbClr val="A4A3A4"/>
+          </p15:clr>
+        </p15:guide>
+        <p15:guide id="2" pos="2880">
+          <p15:clr>
+            <a:srgbClr val="A4A3A4"/>
+          </p15:clr>
+        </p15:guide>
+      </p15:sldGuideLst>
+    </p:ext>
+  </p:extLst>
 </p:presentation>
+</file>
+
+<file path=ppt/changesInfos/changesInfo1.xml><?xml version="1.0" encoding="utf-8"?>
+<pc:chgInfo xmlns:a="http://schemas.openxmlformats.org/drawingml/2006/main" xmlns:r="http://schemas.openxmlformats.org/officeDocument/2006/relationships" xmlns:ac="http://schemas.microsoft.com/office/drawing/2013/main/command" xmlns:pc="http://schemas.microsoft.com/office/powerpoint/2013/main/command">
+  <pc:docChgLst>
+    <pc:chgData name="Shreyas Gupta" userId="012d5afd-9295-4939-981a-93e082ffd108" providerId="ADAL" clId="{ECA260C8-5CAA-4207-9635-07E614C4BA65}"/>
+    <pc:docChg chg="mod modSld modMainMaster">
+      <pc:chgData name="Shreyas Gupta" userId="012d5afd-9295-4939-981a-93e082ffd108" providerId="ADAL" clId="{ECA260C8-5CAA-4207-9635-07E614C4BA65}" dt="2026-07-20T07:35:48.802" v="3" actId="33475"/>
+      <pc:docMkLst>
+        <pc:docMk/>
+      </pc:docMkLst>
+      <pc:sldChg chg="modSp mod">
+        <pc:chgData name="Shreyas Gupta" userId="012d5afd-9295-4939-981a-93e082ffd108" providerId="ADAL" clId="{ECA260C8-5CAA-4207-9635-07E614C4BA65}" dt="2026-07-20T07:35:47.433" v="1" actId="1076"/>
+        <pc:sldMkLst>
+          <pc:docMk/>
+          <pc:sldMk cId="0" sldId="264"/>
+        </pc:sldMkLst>
+        <pc:spChg chg="mod">
+          <ac:chgData name="Shreyas Gupta" userId="012d5afd-9295-4939-981a-93e082ffd108" providerId="ADAL" clId="{ECA260C8-5CAA-4207-9635-07E614C4BA65}" dt="2026-07-20T07:35:42.247" v="0" actId="1076"/>
+          <ac:spMkLst>
+            <pc:docMk/>
+            <pc:sldMk cId="0" sldId="264"/>
+            <ac:spMk id="13" creationId="{00000000-0000-0000-0000-000000000000}"/>
+          </ac:spMkLst>
+        </pc:spChg>
+        <pc:spChg chg="mod">
+          <ac:chgData name="Shreyas Gupta" userId="012d5afd-9295-4939-981a-93e082ffd108" providerId="ADAL" clId="{ECA260C8-5CAA-4207-9635-07E614C4BA65}" dt="2026-07-20T07:35:47.433" v="1" actId="1076"/>
+          <ac:spMkLst>
+            <pc:docMk/>
+            <pc:sldMk cId="0" sldId="264"/>
+            <ac:spMk id="14" creationId="{00000000-0000-0000-0000-000000000000}"/>
+          </ac:spMkLst>
+        </pc:spChg>
+      </pc:sldChg>
+      <pc:sldMasterChg chg="addSp mod">
+        <pc:chgData name="Shreyas Gupta" userId="012d5afd-9295-4939-981a-93e082ffd108" providerId="ADAL" clId="{ECA260C8-5CAA-4207-9635-07E614C4BA65}" dt="2026-07-20T07:35:48.797" v="2" actId="33475"/>
+        <pc:sldMasterMkLst>
+          <pc:docMk/>
+          <pc:sldMasterMk cId="2209977519" sldId="2147483648"/>
+        </pc:sldMasterMkLst>
+        <pc:spChg chg="add">
+          <ac:chgData name="Shreyas Gupta" userId="012d5afd-9295-4939-981a-93e082ffd108" providerId="ADAL" clId="{ECA260C8-5CAA-4207-9635-07E614C4BA65}" dt="2026-07-20T07:35:48.797" v="2" actId="33475"/>
+          <ac:spMkLst>
+            <pc:docMk/>
+            <pc:sldMasterMk cId="2209977519" sldId="2147483648"/>
+            <ac:spMk id="8" creationId="{540451B9-7FC6-009F-AC3A-141E756A6DB2}"/>
+          </ac:spMkLst>
+        </pc:spChg>
+      </pc:sldMasterChg>
+    </pc:docChg>
+  </pc:docChgLst>
+</pc:chgInfo>
 </file>
 
 <file path=ppt/slideLayouts/slideLayout1.xml><?xml version="1.0" encoding="utf-8"?>
@@ -168,10 +236,9 @@
           <a:lstStyle/>
           <a:p>
             <a:r>
-              <a:rPr lang="en-US" smtClean="0"/>
+              <a:rPr lang="en-US"/>
               <a:t>Click to edit Master title style</a:t>
             </a:r>
-            <a:endParaRPr lang="en-US"/>
           </a:p>
         </p:txBody>
       </p:sp>
@@ -287,10 +354,9 @@
           </a:lstStyle>
           <a:p>
             <a:r>
-              <a:rPr lang="en-US" smtClean="0"/>
+              <a:rPr lang="en-US"/>
               <a:t>Click to edit Master subtitle style</a:t>
             </a:r>
-            <a:endParaRPr lang="en-US"/>
           </a:p>
         </p:txBody>
       </p:sp>
@@ -311,7 +377,7 @@
           <a:p>
             <a:fld id="{5BCAD085-E8A6-8845-BD4E-CB4CCA059FC4}" type="datetimeFigureOut">
               <a:rPr lang="en-US" smtClean="0"/>
-              <a:t>1/27/13</a:t>
+              <a:t>20-Jul-26</a:t>
             </a:fld>
             <a:endParaRPr lang="en-US"/>
           </a:p>
@@ -405,10 +471,9 @@
           <a:lstStyle/>
           <a:p>
             <a:r>
-              <a:rPr lang="en-US" smtClean="0"/>
+              <a:rPr lang="en-US"/>
               <a:t>Click to edit Master title style</a:t>
             </a:r>
-            <a:endParaRPr lang="en-US"/>
           </a:p>
         </p:txBody>
       </p:sp>
@@ -429,38 +494,37 @@
           <a:p>
             <a:pPr lvl="0"/>
             <a:r>
-              <a:rPr lang="en-US" smtClean="0"/>
+              <a:rPr lang="en-US"/>
               <a:t>Click to edit Master text styles</a:t>
             </a:r>
           </a:p>
           <a:p>
             <a:pPr lvl="1"/>
             <a:r>
-              <a:rPr lang="en-US" smtClean="0"/>
+              <a:rPr lang="en-US"/>
               <a:t>Second level</a:t>
             </a:r>
           </a:p>
           <a:p>
             <a:pPr lvl="2"/>
             <a:r>
-              <a:rPr lang="en-US" smtClean="0"/>
+              <a:rPr lang="en-US"/>
               <a:t>Third level</a:t>
             </a:r>
           </a:p>
           <a:p>
             <a:pPr lvl="3"/>
             <a:r>
-              <a:rPr lang="en-US" smtClean="0"/>
+              <a:rPr lang="en-US"/>
               <a:t>Fourth level</a:t>
             </a:r>
           </a:p>
           <a:p>
             <a:pPr lvl="4"/>
             <a:r>
-              <a:rPr lang="en-US" smtClean="0"/>
+              <a:rPr lang="en-US"/>
               <a:t>Fifth level</a:t>
             </a:r>
-            <a:endParaRPr lang="en-US"/>
           </a:p>
         </p:txBody>
       </p:sp>
@@ -481,7 +545,7 @@
           <a:p>
             <a:fld id="{5BCAD085-E8A6-8845-BD4E-CB4CCA059FC4}" type="datetimeFigureOut">
               <a:rPr lang="en-US" smtClean="0"/>
-              <a:t>1/27/13</a:t>
+              <a:t>20-Jul-26</a:t>
             </a:fld>
             <a:endParaRPr lang="en-US"/>
           </a:p>
@@ -580,10 +644,9 @@
           <a:lstStyle/>
           <a:p>
             <a:r>
-              <a:rPr lang="en-US" smtClean="0"/>
+              <a:rPr lang="en-US"/>
               <a:t>Click to edit Master title style</a:t>
             </a:r>
-            <a:endParaRPr lang="en-US"/>
           </a:p>
         </p:txBody>
       </p:sp>
@@ -609,38 +672,37 @@
           <a:p>
             <a:pPr lvl="0"/>
             <a:r>
-              <a:rPr lang="en-US" smtClean="0"/>
+              <a:rPr lang="en-US"/>
               <a:t>Click to edit Master text styles</a:t>
             </a:r>
           </a:p>
           <a:p>
             <a:pPr lvl="1"/>
             <a:r>
-              <a:rPr lang="en-US" smtClean="0"/>
+              <a:rPr lang="en-US"/>
               <a:t>Second level</a:t>
             </a:r>
           </a:p>
           <a:p>
             <a:pPr lvl="2"/>
             <a:r>
-              <a:rPr lang="en-US" smtClean="0"/>
+              <a:rPr lang="en-US"/>
               <a:t>Third level</a:t>
             </a:r>
           </a:p>
           <a:p>
             <a:pPr lvl="3"/>
             <a:r>
-              <a:rPr lang="en-US" smtClean="0"/>
+              <a:rPr lang="en-US"/>
               <a:t>Fourth level</a:t>
             </a:r>
           </a:p>
           <a:p>
             <a:pPr lvl="4"/>
             <a:r>
-              <a:rPr lang="en-US" smtClean="0"/>
+              <a:rPr lang="en-US"/>
               <a:t>Fifth level</a:t>
             </a:r>
-            <a:endParaRPr lang="en-US"/>
           </a:p>
         </p:txBody>
       </p:sp>
@@ -661,7 +723,7 @@
           <a:p>
             <a:fld id="{5BCAD085-E8A6-8845-BD4E-CB4CCA059FC4}" type="datetimeFigureOut">
               <a:rPr lang="en-US" smtClean="0"/>
-              <a:t>1/27/13</a:t>
+              <a:t>20-Jul-26</a:t>
             </a:fld>
             <a:endParaRPr lang="en-US"/>
           </a:p>
@@ -755,10 +817,9 @@
           <a:lstStyle/>
           <a:p>
             <a:r>
-              <a:rPr lang="en-US" smtClean="0"/>
+              <a:rPr lang="en-US"/>
               <a:t>Click to edit Master title style</a:t>
             </a:r>
-            <a:endParaRPr lang="en-US"/>
           </a:p>
         </p:txBody>
       </p:sp>
@@ -779,38 +840,37 @@
           <a:p>
             <a:pPr lvl="0"/>
             <a:r>
-              <a:rPr lang="en-US" smtClean="0"/>
+              <a:rPr lang="en-US"/>
               <a:t>Click to edit Master text styles</a:t>
             </a:r>
           </a:p>
           <a:p>
             <a:pPr lvl="1"/>
             <a:r>
-              <a:rPr lang="en-US" smtClean="0"/>
+              <a:rPr lang="en-US"/>
               <a:t>Second level</a:t>
             </a:r>
           </a:p>
           <a:p>
             <a:pPr lvl="2"/>
             <a:r>
-              <a:rPr lang="en-US" smtClean="0"/>
+              <a:rPr lang="en-US"/>
               <a:t>Third level</a:t>
             </a:r>
           </a:p>
           <a:p>
             <a:pPr lvl="3"/>
             <a:r>
-              <a:rPr lang="en-US" smtClean="0"/>
+              <a:rPr lang="en-US"/>
               <a:t>Fourth level</a:t>
             </a:r>
           </a:p>
           <a:p>
             <a:pPr lvl="4"/>
             <a:r>
-              <a:rPr lang="en-US" smtClean="0"/>
+              <a:rPr lang="en-US"/>
               <a:t>Fifth level</a:t>
             </a:r>
-            <a:endParaRPr lang="en-US"/>
           </a:p>
         </p:txBody>
       </p:sp>
@@ -831,7 +891,7 @@
           <a:p>
             <a:fld id="{5BCAD085-E8A6-8845-BD4E-CB4CCA059FC4}" type="datetimeFigureOut">
               <a:rPr lang="en-US" smtClean="0"/>
-              <a:t>1/27/13</a:t>
+              <a:t>20-Jul-26</a:t>
             </a:fld>
             <a:endParaRPr lang="en-US"/>
           </a:p>
@@ -934,10 +994,9 @@
           </a:lstStyle>
           <a:p>
             <a:r>
-              <a:rPr lang="en-US" smtClean="0"/>
+              <a:rPr lang="en-US"/>
               <a:t>Click to edit Master title style</a:t>
             </a:r>
-            <a:endParaRPr lang="en-US"/>
           </a:p>
         </p:txBody>
       </p:sp>
@@ -1054,7 +1113,7 @@
           <a:p>
             <a:pPr lvl="0"/>
             <a:r>
-              <a:rPr lang="en-US" smtClean="0"/>
+              <a:rPr lang="en-US"/>
               <a:t>Click to edit Master text styles</a:t>
             </a:r>
           </a:p>
@@ -1077,7 +1136,7 @@
           <a:p>
             <a:fld id="{5BCAD085-E8A6-8845-BD4E-CB4CCA059FC4}" type="datetimeFigureOut">
               <a:rPr lang="en-US" smtClean="0"/>
-              <a:t>1/27/13</a:t>
+              <a:t>20-Jul-26</a:t>
             </a:fld>
             <a:endParaRPr lang="en-US"/>
           </a:p>
@@ -1171,10 +1230,9 @@
           <a:lstStyle/>
           <a:p>
             <a:r>
-              <a:rPr lang="en-US" smtClean="0"/>
+              <a:rPr lang="en-US"/>
               <a:t>Click to edit Master title style</a:t>
             </a:r>
-            <a:endParaRPr lang="en-US"/>
           </a:p>
         </p:txBody>
       </p:sp>
@@ -1228,38 +1286,37 @@
           <a:p>
             <a:pPr lvl="0"/>
             <a:r>
-              <a:rPr lang="en-US" smtClean="0"/>
+              <a:rPr lang="en-US"/>
               <a:t>Click to edit Master text styles</a:t>
             </a:r>
           </a:p>
           <a:p>
             <a:pPr lvl="1"/>
             <a:r>
-              <a:rPr lang="en-US" smtClean="0"/>
+              <a:rPr lang="en-US"/>
               <a:t>Second level</a:t>
             </a:r>
           </a:p>
           <a:p>
             <a:pPr lvl="2"/>
             <a:r>
-              <a:rPr lang="en-US" smtClean="0"/>
+              <a:rPr lang="en-US"/>
               <a:t>Third level</a:t>
             </a:r>
           </a:p>
           <a:p>
             <a:pPr lvl="3"/>
             <a:r>
-              <a:rPr lang="en-US" smtClean="0"/>
+              <a:rPr lang="en-US"/>
               <a:t>Fourth level</a:t>
             </a:r>
           </a:p>
           <a:p>
             <a:pPr lvl="4"/>
             <a:r>
-              <a:rPr lang="en-US" smtClean="0"/>
+              <a:rPr lang="en-US"/>
               <a:t>Fifth level</a:t>
             </a:r>
-            <a:endParaRPr lang="en-US"/>
           </a:p>
         </p:txBody>
       </p:sp>
@@ -1313,38 +1370,37 @@
           <a:p>
             <a:pPr lvl="0"/>
             <a:r>
-              <a:rPr lang="en-US" smtClean="0"/>
+              <a:rPr lang="en-US"/>
               <a:t>Click to edit Master text styles</a:t>
             </a:r>
           </a:p>
           <a:p>
             <a:pPr lvl="1"/>
             <a:r>
-              <a:rPr lang="en-US" smtClean="0"/>
+              <a:rPr lang="en-US"/>
               <a:t>Second level</a:t>
             </a:r>
           </a:p>
           <a:p>
             <a:pPr lvl="2"/>
             <a:r>
-              <a:rPr lang="en-US" smtClean="0"/>
+              <a:rPr lang="en-US"/>
               <a:t>Third level</a:t>
             </a:r>
           </a:p>
           <a:p>
             <a:pPr lvl="3"/>
             <a:r>
-              <a:rPr lang="en-US" smtClean="0"/>
+              <a:rPr lang="en-US"/>
               <a:t>Fourth level</a:t>
             </a:r>
           </a:p>
           <a:p>
             <a:pPr lvl="4"/>
             <a:r>
-              <a:rPr lang="en-US" smtClean="0"/>
+              <a:rPr lang="en-US"/>
               <a:t>Fifth level</a:t>
             </a:r>
-            <a:endParaRPr lang="en-US"/>
           </a:p>
         </p:txBody>
       </p:sp>
@@ -1365,7 +1421,7 @@
           <a:p>
             <a:fld id="{5BCAD085-E8A6-8845-BD4E-CB4CCA059FC4}" type="datetimeFigureOut">
               <a:rPr lang="en-US" smtClean="0"/>
-              <a:t>1/27/13</a:t>
+              <a:t>20-Jul-26</a:t>
             </a:fld>
             <a:endParaRPr lang="en-US"/>
           </a:p>
@@ -1463,10 +1519,9 @@
           </a:lstStyle>
           <a:p>
             <a:r>
-              <a:rPr lang="en-US" smtClean="0"/>
+              <a:rPr lang="en-US"/>
               <a:t>Click to edit Master title style</a:t>
             </a:r>
-            <a:endParaRPr lang="en-US"/>
           </a:p>
         </p:txBody>
       </p:sp>
@@ -1529,7 +1584,7 @@
           <a:p>
             <a:pPr lvl="0"/>
             <a:r>
-              <a:rPr lang="en-US" smtClean="0"/>
+              <a:rPr lang="en-US"/>
               <a:t>Click to edit Master text styles</a:t>
             </a:r>
           </a:p>
@@ -1585,38 +1640,37 @@
           <a:p>
             <a:pPr lvl="0"/>
             <a:r>
-              <a:rPr lang="en-US" smtClean="0"/>
+              <a:rPr lang="en-US"/>
               <a:t>Click to edit Master text styles</a:t>
             </a:r>
           </a:p>
           <a:p>
             <a:pPr lvl="1"/>
             <a:r>
-              <a:rPr lang="en-US" smtClean="0"/>
+              <a:rPr lang="en-US"/>
               <a:t>Second level</a:t>
             </a:r>
           </a:p>
           <a:p>
             <a:pPr lvl="2"/>
             <a:r>
-              <a:rPr lang="en-US" smtClean="0"/>
+              <a:rPr lang="en-US"/>
               <a:t>Third level</a:t>
             </a:r>
           </a:p>
           <a:p>
             <a:pPr lvl="3"/>
             <a:r>
-              <a:rPr lang="en-US" smtClean="0"/>
+              <a:rPr lang="en-US"/>
               <a:t>Fourth level</a:t>
             </a:r>
           </a:p>
           <a:p>
             <a:pPr lvl="4"/>
             <a:r>
-              <a:rPr lang="en-US" smtClean="0"/>
+              <a:rPr lang="en-US"/>
               <a:t>Fifth level</a:t>
             </a:r>
-            <a:endParaRPr lang="en-US"/>
           </a:p>
         </p:txBody>
       </p:sp>
@@ -1679,7 +1733,7 @@
           <a:p>
             <a:pPr lvl="0"/>
             <a:r>
-              <a:rPr lang="en-US" smtClean="0"/>
+              <a:rPr lang="en-US"/>
               <a:t>Click to edit Master text styles</a:t>
             </a:r>
           </a:p>
@@ -1735,38 +1789,37 @@
           <a:p>
             <a:pPr lvl="0"/>
             <a:r>
-              <a:rPr lang="en-US" smtClean="0"/>
+              <a:rPr lang="en-US"/>
               <a:t>Click to edit Master text styles</a:t>
             </a:r>
           </a:p>
           <a:p>
             <a:pPr lvl="1"/>
             <a:r>
-              <a:rPr lang="en-US" smtClean="0"/>
+              <a:rPr lang="en-US"/>
               <a:t>Second level</a:t>
             </a:r>
           </a:p>
           <a:p>
             <a:pPr lvl="2"/>
             <a:r>
-              <a:rPr lang="en-US" smtClean="0"/>
+              <a:rPr lang="en-US"/>
               <a:t>Third level</a:t>
             </a:r>
           </a:p>
           <a:p>
             <a:pPr lvl="3"/>
             <a:r>
-              <a:rPr lang="en-US" smtClean="0"/>
+              <a:rPr lang="en-US"/>
               <a:t>Fourth level</a:t>
             </a:r>
           </a:p>
           <a:p>
             <a:pPr lvl="4"/>
             <a:r>
-              <a:rPr lang="en-US" smtClean="0"/>
+              <a:rPr lang="en-US"/>
               <a:t>Fifth level</a:t>
             </a:r>
-            <a:endParaRPr lang="en-US"/>
           </a:p>
         </p:txBody>
       </p:sp>
@@ -1787,7 +1840,7 @@
           <a:p>
             <a:fld id="{5BCAD085-E8A6-8845-BD4E-CB4CCA059FC4}" type="datetimeFigureOut">
               <a:rPr lang="en-US" smtClean="0"/>
-              <a:t>1/27/13</a:t>
+              <a:t>20-Jul-26</a:t>
             </a:fld>
             <a:endParaRPr lang="en-US"/>
           </a:p>
@@ -1881,10 +1934,9 @@
           <a:lstStyle/>
           <a:p>
             <a:r>
-              <a:rPr lang="en-US" smtClean="0"/>
+              <a:rPr lang="en-US"/>
               <a:t>Click to edit Master title style</a:t>
             </a:r>
-            <a:endParaRPr lang="en-US"/>
           </a:p>
         </p:txBody>
       </p:sp>
@@ -1905,7 +1957,7 @@
           <a:p>
             <a:fld id="{5BCAD085-E8A6-8845-BD4E-CB4CCA059FC4}" type="datetimeFigureOut">
               <a:rPr lang="en-US" smtClean="0"/>
-              <a:t>1/27/13</a:t>
+              <a:t>20-Jul-26</a:t>
             </a:fld>
             <a:endParaRPr lang="en-US"/>
           </a:p>
@@ -2000,7 +2052,7 @@
           <a:p>
             <a:fld id="{5BCAD085-E8A6-8845-BD4E-CB4CCA059FC4}" type="datetimeFigureOut">
               <a:rPr lang="en-US" smtClean="0"/>
-              <a:t>1/27/13</a:t>
+              <a:t>20-Jul-26</a:t>
             </a:fld>
             <a:endParaRPr lang="en-US"/>
           </a:p>
@@ -2103,10 +2155,9 @@
           </a:lstStyle>
           <a:p>
             <a:r>
-              <a:rPr lang="en-US" smtClean="0"/>
+              <a:rPr lang="en-US"/>
               <a:t>Click to edit Master title style</a:t>
             </a:r>
-            <a:endParaRPr lang="en-US"/>
           </a:p>
         </p:txBody>
       </p:sp>
@@ -2160,38 +2211,37 @@
           <a:p>
             <a:pPr lvl="0"/>
             <a:r>
-              <a:rPr lang="en-US" smtClean="0"/>
+              <a:rPr lang="en-US"/>
               <a:t>Click to edit Master text styles</a:t>
             </a:r>
           </a:p>
           <a:p>
             <a:pPr lvl="1"/>
             <a:r>
-              <a:rPr lang="en-US" smtClean="0"/>
+              <a:rPr lang="en-US"/>
               <a:t>Second level</a:t>
             </a:r>
           </a:p>
           <a:p>
             <a:pPr lvl="2"/>
             <a:r>
-              <a:rPr lang="en-US" smtClean="0"/>
+              <a:rPr lang="en-US"/>
               <a:t>Third level</a:t>
             </a:r>
           </a:p>
           <a:p>
             <a:pPr lvl="3"/>
             <a:r>
-              <a:rPr lang="en-US" smtClean="0"/>
+              <a:rPr lang="en-US"/>
               <a:t>Fourth level</a:t>
             </a:r>
           </a:p>
           <a:p>
             <a:pPr lvl="4"/>
             <a:r>
-              <a:rPr lang="en-US" smtClean="0"/>
+              <a:rPr lang="en-US"/>
               <a:t>Fifth level</a:t>
             </a:r>
-            <a:endParaRPr lang="en-US"/>
           </a:p>
         </p:txBody>
       </p:sp>
@@ -2254,7 +2304,7 @@
           <a:p>
             <a:pPr lvl="0"/>
             <a:r>
-              <a:rPr lang="en-US" smtClean="0"/>
+              <a:rPr lang="en-US"/>
               <a:t>Click to edit Master text styles</a:t>
             </a:r>
           </a:p>
@@ -2277,7 +2327,7 @@
           <a:p>
             <a:fld id="{5BCAD085-E8A6-8845-BD4E-CB4CCA059FC4}" type="datetimeFigureOut">
               <a:rPr lang="en-US" smtClean="0"/>
-              <a:t>1/27/13</a:t>
+              <a:t>20-Jul-26</a:t>
             </a:fld>
             <a:endParaRPr lang="en-US"/>
           </a:p>
@@ -2380,10 +2430,9 @@
           </a:lstStyle>
           <a:p>
             <a:r>
-              <a:rPr lang="en-US" smtClean="0"/>
+              <a:rPr lang="en-US"/>
               <a:t>Click to edit Master title style</a:t>
             </a:r>
-            <a:endParaRPr lang="en-US"/>
           </a:p>
         </p:txBody>
       </p:sp>
@@ -2507,7 +2556,7 @@
           <a:p>
             <a:pPr lvl="0"/>
             <a:r>
-              <a:rPr lang="en-US" smtClean="0"/>
+              <a:rPr lang="en-US"/>
               <a:t>Click to edit Master text styles</a:t>
             </a:r>
           </a:p>
@@ -2530,7 +2579,7 @@
           <a:p>
             <a:fld id="{5BCAD085-E8A6-8845-BD4E-CB4CCA059FC4}" type="datetimeFigureOut">
               <a:rPr lang="en-US" smtClean="0"/>
-              <a:t>1/27/13</a:t>
+              <a:t>20-Jul-26</a:t>
             </a:fld>
             <a:endParaRPr lang="en-US"/>
           </a:p>
@@ -2639,10 +2688,9 @@
           <a:lstStyle/>
           <a:p>
             <a:r>
-              <a:rPr lang="en-US" smtClean="0"/>
+              <a:rPr lang="en-US"/>
               <a:t>Click to edit Master title style</a:t>
             </a:r>
-            <a:endParaRPr lang="en-US"/>
           </a:p>
         </p:txBody>
       </p:sp>
@@ -2673,38 +2721,37 @@
           <a:p>
             <a:pPr lvl="0"/>
             <a:r>
-              <a:rPr lang="en-US" smtClean="0"/>
+              <a:rPr lang="en-US"/>
               <a:t>Click to edit Master text styles</a:t>
             </a:r>
           </a:p>
           <a:p>
             <a:pPr lvl="1"/>
             <a:r>
-              <a:rPr lang="en-US" smtClean="0"/>
+              <a:rPr lang="en-US"/>
               <a:t>Second level</a:t>
             </a:r>
           </a:p>
           <a:p>
             <a:pPr lvl="2"/>
             <a:r>
-              <a:rPr lang="en-US" smtClean="0"/>
+              <a:rPr lang="en-US"/>
               <a:t>Third level</a:t>
             </a:r>
           </a:p>
           <a:p>
             <a:pPr lvl="3"/>
             <a:r>
-              <a:rPr lang="en-US" smtClean="0"/>
+              <a:rPr lang="en-US"/>
               <a:t>Fourth level</a:t>
             </a:r>
           </a:p>
           <a:p>
             <a:pPr lvl="4"/>
             <a:r>
-              <a:rPr lang="en-US" smtClean="0"/>
+              <a:rPr lang="en-US"/>
               <a:t>Fifth level</a:t>
             </a:r>
-            <a:endParaRPr lang="en-US"/>
           </a:p>
         </p:txBody>
       </p:sp>
@@ -2743,7 +2790,7 @@
           <a:p>
             <a:fld id="{5BCAD085-E8A6-8845-BD4E-CB4CCA059FC4}" type="datetimeFigureOut">
               <a:rPr lang="en-US" smtClean="0"/>
-              <a:t>1/27/13</a:t>
+              <a:t>20-Jul-26</a:t>
             </a:fld>
             <a:endParaRPr lang="en-US"/>
           </a:p>
@@ -2824,6 +2871,54 @@
               <a:t>‹#›</a:t>
             </a:fld>
             <a:endParaRPr lang="en-US"/>
+          </a:p>
+        </p:txBody>
+      </p:sp>
+      <p:sp>
+        <p:nvSpPr>
+          <p:cNvPr id="8" name="TextBox 7">
+            <a:extLst>
+              <a:ext uri="{FF2B5EF4-FFF2-40B4-BE49-F238E27FC236}">
+                <a16:creationId xmlns:a16="http://schemas.microsoft.com/office/drawing/2014/main" id="{540451B9-7FC6-009F-AC3A-141E756A6DB2}"/>
+              </a:ext>
+            </a:extLst>
+          </p:cNvPr>
+          <p:cNvSpPr txBox="1"/>
+          <p:nvPr userDrawn="1">
+            <p:extLst>
+              <p:ext uri="{1162E1C5-73C7-4A58-AE30-91384D911F3F}">
+                <p184:classification xmlns:p184="http://schemas.microsoft.com/office/powerpoint/2018/4/main" val="hdr"/>
+              </p:ext>
+            </p:extLst>
+          </p:nvPr>
+        </p:nvSpPr>
+        <p:spPr>
+          <a:xfrm>
+            <a:off x="5518150" y="63500"/>
+            <a:ext cx="1181100" cy="152400"/>
+          </a:xfrm>
+          <a:prstGeom prst="rect">
+            <a:avLst/>
+          </a:prstGeom>
+        </p:spPr>
+        <p:txBody>
+          <a:bodyPr horzOverflow="overflow" lIns="0" tIns="0" rIns="0" bIns="0">
+            <a:spAutoFit/>
+          </a:bodyPr>
+          <a:lstStyle/>
+          <a:p>
+            <a:pPr algn="l"/>
+            <a:r>
+              <a:rPr lang="en-US" sz="1000">
+                <a:solidFill>
+                  <a:srgbClr val="0000FF">
+                    <a:alpha val="50000"/>
+                  </a:srgbClr>
+                </a:solidFill>
+                <a:latin typeface="Aptos" panose="020B0004020202020204" pitchFamily="34" charset="0"/>
+              </a:rPr>
+              <a:t>Classified as Internal</a:t>
+            </a:r>
           </a:p>
         </p:txBody>
       </p:sp>
@@ -3102,7 +3197,7 @@
 </file>
 
 <file path=ppt/slides/slide1.xml><?xml version="1.0" encoding="utf-8"?>
-<p:sld xmlns:a="http://schemas.openxmlformats.org/drawingml/2006/main" xmlns:p="http://schemas.openxmlformats.org/presentationml/2006/main" xmlns:r="http://schemas.openxmlformats.org/officeDocument/2006/relationships">
+<p:sld xmlns:a="http://schemas.openxmlformats.org/drawingml/2006/main" xmlns:r="http://schemas.openxmlformats.org/officeDocument/2006/relationships" xmlns:p="http://schemas.openxmlformats.org/presentationml/2006/main">
   <p:cSld>
     <p:spTree>
       <p:nvGrpSpPr>
@@ -3110,7 +3205,14 @@
         <p:cNvGrpSpPr/>
         <p:nvPr/>
       </p:nvGrpSpPr>
-      <p:grpSpPr/>
+      <p:grpSpPr>
+        <a:xfrm>
+          <a:off x="0" y="0"/>
+          <a:ext cx="0" cy="0"/>
+          <a:chOff x="0" y="0"/>
+          <a:chExt cx="0" cy="0"/>
+        </a:xfrm>
+      </p:grpSpPr>
       <p:sp>
         <p:nvSpPr>
           <p:cNvPr id="2" name="Rectangle 1"/>
@@ -3152,6 +3254,7 @@
           <a:lstStyle/>
           <a:p>
             <a:pPr algn="ctr"/>
+            <a:endParaRPr/>
           </a:p>
         </p:txBody>
       </p:sp>
@@ -3196,6 +3299,7 @@
           <a:lstStyle/>
           <a:p>
             <a:pPr algn="ctr"/>
+            <a:endParaRPr/>
           </a:p>
         </p:txBody>
       </p:sp>
@@ -3240,6 +3344,7 @@
           <a:lstStyle/>
           <a:p>
             <a:pPr algn="ctr"/>
+            <a:endParaRPr/>
           </a:p>
         </p:txBody>
       </p:sp>
@@ -3284,6 +3389,7 @@
           <a:lstStyle/>
           <a:p>
             <a:pPr algn="ctr"/>
+            <a:endParaRPr/>
           </a:p>
         </p:txBody>
       </p:sp>
@@ -3476,7 +3582,7 @@
 </file>
 
 <file path=ppt/slides/slide10.xml><?xml version="1.0" encoding="utf-8"?>
-<p:sld xmlns:a="http://schemas.openxmlformats.org/drawingml/2006/main" xmlns:p="http://schemas.openxmlformats.org/presentationml/2006/main" xmlns:r="http://schemas.openxmlformats.org/officeDocument/2006/relationships">
+<p:sld xmlns:a="http://schemas.openxmlformats.org/drawingml/2006/main" xmlns:r="http://schemas.openxmlformats.org/officeDocument/2006/relationships" xmlns:p="http://schemas.openxmlformats.org/presentationml/2006/main">
   <p:cSld>
     <p:spTree>
       <p:nvGrpSpPr>
@@ -3484,7 +3590,14 @@
         <p:cNvGrpSpPr/>
         <p:nvPr/>
       </p:nvGrpSpPr>
-      <p:grpSpPr/>
+      <p:grpSpPr>
+        <a:xfrm>
+          <a:off x="0" y="0"/>
+          <a:ext cx="0" cy="0"/>
+          <a:chOff x="0" y="0"/>
+          <a:chExt cx="0" cy="0"/>
+        </a:xfrm>
+      </p:grpSpPr>
       <p:sp>
         <p:nvSpPr>
           <p:cNvPr id="2" name="Rectangle 1"/>
@@ -3526,6 +3639,7 @@
           <a:lstStyle/>
           <a:p>
             <a:pPr algn="ctr"/>
+            <a:endParaRPr/>
           </a:p>
         </p:txBody>
       </p:sp>
@@ -3570,6 +3684,7 @@
           <a:lstStyle/>
           <a:p>
             <a:pPr algn="ctr"/>
+            <a:endParaRPr/>
           </a:p>
         </p:txBody>
       </p:sp>
@@ -3684,6 +3799,7 @@
           <a:lstStyle/>
           <a:p>
             <a:pPr algn="ctr"/>
+            <a:endParaRPr/>
           </a:p>
         </p:txBody>
       </p:sp>
@@ -3728,6 +3844,7 @@
           <a:lstStyle/>
           <a:p>
             <a:pPr algn="ctr"/>
+            <a:endParaRPr/>
           </a:p>
         </p:txBody>
       </p:sp>
@@ -3881,6 +3998,7 @@
           <a:lstStyle/>
           <a:p>
             <a:pPr algn="ctr"/>
+            <a:endParaRPr/>
           </a:p>
         </p:txBody>
       </p:sp>
@@ -4019,6 +4137,7 @@
           <a:lstStyle/>
           <a:p>
             <a:pPr algn="ctr"/>
+            <a:endParaRPr/>
           </a:p>
         </p:txBody>
       </p:sp>
@@ -4104,6 +4223,7 @@
           <a:lstStyle/>
           <a:p>
             <a:pPr algn="ctr"/>
+            <a:endParaRPr/>
           </a:p>
         </p:txBody>
       </p:sp>
@@ -4187,7 +4307,7 @@
 </file>
 
 <file path=ppt/slides/slide11.xml><?xml version="1.0" encoding="utf-8"?>
-<p:sld xmlns:a="http://schemas.openxmlformats.org/drawingml/2006/main" xmlns:p="http://schemas.openxmlformats.org/presentationml/2006/main" xmlns:r="http://schemas.openxmlformats.org/officeDocument/2006/relationships">
+<p:sld xmlns:a="http://schemas.openxmlformats.org/drawingml/2006/main" xmlns:r="http://schemas.openxmlformats.org/officeDocument/2006/relationships" xmlns:p="http://schemas.openxmlformats.org/presentationml/2006/main">
   <p:cSld>
     <p:spTree>
       <p:nvGrpSpPr>
@@ -4195,7 +4315,14 @@
         <p:cNvGrpSpPr/>
         <p:nvPr/>
       </p:nvGrpSpPr>
-      <p:grpSpPr/>
+      <p:grpSpPr>
+        <a:xfrm>
+          <a:off x="0" y="0"/>
+          <a:ext cx="0" cy="0"/>
+          <a:chOff x="0" y="0"/>
+          <a:chExt cx="0" cy="0"/>
+        </a:xfrm>
+      </p:grpSpPr>
       <p:sp>
         <p:nvSpPr>
           <p:cNvPr id="2" name="Rectangle 1"/>
@@ -4237,6 +4364,7 @@
           <a:lstStyle/>
           <a:p>
             <a:pPr algn="ctr"/>
+            <a:endParaRPr/>
           </a:p>
         </p:txBody>
       </p:sp>
@@ -4281,6 +4409,7 @@
           <a:lstStyle/>
           <a:p>
             <a:pPr algn="ctr"/>
+            <a:endParaRPr/>
           </a:p>
         </p:txBody>
       </p:sp>
@@ -4395,6 +4524,7 @@
           <a:lstStyle/>
           <a:p>
             <a:pPr algn="ctr"/>
+            <a:endParaRPr/>
           </a:p>
         </p:txBody>
       </p:sp>
@@ -4439,6 +4569,7 @@
           <a:lstStyle/>
           <a:p>
             <a:pPr algn="ctr"/>
+            <a:endParaRPr/>
           </a:p>
         </p:txBody>
       </p:sp>
@@ -4592,6 +4723,7 @@
           <a:lstStyle/>
           <a:p>
             <a:pPr algn="ctr"/>
+            <a:endParaRPr/>
           </a:p>
         </p:txBody>
       </p:sp>
@@ -4665,15 +4797,27 @@
         <a:graphic>
           <a:graphicData uri="http://schemas.openxmlformats.org/drawingml/2006/table">
             <a:tbl>
-              <a:tblPr firstRow="0" bandRow="0"/>
+              <a:tblPr/>
               <a:tblGrid>
-                <a:gridCol w="3120390"/>
-                <a:gridCol w="1040130"/>
+                <a:gridCol w="3120390">
+                  <a:extLst>
+                    <a:ext uri="{9D8B030D-6E8A-4147-A177-3AD203B41FA5}">
+                      <a16:colId xmlns:a16="http://schemas.microsoft.com/office/drawing/2014/main" val="20000"/>
+                    </a:ext>
+                  </a:extLst>
+                </a:gridCol>
+                <a:gridCol w="1040130">
+                  <a:extLst>
+                    <a:ext uri="{9D8B030D-6E8A-4147-A177-3AD203B41FA5}">
+                      <a16:colId xmlns:a16="http://schemas.microsoft.com/office/drawing/2014/main" val="20001"/>
+                    </a:ext>
+                  </a:extLst>
+                </a:gridCol>
               </a:tblGrid>
               <a:tr h="329184">
                 <a:tc>
                   <a:txBody>
-                    <a:bodyPr wrap="square"/>
+                    <a:bodyPr/>
                     <a:lstStyle/>
                     <a:p>
                       <a:pPr algn="l"/>
@@ -4696,7 +4840,7 @@
                 </a:tc>
                 <a:tc>
                   <a:txBody>
-                    <a:bodyPr wrap="square"/>
+                    <a:bodyPr/>
                     <a:lstStyle/>
                     <a:p>
                       <a:pPr algn="ctr"/>
@@ -4717,11 +4861,16 @@
                     </a:solidFill>
                   </a:tcPr>
                 </a:tc>
+                <a:extLst>
+                  <a:ext uri="{0D108BD9-81ED-4DB2-BD59-A6C34878D82A}">
+                    <a16:rowId xmlns:a16="http://schemas.microsoft.com/office/drawing/2014/main" val="10000"/>
+                  </a:ext>
+                </a:extLst>
               </a:tr>
               <a:tr h="329184">
                 <a:tc>
                   <a:txBody>
-                    <a:bodyPr wrap="square"/>
+                    <a:bodyPr/>
                     <a:lstStyle/>
                     <a:p>
                       <a:pPr algn="l"/>
@@ -4744,7 +4893,7 @@
                 </a:tc>
                 <a:tc>
                   <a:txBody>
-                    <a:bodyPr wrap="square"/>
+                    <a:bodyPr/>
                     <a:lstStyle/>
                     <a:p>
                       <a:pPr algn="ctr"/>
@@ -4765,11 +4914,16 @@
                     </a:solidFill>
                   </a:tcPr>
                 </a:tc>
+                <a:extLst>
+                  <a:ext uri="{0D108BD9-81ED-4DB2-BD59-A6C34878D82A}">
+                    <a16:rowId xmlns:a16="http://schemas.microsoft.com/office/drawing/2014/main" val="10001"/>
+                  </a:ext>
+                </a:extLst>
               </a:tr>
               <a:tr h="329184">
                 <a:tc>
                   <a:txBody>
-                    <a:bodyPr wrap="square"/>
+                    <a:bodyPr/>
                     <a:lstStyle/>
                     <a:p>
                       <a:pPr algn="l"/>
@@ -4792,7 +4946,7 @@
                 </a:tc>
                 <a:tc>
                   <a:txBody>
-                    <a:bodyPr wrap="square"/>
+                    <a:bodyPr/>
                     <a:lstStyle/>
                     <a:p>
                       <a:pPr algn="ctr"/>
@@ -4813,11 +4967,16 @@
                     </a:solidFill>
                   </a:tcPr>
                 </a:tc>
+                <a:extLst>
+                  <a:ext uri="{0D108BD9-81ED-4DB2-BD59-A6C34878D82A}">
+                    <a16:rowId xmlns:a16="http://schemas.microsoft.com/office/drawing/2014/main" val="10002"/>
+                  </a:ext>
+                </a:extLst>
               </a:tr>
               <a:tr h="329184">
                 <a:tc>
                   <a:txBody>
-                    <a:bodyPr wrap="square"/>
+                    <a:bodyPr/>
                     <a:lstStyle/>
                     <a:p>
                       <a:pPr algn="l"/>
@@ -4840,7 +4999,7 @@
                 </a:tc>
                 <a:tc>
                   <a:txBody>
-                    <a:bodyPr wrap="square"/>
+                    <a:bodyPr/>
                     <a:lstStyle/>
                     <a:p>
                       <a:pPr algn="ctr"/>
@@ -4861,11 +5020,16 @@
                     </a:solidFill>
                   </a:tcPr>
                 </a:tc>
+                <a:extLst>
+                  <a:ext uri="{0D108BD9-81ED-4DB2-BD59-A6C34878D82A}">
+                    <a16:rowId xmlns:a16="http://schemas.microsoft.com/office/drawing/2014/main" val="10003"/>
+                  </a:ext>
+                </a:extLst>
               </a:tr>
               <a:tr h="329184">
                 <a:tc>
                   <a:txBody>
-                    <a:bodyPr wrap="square"/>
+                    <a:bodyPr/>
                     <a:lstStyle/>
                     <a:p>
                       <a:pPr algn="l"/>
@@ -4888,7 +5052,7 @@
                 </a:tc>
                 <a:tc>
                   <a:txBody>
-                    <a:bodyPr wrap="square"/>
+                    <a:bodyPr/>
                     <a:lstStyle/>
                     <a:p>
                       <a:pPr algn="ctr"/>
@@ -4909,11 +5073,16 @@
                     </a:solidFill>
                   </a:tcPr>
                 </a:tc>
+                <a:extLst>
+                  <a:ext uri="{0D108BD9-81ED-4DB2-BD59-A6C34878D82A}">
+                    <a16:rowId xmlns:a16="http://schemas.microsoft.com/office/drawing/2014/main" val="10004"/>
+                  </a:ext>
+                </a:extLst>
               </a:tr>
               <a:tr h="329184">
                 <a:tc>
                   <a:txBody>
-                    <a:bodyPr wrap="square"/>
+                    <a:bodyPr/>
                     <a:lstStyle/>
                     <a:p>
                       <a:pPr algn="l"/>
@@ -4936,7 +5105,7 @@
                 </a:tc>
                 <a:tc>
                   <a:txBody>
-                    <a:bodyPr wrap="square"/>
+                    <a:bodyPr/>
                     <a:lstStyle/>
                     <a:p>
                       <a:pPr algn="ctr"/>
@@ -4957,6 +5126,11 @@
                     </a:solidFill>
                   </a:tcPr>
                 </a:tc>
+                <a:extLst>
+                  <a:ext uri="{0D108BD9-81ED-4DB2-BD59-A6C34878D82A}">
+                    <a16:rowId xmlns:a16="http://schemas.microsoft.com/office/drawing/2014/main" val="10005"/>
+                  </a:ext>
+                </a:extLst>
               </a:tr>
             </a:tbl>
           </a:graphicData>
@@ -5042,6 +5216,7 @@
           <a:lstStyle/>
           <a:p>
             <a:pPr algn="ctr"/>
+            <a:endParaRPr/>
           </a:p>
         </p:txBody>
       </p:sp>
@@ -5157,7 +5332,7 @@
 </file>
 
 <file path=ppt/slides/slide12.xml><?xml version="1.0" encoding="utf-8"?>
-<p:sld xmlns:a="http://schemas.openxmlformats.org/drawingml/2006/main" xmlns:p="http://schemas.openxmlformats.org/presentationml/2006/main" xmlns:r="http://schemas.openxmlformats.org/officeDocument/2006/relationships">
+<p:sld xmlns:a="http://schemas.openxmlformats.org/drawingml/2006/main" xmlns:r="http://schemas.openxmlformats.org/officeDocument/2006/relationships" xmlns:p="http://schemas.openxmlformats.org/presentationml/2006/main">
   <p:cSld>
     <p:spTree>
       <p:nvGrpSpPr>
@@ -5165,7 +5340,14 @@
         <p:cNvGrpSpPr/>
         <p:nvPr/>
       </p:nvGrpSpPr>
-      <p:grpSpPr/>
+      <p:grpSpPr>
+        <a:xfrm>
+          <a:off x="0" y="0"/>
+          <a:ext cx="0" cy="0"/>
+          <a:chOff x="0" y="0"/>
+          <a:chExt cx="0" cy="0"/>
+        </a:xfrm>
+      </p:grpSpPr>
       <p:sp>
         <p:nvSpPr>
           <p:cNvPr id="2" name="Rectangle 1"/>
@@ -5207,6 +5389,7 @@
           <a:lstStyle/>
           <a:p>
             <a:pPr algn="ctr"/>
+            <a:endParaRPr/>
           </a:p>
         </p:txBody>
       </p:sp>
@@ -5251,6 +5434,7 @@
           <a:lstStyle/>
           <a:p>
             <a:pPr algn="ctr"/>
+            <a:endParaRPr/>
           </a:p>
         </p:txBody>
       </p:sp>
@@ -5365,6 +5549,7 @@
           <a:lstStyle/>
           <a:p>
             <a:pPr algn="ctr"/>
+            <a:endParaRPr/>
           </a:p>
         </p:txBody>
       </p:sp>
@@ -5409,6 +5594,7 @@
           <a:lstStyle/>
           <a:p>
             <a:pPr algn="ctr"/>
+            <a:endParaRPr/>
           </a:p>
         </p:txBody>
       </p:sp>
@@ -5527,6 +5713,7 @@
           <a:lstStyle/>
           <a:p>
             <a:pPr algn="ctr"/>
+            <a:endParaRPr/>
           </a:p>
         </p:txBody>
       </p:sp>
@@ -5630,6 +5817,7 @@
           <a:lstStyle/>
           <a:p>
             <a:pPr algn="ctr"/>
+            <a:endParaRPr/>
           </a:p>
         </p:txBody>
       </p:sp>
@@ -5770,7 +5958,7 @@
 </file>
 
 <file path=ppt/slides/slide13.xml><?xml version="1.0" encoding="utf-8"?>
-<p:sld xmlns:a="http://schemas.openxmlformats.org/drawingml/2006/main" xmlns:p="http://schemas.openxmlformats.org/presentationml/2006/main" xmlns:r="http://schemas.openxmlformats.org/officeDocument/2006/relationships">
+<p:sld xmlns:a="http://schemas.openxmlformats.org/drawingml/2006/main" xmlns:r="http://schemas.openxmlformats.org/officeDocument/2006/relationships" xmlns:p="http://schemas.openxmlformats.org/presentationml/2006/main">
   <p:cSld>
     <p:spTree>
       <p:nvGrpSpPr>
@@ -5778,7 +5966,14 @@
         <p:cNvGrpSpPr/>
         <p:nvPr/>
       </p:nvGrpSpPr>
-      <p:grpSpPr/>
+      <p:grpSpPr>
+        <a:xfrm>
+          <a:off x="0" y="0"/>
+          <a:ext cx="0" cy="0"/>
+          <a:chOff x="0" y="0"/>
+          <a:chExt cx="0" cy="0"/>
+        </a:xfrm>
+      </p:grpSpPr>
       <p:sp>
         <p:nvSpPr>
           <p:cNvPr id="2" name="Rectangle 1"/>
@@ -5820,6 +6015,7 @@
           <a:lstStyle/>
           <a:p>
             <a:pPr algn="ctr"/>
+            <a:endParaRPr/>
           </a:p>
         </p:txBody>
       </p:sp>
@@ -5864,6 +6060,7 @@
           <a:lstStyle/>
           <a:p>
             <a:pPr algn="ctr"/>
+            <a:endParaRPr/>
           </a:p>
         </p:txBody>
       </p:sp>
@@ -5908,6 +6105,7 @@
           <a:lstStyle/>
           <a:p>
             <a:pPr algn="ctr"/>
+            <a:endParaRPr/>
           </a:p>
         </p:txBody>
       </p:sp>
@@ -6025,7 +6223,7 @@
 </file>
 
 <file path=ppt/slides/slide14.xml><?xml version="1.0" encoding="utf-8"?>
-<p:sld xmlns:a="http://schemas.openxmlformats.org/drawingml/2006/main" xmlns:p="http://schemas.openxmlformats.org/presentationml/2006/main" xmlns:r="http://schemas.openxmlformats.org/officeDocument/2006/relationships">
+<p:sld xmlns:a="http://schemas.openxmlformats.org/drawingml/2006/main" xmlns:r="http://schemas.openxmlformats.org/officeDocument/2006/relationships" xmlns:p="http://schemas.openxmlformats.org/presentationml/2006/main">
   <p:cSld>
     <p:spTree>
       <p:nvGrpSpPr>
@@ -6033,7 +6231,14 @@
         <p:cNvGrpSpPr/>
         <p:nvPr/>
       </p:nvGrpSpPr>
-      <p:grpSpPr/>
+      <p:grpSpPr>
+        <a:xfrm>
+          <a:off x="0" y="0"/>
+          <a:ext cx="0" cy="0"/>
+          <a:chOff x="0" y="0"/>
+          <a:chExt cx="0" cy="0"/>
+        </a:xfrm>
+      </p:grpSpPr>
       <p:sp>
         <p:nvSpPr>
           <p:cNvPr id="2" name="Rectangle 1"/>
@@ -6075,6 +6280,7 @@
           <a:lstStyle/>
           <a:p>
             <a:pPr algn="ctr"/>
+            <a:endParaRPr/>
           </a:p>
         </p:txBody>
       </p:sp>
@@ -6119,6 +6325,7 @@
           <a:lstStyle/>
           <a:p>
             <a:pPr algn="ctr"/>
+            <a:endParaRPr/>
           </a:p>
         </p:txBody>
       </p:sp>
@@ -6233,6 +6440,7 @@
           <a:lstStyle/>
           <a:p>
             <a:pPr algn="ctr"/>
+            <a:endParaRPr/>
           </a:p>
         </p:txBody>
       </p:sp>
@@ -6277,6 +6485,7 @@
           <a:lstStyle/>
           <a:p>
             <a:pPr algn="ctr"/>
+            <a:endParaRPr/>
           </a:p>
         </p:txBody>
       </p:sp>
@@ -6641,6 +6850,7 @@
           <a:lstStyle/>
           <a:p>
             <a:pPr algn="ctr"/>
+            <a:endParaRPr/>
           </a:p>
         </p:txBody>
       </p:sp>
@@ -6786,7 +6996,7 @@
 </file>
 
 <file path=ppt/slides/slide15.xml><?xml version="1.0" encoding="utf-8"?>
-<p:sld xmlns:a="http://schemas.openxmlformats.org/drawingml/2006/main" xmlns:p="http://schemas.openxmlformats.org/presentationml/2006/main" xmlns:r="http://schemas.openxmlformats.org/officeDocument/2006/relationships">
+<p:sld xmlns:a="http://schemas.openxmlformats.org/drawingml/2006/main" xmlns:r="http://schemas.openxmlformats.org/officeDocument/2006/relationships" xmlns:p="http://schemas.openxmlformats.org/presentationml/2006/main">
   <p:cSld>
     <p:spTree>
       <p:nvGrpSpPr>
@@ -6794,7 +7004,14 @@
         <p:cNvGrpSpPr/>
         <p:nvPr/>
       </p:nvGrpSpPr>
-      <p:grpSpPr/>
+      <p:grpSpPr>
+        <a:xfrm>
+          <a:off x="0" y="0"/>
+          <a:ext cx="0" cy="0"/>
+          <a:chOff x="0" y="0"/>
+          <a:chExt cx="0" cy="0"/>
+        </a:xfrm>
+      </p:grpSpPr>
       <p:sp>
         <p:nvSpPr>
           <p:cNvPr id="2" name="Rectangle 1"/>
@@ -6836,6 +7053,7 @@
           <a:lstStyle/>
           <a:p>
             <a:pPr algn="ctr"/>
+            <a:endParaRPr/>
           </a:p>
         </p:txBody>
       </p:sp>
@@ -6880,6 +7098,7 @@
           <a:lstStyle/>
           <a:p>
             <a:pPr algn="ctr"/>
+            <a:endParaRPr/>
           </a:p>
         </p:txBody>
       </p:sp>
@@ -6994,6 +7213,7 @@
           <a:lstStyle/>
           <a:p>
             <a:pPr algn="ctr"/>
+            <a:endParaRPr/>
           </a:p>
         </p:txBody>
       </p:sp>
@@ -7038,6 +7258,7 @@
           <a:lstStyle/>
           <a:p>
             <a:pPr algn="ctr"/>
+            <a:endParaRPr/>
           </a:p>
         </p:txBody>
       </p:sp>
@@ -7156,6 +7377,7 @@
           <a:lstStyle/>
           <a:p>
             <a:pPr algn="ctr"/>
+            <a:endParaRPr/>
           </a:p>
         </p:txBody>
       </p:sp>
@@ -7383,6 +7605,7 @@
           <a:lstStyle/>
           <a:p>
             <a:pPr algn="ctr"/>
+            <a:endParaRPr/>
           </a:p>
         </p:txBody>
       </p:sp>
@@ -7466,7 +7689,7 @@
 </file>
 
 <file path=ppt/slides/slide16.xml><?xml version="1.0" encoding="utf-8"?>
-<p:sld xmlns:a="http://schemas.openxmlformats.org/drawingml/2006/main" xmlns:p="http://schemas.openxmlformats.org/presentationml/2006/main" xmlns:r="http://schemas.openxmlformats.org/officeDocument/2006/relationships">
+<p:sld xmlns:a="http://schemas.openxmlformats.org/drawingml/2006/main" xmlns:r="http://schemas.openxmlformats.org/officeDocument/2006/relationships" xmlns:p="http://schemas.openxmlformats.org/presentationml/2006/main">
   <p:cSld>
     <p:spTree>
       <p:nvGrpSpPr>
@@ -7474,7 +7697,14 @@
         <p:cNvGrpSpPr/>
         <p:nvPr/>
       </p:nvGrpSpPr>
-      <p:grpSpPr/>
+      <p:grpSpPr>
+        <a:xfrm>
+          <a:off x="0" y="0"/>
+          <a:ext cx="0" cy="0"/>
+          <a:chOff x="0" y="0"/>
+          <a:chExt cx="0" cy="0"/>
+        </a:xfrm>
+      </p:grpSpPr>
       <p:sp>
         <p:nvSpPr>
           <p:cNvPr id="2" name="Rectangle 1"/>
@@ -7516,6 +7746,7 @@
           <a:lstStyle/>
           <a:p>
             <a:pPr algn="ctr"/>
+            <a:endParaRPr/>
           </a:p>
         </p:txBody>
       </p:sp>
@@ -7560,6 +7791,7 @@
           <a:lstStyle/>
           <a:p>
             <a:pPr algn="ctr"/>
+            <a:endParaRPr/>
           </a:p>
         </p:txBody>
       </p:sp>
@@ -7674,6 +7906,7 @@
           <a:lstStyle/>
           <a:p>
             <a:pPr algn="ctr"/>
+            <a:endParaRPr/>
           </a:p>
         </p:txBody>
       </p:sp>
@@ -7718,6 +7951,7 @@
           <a:lstStyle/>
           <a:p>
             <a:pPr algn="ctr"/>
+            <a:endParaRPr/>
           </a:p>
         </p:txBody>
       </p:sp>
@@ -7806,15 +8040,27 @@
         <a:graphic>
           <a:graphicData uri="http://schemas.openxmlformats.org/drawingml/2006/table">
             <a:tbl>
-              <a:tblPr firstRow="0" bandRow="0"/>
+              <a:tblPr/>
               <a:tblGrid>
-                <a:gridCol w="4568267"/>
-                <a:gridCol w="2015412"/>
+                <a:gridCol w="4568267">
+                  <a:extLst>
+                    <a:ext uri="{9D8B030D-6E8A-4147-A177-3AD203B41FA5}">
+                      <a16:colId xmlns:a16="http://schemas.microsoft.com/office/drawing/2014/main" val="20000"/>
+                    </a:ext>
+                  </a:extLst>
+                </a:gridCol>
+                <a:gridCol w="2015412">
+                  <a:extLst>
+                    <a:ext uri="{9D8B030D-6E8A-4147-A177-3AD203B41FA5}">
+                      <a16:colId xmlns:a16="http://schemas.microsoft.com/office/drawing/2014/main" val="20001"/>
+                    </a:ext>
+                  </a:extLst>
+                </a:gridCol>
               </a:tblGrid>
               <a:tr h="402336">
                 <a:tc>
                   <a:txBody>
-                    <a:bodyPr wrap="square"/>
+                    <a:bodyPr/>
                     <a:lstStyle/>
                     <a:p>
                       <a:pPr algn="l"/>
@@ -7837,7 +8083,7 @@
                 </a:tc>
                 <a:tc>
                   <a:txBody>
-                    <a:bodyPr wrap="square"/>
+                    <a:bodyPr/>
                     <a:lstStyle/>
                     <a:p>
                       <a:pPr algn="ctr"/>
@@ -7858,11 +8104,16 @@
                     </a:solidFill>
                   </a:tcPr>
                 </a:tc>
+                <a:extLst>
+                  <a:ext uri="{0D108BD9-81ED-4DB2-BD59-A6C34878D82A}">
+                    <a16:rowId xmlns:a16="http://schemas.microsoft.com/office/drawing/2014/main" val="10000"/>
+                  </a:ext>
+                </a:extLst>
               </a:tr>
               <a:tr h="402336">
                 <a:tc>
                   <a:txBody>
-                    <a:bodyPr wrap="square"/>
+                    <a:bodyPr/>
                     <a:lstStyle/>
                     <a:p>
                       <a:pPr algn="l"/>
@@ -7885,7 +8136,7 @@
                 </a:tc>
                 <a:tc>
                   <a:txBody>
-                    <a:bodyPr wrap="square"/>
+                    <a:bodyPr/>
                     <a:lstStyle/>
                     <a:p>
                       <a:pPr algn="ctr"/>
@@ -7906,11 +8157,16 @@
                     </a:solidFill>
                   </a:tcPr>
                 </a:tc>
+                <a:extLst>
+                  <a:ext uri="{0D108BD9-81ED-4DB2-BD59-A6C34878D82A}">
+                    <a16:rowId xmlns:a16="http://schemas.microsoft.com/office/drawing/2014/main" val="10001"/>
+                  </a:ext>
+                </a:extLst>
               </a:tr>
               <a:tr h="402336">
                 <a:tc>
                   <a:txBody>
-                    <a:bodyPr wrap="square"/>
+                    <a:bodyPr/>
                     <a:lstStyle/>
                     <a:p>
                       <a:pPr algn="l"/>
@@ -7933,7 +8189,7 @@
                 </a:tc>
                 <a:tc>
                   <a:txBody>
-                    <a:bodyPr wrap="square"/>
+                    <a:bodyPr/>
                     <a:lstStyle/>
                     <a:p>
                       <a:pPr algn="ctr"/>
@@ -7954,11 +8210,16 @@
                     </a:solidFill>
                   </a:tcPr>
                 </a:tc>
+                <a:extLst>
+                  <a:ext uri="{0D108BD9-81ED-4DB2-BD59-A6C34878D82A}">
+                    <a16:rowId xmlns:a16="http://schemas.microsoft.com/office/drawing/2014/main" val="10002"/>
+                  </a:ext>
+                </a:extLst>
               </a:tr>
               <a:tr h="402336">
                 <a:tc>
                   <a:txBody>
-                    <a:bodyPr wrap="square"/>
+                    <a:bodyPr/>
                     <a:lstStyle/>
                     <a:p>
                       <a:pPr algn="l"/>
@@ -7981,7 +8242,7 @@
                 </a:tc>
                 <a:tc>
                   <a:txBody>
-                    <a:bodyPr wrap="square"/>
+                    <a:bodyPr/>
                     <a:lstStyle/>
                     <a:p>
                       <a:pPr algn="ctr"/>
@@ -8002,11 +8263,16 @@
                     </a:solidFill>
                   </a:tcPr>
                 </a:tc>
+                <a:extLst>
+                  <a:ext uri="{0D108BD9-81ED-4DB2-BD59-A6C34878D82A}">
+                    <a16:rowId xmlns:a16="http://schemas.microsoft.com/office/drawing/2014/main" val="10003"/>
+                  </a:ext>
+                </a:extLst>
               </a:tr>
               <a:tr h="402336">
                 <a:tc>
                   <a:txBody>
-                    <a:bodyPr wrap="square"/>
+                    <a:bodyPr/>
                     <a:lstStyle/>
                     <a:p>
                       <a:pPr algn="l"/>
@@ -8029,7 +8295,7 @@
                 </a:tc>
                 <a:tc>
                   <a:txBody>
-                    <a:bodyPr wrap="square"/>
+                    <a:bodyPr/>
                     <a:lstStyle/>
                     <a:p>
                       <a:pPr algn="ctr"/>
@@ -8050,11 +8316,16 @@
                     </a:solidFill>
                   </a:tcPr>
                 </a:tc>
+                <a:extLst>
+                  <a:ext uri="{0D108BD9-81ED-4DB2-BD59-A6C34878D82A}">
+                    <a16:rowId xmlns:a16="http://schemas.microsoft.com/office/drawing/2014/main" val="10004"/>
+                  </a:ext>
+                </a:extLst>
               </a:tr>
               <a:tr h="402336">
                 <a:tc>
                   <a:txBody>
-                    <a:bodyPr wrap="square"/>
+                    <a:bodyPr/>
                     <a:lstStyle/>
                     <a:p>
                       <a:pPr algn="l"/>
@@ -8077,7 +8348,7 @@
                 </a:tc>
                 <a:tc>
                   <a:txBody>
-                    <a:bodyPr wrap="square"/>
+                    <a:bodyPr/>
                     <a:lstStyle/>
                     <a:p>
                       <a:pPr algn="ctr"/>
@@ -8098,11 +8369,16 @@
                     </a:solidFill>
                   </a:tcPr>
                 </a:tc>
+                <a:extLst>
+                  <a:ext uri="{0D108BD9-81ED-4DB2-BD59-A6C34878D82A}">
+                    <a16:rowId xmlns:a16="http://schemas.microsoft.com/office/drawing/2014/main" val="10005"/>
+                  </a:ext>
+                </a:extLst>
               </a:tr>
               <a:tr h="402336">
                 <a:tc>
                   <a:txBody>
-                    <a:bodyPr wrap="square"/>
+                    <a:bodyPr/>
                     <a:lstStyle/>
                     <a:p>
                       <a:pPr algn="l"/>
@@ -8125,7 +8401,7 @@
                 </a:tc>
                 <a:tc>
                   <a:txBody>
-                    <a:bodyPr wrap="square"/>
+                    <a:bodyPr/>
                     <a:lstStyle/>
                     <a:p>
                       <a:pPr algn="ctr"/>
@@ -8146,11 +8422,16 @@
                     </a:solidFill>
                   </a:tcPr>
                 </a:tc>
+                <a:extLst>
+                  <a:ext uri="{0D108BD9-81ED-4DB2-BD59-A6C34878D82A}">
+                    <a16:rowId xmlns:a16="http://schemas.microsoft.com/office/drawing/2014/main" val="10006"/>
+                  </a:ext>
+                </a:extLst>
               </a:tr>
               <a:tr h="402336">
                 <a:tc>
                   <a:txBody>
-                    <a:bodyPr wrap="square"/>
+                    <a:bodyPr/>
                     <a:lstStyle/>
                     <a:p>
                       <a:pPr algn="l"/>
@@ -8173,7 +8454,7 @@
                 </a:tc>
                 <a:tc>
                   <a:txBody>
-                    <a:bodyPr wrap="square"/>
+                    <a:bodyPr/>
                     <a:lstStyle/>
                     <a:p>
                       <a:pPr algn="ctr"/>
@@ -8194,6 +8475,11 @@
                     </a:solidFill>
                   </a:tcPr>
                 </a:tc>
+                <a:extLst>
+                  <a:ext uri="{0D108BD9-81ED-4DB2-BD59-A6C34878D82A}">
+                    <a16:rowId xmlns:a16="http://schemas.microsoft.com/office/drawing/2014/main" val="10007"/>
+                  </a:ext>
+                </a:extLst>
               </a:tr>
             </a:tbl>
           </a:graphicData>
@@ -8244,6 +8530,7 @@
           <a:lstStyle/>
           <a:p>
             <a:pPr algn="ctr"/>
+            <a:endParaRPr/>
           </a:p>
         </p:txBody>
       </p:sp>
@@ -8410,7 +8697,7 @@
 </file>
 
 <file path=ppt/slides/slide17.xml><?xml version="1.0" encoding="utf-8"?>
-<p:sld xmlns:a="http://schemas.openxmlformats.org/drawingml/2006/main" xmlns:p="http://schemas.openxmlformats.org/presentationml/2006/main" xmlns:r="http://schemas.openxmlformats.org/officeDocument/2006/relationships">
+<p:sld xmlns:a="http://schemas.openxmlformats.org/drawingml/2006/main" xmlns:r="http://schemas.openxmlformats.org/officeDocument/2006/relationships" xmlns:p="http://schemas.openxmlformats.org/presentationml/2006/main">
   <p:cSld>
     <p:spTree>
       <p:nvGrpSpPr>
@@ -8418,7 +8705,14 @@
         <p:cNvGrpSpPr/>
         <p:nvPr/>
       </p:nvGrpSpPr>
-      <p:grpSpPr/>
+      <p:grpSpPr>
+        <a:xfrm>
+          <a:off x="0" y="0"/>
+          <a:ext cx="0" cy="0"/>
+          <a:chOff x="0" y="0"/>
+          <a:chExt cx="0" cy="0"/>
+        </a:xfrm>
+      </p:grpSpPr>
       <p:sp>
         <p:nvSpPr>
           <p:cNvPr id="2" name="Rectangle 1"/>
@@ -8460,6 +8754,7 @@
           <a:lstStyle/>
           <a:p>
             <a:pPr algn="ctr"/>
+            <a:endParaRPr/>
           </a:p>
         </p:txBody>
       </p:sp>
@@ -8504,6 +8799,7 @@
           <a:lstStyle/>
           <a:p>
             <a:pPr algn="ctr"/>
+            <a:endParaRPr/>
           </a:p>
         </p:txBody>
       </p:sp>
@@ -8618,6 +8914,7 @@
           <a:lstStyle/>
           <a:p>
             <a:pPr algn="ctr"/>
+            <a:endParaRPr/>
           </a:p>
         </p:txBody>
       </p:sp>
@@ -8662,6 +8959,7 @@
           <a:lstStyle/>
           <a:p>
             <a:pPr algn="ctr"/>
+            <a:endParaRPr/>
           </a:p>
         </p:txBody>
       </p:sp>
@@ -8815,6 +9113,7 @@
           <a:lstStyle/>
           <a:p>
             <a:pPr algn="ctr"/>
+            <a:endParaRPr/>
           </a:p>
         </p:txBody>
       </p:sp>
@@ -8937,6 +9236,7 @@
           <a:lstStyle/>
           <a:p>
             <a:pPr algn="ctr"/>
+            <a:endParaRPr/>
           </a:p>
         </p:txBody>
       </p:sp>
@@ -9029,15 +9329,27 @@
         <a:graphic>
           <a:graphicData uri="http://schemas.openxmlformats.org/drawingml/2006/table">
             <a:tbl>
-              <a:tblPr firstRow="0" bandRow="0"/>
+              <a:tblPr/>
               <a:tblGrid>
-                <a:gridCol w="2427889"/>
-                <a:gridCol w="3972910"/>
+                <a:gridCol w="2427889">
+                  <a:extLst>
+                    <a:ext uri="{9D8B030D-6E8A-4147-A177-3AD203B41FA5}">
+                      <a16:colId xmlns:a16="http://schemas.microsoft.com/office/drawing/2014/main" val="20000"/>
+                    </a:ext>
+                  </a:extLst>
+                </a:gridCol>
+                <a:gridCol w="3972910">
+                  <a:extLst>
+                    <a:ext uri="{9D8B030D-6E8A-4147-A177-3AD203B41FA5}">
+                      <a16:colId xmlns:a16="http://schemas.microsoft.com/office/drawing/2014/main" val="20001"/>
+                    </a:ext>
+                  </a:extLst>
+                </a:gridCol>
               </a:tblGrid>
               <a:tr h="438912">
                 <a:tc>
                   <a:txBody>
-                    <a:bodyPr wrap="square"/>
+                    <a:bodyPr/>
                     <a:lstStyle/>
                     <a:p>
                       <a:pPr algn="l"/>
@@ -9060,7 +9372,7 @@
                 </a:tc>
                 <a:tc>
                   <a:txBody>
-                    <a:bodyPr wrap="square"/>
+                    <a:bodyPr/>
                     <a:lstStyle/>
                     <a:p>
                       <a:pPr algn="ctr"/>
@@ -9081,11 +9393,16 @@
                     </a:solidFill>
                   </a:tcPr>
                 </a:tc>
+                <a:extLst>
+                  <a:ext uri="{0D108BD9-81ED-4DB2-BD59-A6C34878D82A}">
+                    <a16:rowId xmlns:a16="http://schemas.microsoft.com/office/drawing/2014/main" val="10000"/>
+                  </a:ext>
+                </a:extLst>
               </a:tr>
               <a:tr h="438912">
                 <a:tc>
                   <a:txBody>
-                    <a:bodyPr wrap="square"/>
+                    <a:bodyPr/>
                     <a:lstStyle/>
                     <a:p>
                       <a:pPr algn="l"/>
@@ -9108,7 +9425,7 @@
                 </a:tc>
                 <a:tc>
                   <a:txBody>
-                    <a:bodyPr wrap="square"/>
+                    <a:bodyPr/>
                     <a:lstStyle/>
                     <a:p>
                       <a:pPr algn="ctr"/>
@@ -9129,11 +9446,16 @@
                     </a:solidFill>
                   </a:tcPr>
                 </a:tc>
+                <a:extLst>
+                  <a:ext uri="{0D108BD9-81ED-4DB2-BD59-A6C34878D82A}">
+                    <a16:rowId xmlns:a16="http://schemas.microsoft.com/office/drawing/2014/main" val="10001"/>
+                  </a:ext>
+                </a:extLst>
               </a:tr>
               <a:tr h="438912">
                 <a:tc>
                   <a:txBody>
-                    <a:bodyPr wrap="square"/>
+                    <a:bodyPr/>
                     <a:lstStyle/>
                     <a:p>
                       <a:pPr algn="l"/>
@@ -9156,7 +9478,7 @@
                 </a:tc>
                 <a:tc>
                   <a:txBody>
-                    <a:bodyPr wrap="square"/>
+                    <a:bodyPr/>
                     <a:lstStyle/>
                     <a:p>
                       <a:pPr algn="ctr"/>
@@ -9177,11 +9499,16 @@
                     </a:solidFill>
                   </a:tcPr>
                 </a:tc>
+                <a:extLst>
+                  <a:ext uri="{0D108BD9-81ED-4DB2-BD59-A6C34878D82A}">
+                    <a16:rowId xmlns:a16="http://schemas.microsoft.com/office/drawing/2014/main" val="10002"/>
+                  </a:ext>
+                </a:extLst>
               </a:tr>
               <a:tr h="438912">
                 <a:tc>
                   <a:txBody>
-                    <a:bodyPr wrap="square"/>
+                    <a:bodyPr/>
                     <a:lstStyle/>
                     <a:p>
                       <a:pPr algn="l"/>
@@ -9204,7 +9531,7 @@
                 </a:tc>
                 <a:tc>
                   <a:txBody>
-                    <a:bodyPr wrap="square"/>
+                    <a:bodyPr/>
                     <a:lstStyle/>
                     <a:p>
                       <a:pPr algn="ctr"/>
@@ -9225,6 +9552,11 @@
                     </a:solidFill>
                   </a:tcPr>
                 </a:tc>
+                <a:extLst>
+                  <a:ext uri="{0D108BD9-81ED-4DB2-BD59-A6C34878D82A}">
+                    <a16:rowId xmlns:a16="http://schemas.microsoft.com/office/drawing/2014/main" val="10003"/>
+                  </a:ext>
+                </a:extLst>
               </a:tr>
             </a:tbl>
           </a:graphicData>
@@ -9337,7 +9669,7 @@
 </file>
 
 <file path=ppt/slides/slide18.xml><?xml version="1.0" encoding="utf-8"?>
-<p:sld xmlns:a="http://schemas.openxmlformats.org/drawingml/2006/main" xmlns:p="http://schemas.openxmlformats.org/presentationml/2006/main" xmlns:r="http://schemas.openxmlformats.org/officeDocument/2006/relationships">
+<p:sld xmlns:a="http://schemas.openxmlformats.org/drawingml/2006/main" xmlns:r="http://schemas.openxmlformats.org/officeDocument/2006/relationships" xmlns:p="http://schemas.openxmlformats.org/presentationml/2006/main">
   <p:cSld>
     <p:spTree>
       <p:nvGrpSpPr>
@@ -9345,7 +9677,14 @@
         <p:cNvGrpSpPr/>
         <p:nvPr/>
       </p:nvGrpSpPr>
-      <p:grpSpPr/>
+      <p:grpSpPr>
+        <a:xfrm>
+          <a:off x="0" y="0"/>
+          <a:ext cx="0" cy="0"/>
+          <a:chOff x="0" y="0"/>
+          <a:chExt cx="0" cy="0"/>
+        </a:xfrm>
+      </p:grpSpPr>
       <p:sp>
         <p:nvSpPr>
           <p:cNvPr id="2" name="Rectangle 1"/>
@@ -9387,6 +9726,7 @@
           <a:lstStyle/>
           <a:p>
             <a:pPr algn="ctr"/>
+            <a:endParaRPr/>
           </a:p>
         </p:txBody>
       </p:sp>
@@ -9431,6 +9771,7 @@
           <a:lstStyle/>
           <a:p>
             <a:pPr algn="ctr"/>
+            <a:endParaRPr/>
           </a:p>
         </p:txBody>
       </p:sp>
@@ -9545,6 +9886,7 @@
           <a:lstStyle/>
           <a:p>
             <a:pPr algn="ctr"/>
+            <a:endParaRPr/>
           </a:p>
         </p:txBody>
       </p:sp>
@@ -9589,6 +9931,7 @@
           <a:lstStyle/>
           <a:p>
             <a:pPr algn="ctr"/>
+            <a:endParaRPr/>
           </a:p>
         </p:txBody>
       </p:sp>
@@ -9903,6 +10246,7 @@
           <a:lstStyle/>
           <a:p>
             <a:pPr algn="ctr"/>
+            <a:endParaRPr/>
           </a:p>
         </p:txBody>
       </p:sp>
@@ -10073,7 +10417,7 @@
 </file>
 
 <file path=ppt/slides/slide19.xml><?xml version="1.0" encoding="utf-8"?>
-<p:sld xmlns:a="http://schemas.openxmlformats.org/drawingml/2006/main" xmlns:p="http://schemas.openxmlformats.org/presentationml/2006/main" xmlns:r="http://schemas.openxmlformats.org/officeDocument/2006/relationships">
+<p:sld xmlns:a="http://schemas.openxmlformats.org/drawingml/2006/main" xmlns:r="http://schemas.openxmlformats.org/officeDocument/2006/relationships" xmlns:p="http://schemas.openxmlformats.org/presentationml/2006/main">
   <p:cSld>
     <p:spTree>
       <p:nvGrpSpPr>
@@ -10081,7 +10425,14 @@
         <p:cNvGrpSpPr/>
         <p:nvPr/>
       </p:nvGrpSpPr>
-      <p:grpSpPr/>
+      <p:grpSpPr>
+        <a:xfrm>
+          <a:off x="0" y="0"/>
+          <a:ext cx="0" cy="0"/>
+          <a:chOff x="0" y="0"/>
+          <a:chExt cx="0" cy="0"/>
+        </a:xfrm>
+      </p:grpSpPr>
       <p:sp>
         <p:nvSpPr>
           <p:cNvPr id="2" name="Rectangle 1"/>
@@ -10123,6 +10474,7 @@
           <a:lstStyle/>
           <a:p>
             <a:pPr algn="ctr"/>
+            <a:endParaRPr/>
           </a:p>
         </p:txBody>
       </p:sp>
@@ -10167,6 +10519,7 @@
           <a:lstStyle/>
           <a:p>
             <a:pPr algn="ctr"/>
+            <a:endParaRPr/>
           </a:p>
         </p:txBody>
       </p:sp>
@@ -10211,6 +10564,7 @@
           <a:lstStyle/>
           <a:p>
             <a:pPr algn="ctr"/>
+            <a:endParaRPr/>
           </a:p>
         </p:txBody>
       </p:sp>
@@ -10328,7 +10682,7 @@
 </file>
 
 <file path=ppt/slides/slide2.xml><?xml version="1.0" encoding="utf-8"?>
-<p:sld xmlns:a="http://schemas.openxmlformats.org/drawingml/2006/main" xmlns:p="http://schemas.openxmlformats.org/presentationml/2006/main" xmlns:r="http://schemas.openxmlformats.org/officeDocument/2006/relationships">
+<p:sld xmlns:a="http://schemas.openxmlformats.org/drawingml/2006/main" xmlns:r="http://schemas.openxmlformats.org/officeDocument/2006/relationships" xmlns:p="http://schemas.openxmlformats.org/presentationml/2006/main">
   <p:cSld>
     <p:spTree>
       <p:nvGrpSpPr>
@@ -10336,7 +10690,14 @@
         <p:cNvGrpSpPr/>
         <p:nvPr/>
       </p:nvGrpSpPr>
-      <p:grpSpPr/>
+      <p:grpSpPr>
+        <a:xfrm>
+          <a:off x="0" y="0"/>
+          <a:ext cx="0" cy="0"/>
+          <a:chOff x="0" y="0"/>
+          <a:chExt cx="0" cy="0"/>
+        </a:xfrm>
+      </p:grpSpPr>
       <p:sp>
         <p:nvSpPr>
           <p:cNvPr id="2" name="Rectangle 1"/>
@@ -10378,6 +10739,7 @@
           <a:lstStyle/>
           <a:p>
             <a:pPr algn="ctr"/>
+            <a:endParaRPr/>
           </a:p>
         </p:txBody>
       </p:sp>
@@ -10422,6 +10784,7 @@
           <a:lstStyle/>
           <a:p>
             <a:pPr algn="ctr"/>
+            <a:endParaRPr/>
           </a:p>
         </p:txBody>
       </p:sp>
@@ -10536,6 +10899,7 @@
           <a:lstStyle/>
           <a:p>
             <a:pPr algn="ctr"/>
+            <a:endParaRPr/>
           </a:p>
         </p:txBody>
       </p:sp>
@@ -10580,6 +10944,7 @@
           <a:lstStyle/>
           <a:p>
             <a:pPr algn="ctr"/>
+            <a:endParaRPr/>
           </a:p>
         </p:txBody>
       </p:sp>
@@ -10905,6 +11270,7 @@
           <a:lstStyle/>
           <a:p>
             <a:pPr algn="ctr"/>
+            <a:endParaRPr/>
           </a:p>
         </p:txBody>
       </p:sp>
@@ -11018,15 +11384,12 @@
                 <a:spcPts val="400"/>
               </a:spcAft>
             </a:pPr>
-            <a:r>
-              <a:rPr sz="800" b="0" i="0">
-                <a:solidFill>
-                  <a:srgbClr val="111827"/>
-                </a:solidFill>
-                <a:latin typeface="Georgia"/>
-              </a:rPr>
-              <a:t/>
-            </a:r>
+            <a:endParaRPr sz="2000" b="1" i="0">
+              <a:solidFill>
+                <a:srgbClr val="1E3A8A"/>
+              </a:solidFill>
+              <a:latin typeface="Bahnschrift"/>
+            </a:endParaRPr>
           </a:p>
           <a:p>
             <a:pPr algn="l">
@@ -11055,7 +11418,7 @@
 </file>
 
 <file path=ppt/slides/slide20.xml><?xml version="1.0" encoding="utf-8"?>
-<p:sld xmlns:a="http://schemas.openxmlformats.org/drawingml/2006/main" xmlns:p="http://schemas.openxmlformats.org/presentationml/2006/main" xmlns:r="http://schemas.openxmlformats.org/officeDocument/2006/relationships">
+<p:sld xmlns:a="http://schemas.openxmlformats.org/drawingml/2006/main" xmlns:r="http://schemas.openxmlformats.org/officeDocument/2006/relationships" xmlns:p="http://schemas.openxmlformats.org/presentationml/2006/main">
   <p:cSld>
     <p:spTree>
       <p:nvGrpSpPr>
@@ -11063,7 +11426,14 @@
         <p:cNvGrpSpPr/>
         <p:nvPr/>
       </p:nvGrpSpPr>
-      <p:grpSpPr/>
+      <p:grpSpPr>
+        <a:xfrm>
+          <a:off x="0" y="0"/>
+          <a:ext cx="0" cy="0"/>
+          <a:chOff x="0" y="0"/>
+          <a:chExt cx="0" cy="0"/>
+        </a:xfrm>
+      </p:grpSpPr>
       <p:sp>
         <p:nvSpPr>
           <p:cNvPr id="2" name="Rectangle 1"/>
@@ -11105,6 +11475,7 @@
           <a:lstStyle/>
           <a:p>
             <a:pPr algn="ctr"/>
+            <a:endParaRPr/>
           </a:p>
         </p:txBody>
       </p:sp>
@@ -11149,6 +11520,7 @@
           <a:lstStyle/>
           <a:p>
             <a:pPr algn="ctr"/>
+            <a:endParaRPr/>
           </a:p>
         </p:txBody>
       </p:sp>
@@ -11263,6 +11635,7 @@
           <a:lstStyle/>
           <a:p>
             <a:pPr algn="ctr"/>
+            <a:endParaRPr/>
           </a:p>
         </p:txBody>
       </p:sp>
@@ -11307,6 +11680,7 @@
           <a:lstStyle/>
           <a:p>
             <a:pPr algn="ctr"/>
+            <a:endParaRPr/>
           </a:p>
         </p:txBody>
       </p:sp>
@@ -11425,6 +11799,7 @@
           <a:lstStyle/>
           <a:p>
             <a:pPr algn="ctr"/>
+            <a:endParaRPr/>
           </a:p>
         </p:txBody>
       </p:sp>
@@ -11674,6 +12049,7 @@
           <a:lstStyle/>
           <a:p>
             <a:pPr algn="ctr"/>
+            <a:endParaRPr/>
           </a:p>
         </p:txBody>
       </p:sp>
@@ -11889,7 +12265,7 @@
 </file>
 
 <file path=ppt/slides/slide21.xml><?xml version="1.0" encoding="utf-8"?>
-<p:sld xmlns:a="http://schemas.openxmlformats.org/drawingml/2006/main" xmlns:p="http://schemas.openxmlformats.org/presentationml/2006/main" xmlns:r="http://schemas.openxmlformats.org/officeDocument/2006/relationships">
+<p:sld xmlns:a="http://schemas.openxmlformats.org/drawingml/2006/main" xmlns:r="http://schemas.openxmlformats.org/officeDocument/2006/relationships" xmlns:p="http://schemas.openxmlformats.org/presentationml/2006/main">
   <p:cSld>
     <p:spTree>
       <p:nvGrpSpPr>
@@ -11897,7 +12273,14 @@
         <p:cNvGrpSpPr/>
         <p:nvPr/>
       </p:nvGrpSpPr>
-      <p:grpSpPr/>
+      <p:grpSpPr>
+        <a:xfrm>
+          <a:off x="0" y="0"/>
+          <a:ext cx="0" cy="0"/>
+          <a:chOff x="0" y="0"/>
+          <a:chExt cx="0" cy="0"/>
+        </a:xfrm>
+      </p:grpSpPr>
       <p:sp>
         <p:nvSpPr>
           <p:cNvPr id="2" name="Rectangle 1"/>
@@ -11939,6 +12322,7 @@
           <a:lstStyle/>
           <a:p>
             <a:pPr algn="ctr"/>
+            <a:endParaRPr/>
           </a:p>
         </p:txBody>
       </p:sp>
@@ -11983,6 +12367,7 @@
           <a:lstStyle/>
           <a:p>
             <a:pPr algn="ctr"/>
+            <a:endParaRPr/>
           </a:p>
         </p:txBody>
       </p:sp>
@@ -12097,6 +12482,7 @@
           <a:lstStyle/>
           <a:p>
             <a:pPr algn="ctr"/>
+            <a:endParaRPr/>
           </a:p>
         </p:txBody>
       </p:sp>
@@ -12141,6 +12527,7 @@
           <a:lstStyle/>
           <a:p>
             <a:pPr algn="ctr"/>
+            <a:endParaRPr/>
           </a:p>
         </p:txBody>
       </p:sp>
@@ -12255,6 +12642,7 @@
           <a:lstStyle/>
           <a:p>
             <a:pPr algn="ctr"/>
+            <a:endParaRPr/>
           </a:p>
         </p:txBody>
       </p:sp>
@@ -12308,17 +12696,41 @@
         <a:graphic>
           <a:graphicData uri="http://schemas.openxmlformats.org/drawingml/2006/table">
             <a:tbl>
-              <a:tblPr firstRow="0" bandRow="0"/>
+              <a:tblPr/>
               <a:tblGrid>
-                <a:gridCol w="2716327"/>
-                <a:gridCol w="769626"/>
-                <a:gridCol w="769626"/>
-                <a:gridCol w="6836091"/>
+                <a:gridCol w="2716327">
+                  <a:extLst>
+                    <a:ext uri="{9D8B030D-6E8A-4147-A177-3AD203B41FA5}">
+                      <a16:colId xmlns:a16="http://schemas.microsoft.com/office/drawing/2014/main" val="20000"/>
+                    </a:ext>
+                  </a:extLst>
+                </a:gridCol>
+                <a:gridCol w="769626">
+                  <a:extLst>
+                    <a:ext uri="{9D8B030D-6E8A-4147-A177-3AD203B41FA5}">
+                      <a16:colId xmlns:a16="http://schemas.microsoft.com/office/drawing/2014/main" val="20001"/>
+                    </a:ext>
+                  </a:extLst>
+                </a:gridCol>
+                <a:gridCol w="769626">
+                  <a:extLst>
+                    <a:ext uri="{9D8B030D-6E8A-4147-A177-3AD203B41FA5}">
+                      <a16:colId xmlns:a16="http://schemas.microsoft.com/office/drawing/2014/main" val="20002"/>
+                    </a:ext>
+                  </a:extLst>
+                </a:gridCol>
+                <a:gridCol w="6836091">
+                  <a:extLst>
+                    <a:ext uri="{9D8B030D-6E8A-4147-A177-3AD203B41FA5}">
+                      <a16:colId xmlns:a16="http://schemas.microsoft.com/office/drawing/2014/main" val="20003"/>
+                    </a:ext>
+                  </a:extLst>
+                </a:gridCol>
               </a:tblGrid>
               <a:tr h="329184">
                 <a:tc>
                   <a:txBody>
-                    <a:bodyPr wrap="square"/>
+                    <a:bodyPr/>
                     <a:lstStyle/>
                     <a:p>
                       <a:pPr algn="l"/>
@@ -12341,7 +12753,7 @@
                 </a:tc>
                 <a:tc>
                   <a:txBody>
-                    <a:bodyPr wrap="square"/>
+                    <a:bodyPr/>
                     <a:lstStyle/>
                     <a:p>
                       <a:pPr algn="ctr"/>
@@ -12364,7 +12776,7 @@
                 </a:tc>
                 <a:tc>
                   <a:txBody>
-                    <a:bodyPr wrap="square"/>
+                    <a:bodyPr/>
                     <a:lstStyle/>
                     <a:p>
                       <a:pPr algn="ctr"/>
@@ -12387,7 +12799,7 @@
                 </a:tc>
                 <a:tc>
                   <a:txBody>
-                    <a:bodyPr wrap="square"/>
+                    <a:bodyPr/>
                     <a:lstStyle/>
                     <a:p>
                       <a:pPr algn="l"/>
@@ -12408,11 +12820,16 @@
                     </a:solidFill>
                   </a:tcPr>
                 </a:tc>
+                <a:extLst>
+                  <a:ext uri="{0D108BD9-81ED-4DB2-BD59-A6C34878D82A}">
+                    <a16:rowId xmlns:a16="http://schemas.microsoft.com/office/drawing/2014/main" val="10000"/>
+                  </a:ext>
+                </a:extLst>
               </a:tr>
               <a:tr h="329184">
                 <a:tc>
                   <a:txBody>
-                    <a:bodyPr wrap="square"/>
+                    <a:bodyPr/>
                     <a:lstStyle/>
                     <a:p>
                       <a:pPr algn="l"/>
@@ -12435,7 +12852,7 @@
                 </a:tc>
                 <a:tc>
                   <a:txBody>
-                    <a:bodyPr wrap="square"/>
+                    <a:bodyPr/>
                     <a:lstStyle/>
                     <a:p>
                       <a:pPr algn="ctr"/>
@@ -12458,7 +12875,7 @@
                 </a:tc>
                 <a:tc>
                   <a:txBody>
-                    <a:bodyPr wrap="square"/>
+                    <a:bodyPr/>
                     <a:lstStyle/>
                     <a:p>
                       <a:pPr algn="ctr"/>
@@ -12481,7 +12898,7 @@
                 </a:tc>
                 <a:tc>
                   <a:txBody>
-                    <a:bodyPr wrap="square"/>
+                    <a:bodyPr/>
                     <a:lstStyle/>
                     <a:p>
                       <a:pPr algn="l"/>
@@ -12502,11 +12919,16 @@
                     </a:solidFill>
                   </a:tcPr>
                 </a:tc>
+                <a:extLst>
+                  <a:ext uri="{0D108BD9-81ED-4DB2-BD59-A6C34878D82A}">
+                    <a16:rowId xmlns:a16="http://schemas.microsoft.com/office/drawing/2014/main" val="10001"/>
+                  </a:ext>
+                </a:extLst>
               </a:tr>
               <a:tr h="329184">
                 <a:tc>
                   <a:txBody>
-                    <a:bodyPr wrap="square"/>
+                    <a:bodyPr/>
                     <a:lstStyle/>
                     <a:p>
                       <a:pPr algn="l"/>
@@ -12529,7 +12951,7 @@
                 </a:tc>
                 <a:tc>
                   <a:txBody>
-                    <a:bodyPr wrap="square"/>
+                    <a:bodyPr/>
                     <a:lstStyle/>
                     <a:p>
                       <a:pPr algn="ctr"/>
@@ -12552,7 +12974,7 @@
                 </a:tc>
                 <a:tc>
                   <a:txBody>
-                    <a:bodyPr wrap="square"/>
+                    <a:bodyPr/>
                     <a:lstStyle/>
                     <a:p>
                       <a:pPr algn="ctr"/>
@@ -12575,7 +12997,7 @@
                 </a:tc>
                 <a:tc>
                   <a:txBody>
-                    <a:bodyPr wrap="square"/>
+                    <a:bodyPr/>
                     <a:lstStyle/>
                     <a:p>
                       <a:pPr algn="l"/>
@@ -12596,11 +13018,16 @@
                     </a:solidFill>
                   </a:tcPr>
                 </a:tc>
+                <a:extLst>
+                  <a:ext uri="{0D108BD9-81ED-4DB2-BD59-A6C34878D82A}">
+                    <a16:rowId xmlns:a16="http://schemas.microsoft.com/office/drawing/2014/main" val="10002"/>
+                  </a:ext>
+                </a:extLst>
               </a:tr>
               <a:tr h="329184">
                 <a:tc>
                   <a:txBody>
-                    <a:bodyPr wrap="square"/>
+                    <a:bodyPr/>
                     <a:lstStyle/>
                     <a:p>
                       <a:pPr algn="l"/>
@@ -12623,7 +13050,7 @@
                 </a:tc>
                 <a:tc>
                   <a:txBody>
-                    <a:bodyPr wrap="square"/>
+                    <a:bodyPr/>
                     <a:lstStyle/>
                     <a:p>
                       <a:pPr algn="ctr"/>
@@ -12646,7 +13073,7 @@
                 </a:tc>
                 <a:tc>
                   <a:txBody>
-                    <a:bodyPr wrap="square"/>
+                    <a:bodyPr/>
                     <a:lstStyle/>
                     <a:p>
                       <a:pPr algn="ctr"/>
@@ -12669,7 +13096,7 @@
                 </a:tc>
                 <a:tc>
                   <a:txBody>
-                    <a:bodyPr wrap="square"/>
+                    <a:bodyPr/>
                     <a:lstStyle/>
                     <a:p>
                       <a:pPr algn="l"/>
@@ -12690,11 +13117,16 @@
                     </a:solidFill>
                   </a:tcPr>
                 </a:tc>
+                <a:extLst>
+                  <a:ext uri="{0D108BD9-81ED-4DB2-BD59-A6C34878D82A}">
+                    <a16:rowId xmlns:a16="http://schemas.microsoft.com/office/drawing/2014/main" val="10003"/>
+                  </a:ext>
+                </a:extLst>
               </a:tr>
               <a:tr h="329184">
                 <a:tc>
                   <a:txBody>
-                    <a:bodyPr wrap="square"/>
+                    <a:bodyPr/>
                     <a:lstStyle/>
                     <a:p>
                       <a:pPr algn="l"/>
@@ -12717,7 +13149,7 @@
                 </a:tc>
                 <a:tc>
                   <a:txBody>
-                    <a:bodyPr wrap="square"/>
+                    <a:bodyPr/>
                     <a:lstStyle/>
                     <a:p>
                       <a:pPr algn="ctr"/>
@@ -12740,7 +13172,7 @@
                 </a:tc>
                 <a:tc>
                   <a:txBody>
-                    <a:bodyPr wrap="square"/>
+                    <a:bodyPr/>
                     <a:lstStyle/>
                     <a:p>
                       <a:pPr algn="ctr"/>
@@ -12763,7 +13195,7 @@
                 </a:tc>
                 <a:tc>
                   <a:txBody>
-                    <a:bodyPr wrap="square"/>
+                    <a:bodyPr/>
                     <a:lstStyle/>
                     <a:p>
                       <a:pPr algn="l"/>
@@ -12784,11 +13216,16 @@
                     </a:solidFill>
                   </a:tcPr>
                 </a:tc>
+                <a:extLst>
+                  <a:ext uri="{0D108BD9-81ED-4DB2-BD59-A6C34878D82A}">
+                    <a16:rowId xmlns:a16="http://schemas.microsoft.com/office/drawing/2014/main" val="10004"/>
+                  </a:ext>
+                </a:extLst>
               </a:tr>
               <a:tr h="329184">
                 <a:tc>
                   <a:txBody>
-                    <a:bodyPr wrap="square"/>
+                    <a:bodyPr/>
                     <a:lstStyle/>
                     <a:p>
                       <a:pPr algn="l"/>
@@ -12811,7 +13248,7 @@
                 </a:tc>
                 <a:tc>
                   <a:txBody>
-                    <a:bodyPr wrap="square"/>
+                    <a:bodyPr/>
                     <a:lstStyle/>
                     <a:p>
                       <a:pPr algn="ctr"/>
@@ -12834,7 +13271,7 @@
                 </a:tc>
                 <a:tc>
                   <a:txBody>
-                    <a:bodyPr wrap="square"/>
+                    <a:bodyPr/>
                     <a:lstStyle/>
                     <a:p>
                       <a:pPr algn="ctr"/>
@@ -12857,7 +13294,7 @@
                 </a:tc>
                 <a:tc>
                   <a:txBody>
-                    <a:bodyPr wrap="square"/>
+                    <a:bodyPr/>
                     <a:lstStyle/>
                     <a:p>
                       <a:pPr algn="l"/>
@@ -12878,6 +13315,11 @@
                     </a:solidFill>
                   </a:tcPr>
                 </a:tc>
+                <a:extLst>
+                  <a:ext uri="{0D108BD9-81ED-4DB2-BD59-A6C34878D82A}">
+                    <a16:rowId xmlns:a16="http://schemas.microsoft.com/office/drawing/2014/main" val="10005"/>
+                  </a:ext>
+                </a:extLst>
               </a:tr>
             </a:tbl>
           </a:graphicData>
@@ -12924,6 +13366,7 @@
           <a:lstStyle/>
           <a:p>
             <a:pPr algn="ctr"/>
+            <a:endParaRPr/>
           </a:p>
         </p:txBody>
       </p:sp>
@@ -12977,17 +13420,41 @@
         <a:graphic>
           <a:graphicData uri="http://schemas.openxmlformats.org/drawingml/2006/table">
             <a:tbl>
-              <a:tblPr firstRow="0" bandRow="0"/>
+              <a:tblPr/>
               <a:tblGrid>
-                <a:gridCol w="2716327"/>
-                <a:gridCol w="769626"/>
-                <a:gridCol w="769626"/>
-                <a:gridCol w="6836091"/>
+                <a:gridCol w="2716327">
+                  <a:extLst>
+                    <a:ext uri="{9D8B030D-6E8A-4147-A177-3AD203B41FA5}">
+                      <a16:colId xmlns:a16="http://schemas.microsoft.com/office/drawing/2014/main" val="20000"/>
+                    </a:ext>
+                  </a:extLst>
+                </a:gridCol>
+                <a:gridCol w="769626">
+                  <a:extLst>
+                    <a:ext uri="{9D8B030D-6E8A-4147-A177-3AD203B41FA5}">
+                      <a16:colId xmlns:a16="http://schemas.microsoft.com/office/drawing/2014/main" val="20001"/>
+                    </a:ext>
+                  </a:extLst>
+                </a:gridCol>
+                <a:gridCol w="769626">
+                  <a:extLst>
+                    <a:ext uri="{9D8B030D-6E8A-4147-A177-3AD203B41FA5}">
+                      <a16:colId xmlns:a16="http://schemas.microsoft.com/office/drawing/2014/main" val="20002"/>
+                    </a:ext>
+                  </a:extLst>
+                </a:gridCol>
+                <a:gridCol w="6836091">
+                  <a:extLst>
+                    <a:ext uri="{9D8B030D-6E8A-4147-A177-3AD203B41FA5}">
+                      <a16:colId xmlns:a16="http://schemas.microsoft.com/office/drawing/2014/main" val="20003"/>
+                    </a:ext>
+                  </a:extLst>
+                </a:gridCol>
               </a:tblGrid>
               <a:tr h="329184">
                 <a:tc>
                   <a:txBody>
-                    <a:bodyPr wrap="square"/>
+                    <a:bodyPr/>
                     <a:lstStyle/>
                     <a:p>
                       <a:pPr algn="l"/>
@@ -13010,7 +13477,7 @@
                 </a:tc>
                 <a:tc>
                   <a:txBody>
-                    <a:bodyPr wrap="square"/>
+                    <a:bodyPr/>
                     <a:lstStyle/>
                     <a:p>
                       <a:pPr algn="ctr"/>
@@ -13033,7 +13500,7 @@
                 </a:tc>
                 <a:tc>
                   <a:txBody>
-                    <a:bodyPr wrap="square"/>
+                    <a:bodyPr/>
                     <a:lstStyle/>
                     <a:p>
                       <a:pPr algn="ctr"/>
@@ -13056,7 +13523,7 @@
                 </a:tc>
                 <a:tc>
                   <a:txBody>
-                    <a:bodyPr wrap="square"/>
+                    <a:bodyPr/>
                     <a:lstStyle/>
                     <a:p>
                       <a:pPr algn="l"/>
@@ -13077,11 +13544,16 @@
                     </a:solidFill>
                   </a:tcPr>
                 </a:tc>
+                <a:extLst>
+                  <a:ext uri="{0D108BD9-81ED-4DB2-BD59-A6C34878D82A}">
+                    <a16:rowId xmlns:a16="http://schemas.microsoft.com/office/drawing/2014/main" val="10000"/>
+                  </a:ext>
+                </a:extLst>
               </a:tr>
               <a:tr h="329184">
                 <a:tc>
                   <a:txBody>
-                    <a:bodyPr wrap="square"/>
+                    <a:bodyPr/>
                     <a:lstStyle/>
                     <a:p>
                       <a:pPr algn="l"/>
@@ -13104,7 +13576,7 @@
                 </a:tc>
                 <a:tc>
                   <a:txBody>
-                    <a:bodyPr wrap="square"/>
+                    <a:bodyPr/>
                     <a:lstStyle/>
                     <a:p>
                       <a:pPr algn="ctr"/>
@@ -13127,7 +13599,7 @@
                 </a:tc>
                 <a:tc>
                   <a:txBody>
-                    <a:bodyPr wrap="square"/>
+                    <a:bodyPr/>
                     <a:lstStyle/>
                     <a:p>
                       <a:pPr algn="ctr"/>
@@ -13150,7 +13622,7 @@
                 </a:tc>
                 <a:tc>
                   <a:txBody>
-                    <a:bodyPr wrap="square"/>
+                    <a:bodyPr/>
                     <a:lstStyle/>
                     <a:p>
                       <a:pPr algn="l"/>
@@ -13171,11 +13643,16 @@
                     </a:solidFill>
                   </a:tcPr>
                 </a:tc>
+                <a:extLst>
+                  <a:ext uri="{0D108BD9-81ED-4DB2-BD59-A6C34878D82A}">
+                    <a16:rowId xmlns:a16="http://schemas.microsoft.com/office/drawing/2014/main" val="10001"/>
+                  </a:ext>
+                </a:extLst>
               </a:tr>
               <a:tr h="329184">
                 <a:tc>
                   <a:txBody>
-                    <a:bodyPr wrap="square"/>
+                    <a:bodyPr/>
                     <a:lstStyle/>
                     <a:p>
                       <a:pPr algn="l"/>
@@ -13198,7 +13675,7 @@
                 </a:tc>
                 <a:tc>
                   <a:txBody>
-                    <a:bodyPr wrap="square"/>
+                    <a:bodyPr/>
                     <a:lstStyle/>
                     <a:p>
                       <a:pPr algn="ctr"/>
@@ -13221,7 +13698,7 @@
                 </a:tc>
                 <a:tc>
                   <a:txBody>
-                    <a:bodyPr wrap="square"/>
+                    <a:bodyPr/>
                     <a:lstStyle/>
                     <a:p>
                       <a:pPr algn="ctr"/>
@@ -13244,7 +13721,7 @@
                 </a:tc>
                 <a:tc>
                   <a:txBody>
-                    <a:bodyPr wrap="square"/>
+                    <a:bodyPr/>
                     <a:lstStyle/>
                     <a:p>
                       <a:pPr algn="l"/>
@@ -13265,11 +13742,16 @@
                     </a:solidFill>
                   </a:tcPr>
                 </a:tc>
+                <a:extLst>
+                  <a:ext uri="{0D108BD9-81ED-4DB2-BD59-A6C34878D82A}">
+                    <a16:rowId xmlns:a16="http://schemas.microsoft.com/office/drawing/2014/main" val="10002"/>
+                  </a:ext>
+                </a:extLst>
               </a:tr>
               <a:tr h="329184">
                 <a:tc>
                   <a:txBody>
-                    <a:bodyPr wrap="square"/>
+                    <a:bodyPr/>
                     <a:lstStyle/>
                     <a:p>
                       <a:pPr algn="l"/>
@@ -13292,7 +13774,7 @@
                 </a:tc>
                 <a:tc>
                   <a:txBody>
-                    <a:bodyPr wrap="square"/>
+                    <a:bodyPr/>
                     <a:lstStyle/>
                     <a:p>
                       <a:pPr algn="ctr"/>
@@ -13315,7 +13797,7 @@
                 </a:tc>
                 <a:tc>
                   <a:txBody>
-                    <a:bodyPr wrap="square"/>
+                    <a:bodyPr/>
                     <a:lstStyle/>
                     <a:p>
                       <a:pPr algn="ctr"/>
@@ -13338,7 +13820,7 @@
                 </a:tc>
                 <a:tc>
                   <a:txBody>
-                    <a:bodyPr wrap="square"/>
+                    <a:bodyPr/>
                     <a:lstStyle/>
                     <a:p>
                       <a:pPr algn="l"/>
@@ -13359,11 +13841,16 @@
                     </a:solidFill>
                   </a:tcPr>
                 </a:tc>
+                <a:extLst>
+                  <a:ext uri="{0D108BD9-81ED-4DB2-BD59-A6C34878D82A}">
+                    <a16:rowId xmlns:a16="http://schemas.microsoft.com/office/drawing/2014/main" val="10003"/>
+                  </a:ext>
+                </a:extLst>
               </a:tr>
               <a:tr h="329184">
                 <a:tc>
                   <a:txBody>
-                    <a:bodyPr wrap="square"/>
+                    <a:bodyPr/>
                     <a:lstStyle/>
                     <a:p>
                       <a:pPr algn="l"/>
@@ -13386,7 +13873,7 @@
                 </a:tc>
                 <a:tc>
                   <a:txBody>
-                    <a:bodyPr wrap="square"/>
+                    <a:bodyPr/>
                     <a:lstStyle/>
                     <a:p>
                       <a:pPr algn="ctr"/>
@@ -13409,7 +13896,7 @@
                 </a:tc>
                 <a:tc>
                   <a:txBody>
-                    <a:bodyPr wrap="square"/>
+                    <a:bodyPr/>
                     <a:lstStyle/>
                     <a:p>
                       <a:pPr algn="ctr"/>
@@ -13432,7 +13919,7 @@
                 </a:tc>
                 <a:tc>
                   <a:txBody>
-                    <a:bodyPr wrap="square"/>
+                    <a:bodyPr/>
                     <a:lstStyle/>
                     <a:p>
                       <a:pPr algn="l"/>
@@ -13453,11 +13940,16 @@
                     </a:solidFill>
                   </a:tcPr>
                 </a:tc>
+                <a:extLst>
+                  <a:ext uri="{0D108BD9-81ED-4DB2-BD59-A6C34878D82A}">
+                    <a16:rowId xmlns:a16="http://schemas.microsoft.com/office/drawing/2014/main" val="10004"/>
+                  </a:ext>
+                </a:extLst>
               </a:tr>
               <a:tr h="329184">
                 <a:tc>
                   <a:txBody>
-                    <a:bodyPr wrap="square"/>
+                    <a:bodyPr/>
                     <a:lstStyle/>
                     <a:p>
                       <a:pPr algn="l"/>
@@ -13480,7 +13972,7 @@
                 </a:tc>
                 <a:tc>
                   <a:txBody>
-                    <a:bodyPr wrap="square"/>
+                    <a:bodyPr/>
                     <a:lstStyle/>
                     <a:p>
                       <a:pPr algn="ctr"/>
@@ -13503,7 +13995,7 @@
                 </a:tc>
                 <a:tc>
                   <a:txBody>
-                    <a:bodyPr wrap="square"/>
+                    <a:bodyPr/>
                     <a:lstStyle/>
                     <a:p>
                       <a:pPr algn="ctr"/>
@@ -13526,7 +14018,7 @@
                 </a:tc>
                 <a:tc>
                   <a:txBody>
-                    <a:bodyPr wrap="square"/>
+                    <a:bodyPr/>
                     <a:lstStyle/>
                     <a:p>
                       <a:pPr algn="l"/>
@@ -13547,6 +14039,11 @@
                     </a:solidFill>
                   </a:tcPr>
                 </a:tc>
+                <a:extLst>
+                  <a:ext uri="{0D108BD9-81ED-4DB2-BD59-A6C34878D82A}">
+                    <a16:rowId xmlns:a16="http://schemas.microsoft.com/office/drawing/2014/main" val="10005"/>
+                  </a:ext>
+                </a:extLst>
               </a:tr>
             </a:tbl>
           </a:graphicData>
@@ -13596,7 +14093,7 @@
 </file>
 
 <file path=ppt/slides/slide22.xml><?xml version="1.0" encoding="utf-8"?>
-<p:sld xmlns:a="http://schemas.openxmlformats.org/drawingml/2006/main" xmlns:p="http://schemas.openxmlformats.org/presentationml/2006/main" xmlns:r="http://schemas.openxmlformats.org/officeDocument/2006/relationships">
+<p:sld xmlns:a="http://schemas.openxmlformats.org/drawingml/2006/main" xmlns:r="http://schemas.openxmlformats.org/officeDocument/2006/relationships" xmlns:p="http://schemas.openxmlformats.org/presentationml/2006/main">
   <p:cSld>
     <p:spTree>
       <p:nvGrpSpPr>
@@ -13604,7 +14101,14 @@
         <p:cNvGrpSpPr/>
         <p:nvPr/>
       </p:nvGrpSpPr>
-      <p:grpSpPr/>
+      <p:grpSpPr>
+        <a:xfrm>
+          <a:off x="0" y="0"/>
+          <a:ext cx="0" cy="0"/>
+          <a:chOff x="0" y="0"/>
+          <a:chExt cx="0" cy="0"/>
+        </a:xfrm>
+      </p:grpSpPr>
       <p:sp>
         <p:nvSpPr>
           <p:cNvPr id="2" name="Rectangle 1"/>
@@ -13646,6 +14150,7 @@
           <a:lstStyle/>
           <a:p>
             <a:pPr algn="ctr"/>
+            <a:endParaRPr/>
           </a:p>
         </p:txBody>
       </p:sp>
@@ -13690,6 +14195,7 @@
           <a:lstStyle/>
           <a:p>
             <a:pPr algn="ctr"/>
+            <a:endParaRPr/>
           </a:p>
         </p:txBody>
       </p:sp>
@@ -13804,6 +14310,7 @@
           <a:lstStyle/>
           <a:p>
             <a:pPr algn="ctr"/>
+            <a:endParaRPr/>
           </a:p>
         </p:txBody>
       </p:sp>
@@ -13848,6 +14355,7 @@
           <a:lstStyle/>
           <a:p>
             <a:pPr algn="ctr"/>
+            <a:endParaRPr/>
           </a:p>
         </p:txBody>
       </p:sp>
@@ -13964,6 +14472,7 @@
           <a:lstStyle/>
           <a:p>
             <a:pPr algn="ctr"/>
+            <a:endParaRPr/>
           </a:p>
         </p:txBody>
       </p:sp>
@@ -14080,6 +14589,7 @@
           <a:lstStyle/>
           <a:p>
             <a:pPr algn="ctr"/>
+            <a:endParaRPr/>
           </a:p>
         </p:txBody>
       </p:sp>
@@ -14196,6 +14706,7 @@
           <a:lstStyle/>
           <a:p>
             <a:pPr algn="ctr"/>
+            <a:endParaRPr/>
           </a:p>
         </p:txBody>
       </p:sp>
@@ -14312,6 +14823,7 @@
           <a:lstStyle/>
           <a:p>
             <a:pPr algn="ctr"/>
+            <a:endParaRPr/>
           </a:p>
         </p:txBody>
       </p:sp>
@@ -14428,6 +14940,7 @@
           <a:lstStyle/>
           <a:p>
             <a:pPr algn="ctr"/>
+            <a:endParaRPr/>
           </a:p>
         </p:txBody>
       </p:sp>
@@ -14544,6 +15057,7 @@
           <a:lstStyle/>
           <a:p>
             <a:pPr algn="ctr"/>
+            <a:endParaRPr/>
           </a:p>
         </p:txBody>
       </p:sp>
@@ -14661,7 +15175,7 @@
 </file>
 
 <file path=ppt/slides/slide23.xml><?xml version="1.0" encoding="utf-8"?>
-<p:sld xmlns:a="http://schemas.openxmlformats.org/drawingml/2006/main" xmlns:p="http://schemas.openxmlformats.org/presentationml/2006/main" xmlns:r="http://schemas.openxmlformats.org/officeDocument/2006/relationships">
+<p:sld xmlns:a="http://schemas.openxmlformats.org/drawingml/2006/main" xmlns:r="http://schemas.openxmlformats.org/officeDocument/2006/relationships" xmlns:p="http://schemas.openxmlformats.org/presentationml/2006/main">
   <p:cSld>
     <p:spTree>
       <p:nvGrpSpPr>
@@ -14669,7 +15183,14 @@
         <p:cNvGrpSpPr/>
         <p:nvPr/>
       </p:nvGrpSpPr>
-      <p:grpSpPr/>
+      <p:grpSpPr>
+        <a:xfrm>
+          <a:off x="0" y="0"/>
+          <a:ext cx="0" cy="0"/>
+          <a:chOff x="0" y="0"/>
+          <a:chExt cx="0" cy="0"/>
+        </a:xfrm>
+      </p:grpSpPr>
       <p:sp>
         <p:nvSpPr>
           <p:cNvPr id="2" name="Rectangle 1"/>
@@ -14711,6 +15232,7 @@
           <a:lstStyle/>
           <a:p>
             <a:pPr algn="ctr"/>
+            <a:endParaRPr/>
           </a:p>
         </p:txBody>
       </p:sp>
@@ -14755,6 +15277,7 @@
           <a:lstStyle/>
           <a:p>
             <a:pPr algn="ctr"/>
+            <a:endParaRPr/>
           </a:p>
         </p:txBody>
       </p:sp>
@@ -14869,6 +15392,7 @@
           <a:lstStyle/>
           <a:p>
             <a:pPr algn="ctr"/>
+            <a:endParaRPr/>
           </a:p>
         </p:txBody>
       </p:sp>
@@ -14913,6 +15437,7 @@
           <a:lstStyle/>
           <a:p>
             <a:pPr algn="ctr"/>
+            <a:endParaRPr/>
           </a:p>
         </p:txBody>
       </p:sp>
@@ -15031,6 +15556,7 @@
           <a:lstStyle/>
           <a:p>
             <a:pPr algn="ctr"/>
+            <a:endParaRPr/>
           </a:p>
         </p:txBody>
       </p:sp>
@@ -15184,6 +15710,7 @@
           <a:lstStyle/>
           <a:p>
             <a:pPr algn="ctr"/>
+            <a:endParaRPr/>
           </a:p>
         </p:txBody>
       </p:sp>
@@ -15337,6 +15864,7 @@
           <a:lstStyle/>
           <a:p>
             <a:pPr algn="ctr"/>
+            <a:endParaRPr/>
           </a:p>
         </p:txBody>
       </p:sp>
@@ -15754,7 +16282,7 @@
 </file>
 
 <file path=ppt/slides/slide24.xml><?xml version="1.0" encoding="utf-8"?>
-<p:sld xmlns:a="http://schemas.openxmlformats.org/drawingml/2006/main" xmlns:p="http://schemas.openxmlformats.org/presentationml/2006/main" xmlns:r="http://schemas.openxmlformats.org/officeDocument/2006/relationships">
+<p:sld xmlns:a="http://schemas.openxmlformats.org/drawingml/2006/main" xmlns:r="http://schemas.openxmlformats.org/officeDocument/2006/relationships" xmlns:p="http://schemas.openxmlformats.org/presentationml/2006/main">
   <p:cSld>
     <p:spTree>
       <p:nvGrpSpPr>
@@ -15762,7 +16290,14 @@
         <p:cNvGrpSpPr/>
         <p:nvPr/>
       </p:nvGrpSpPr>
-      <p:grpSpPr/>
+      <p:grpSpPr>
+        <a:xfrm>
+          <a:off x="0" y="0"/>
+          <a:ext cx="0" cy="0"/>
+          <a:chOff x="0" y="0"/>
+          <a:chExt cx="0" cy="0"/>
+        </a:xfrm>
+      </p:grpSpPr>
       <p:sp>
         <p:nvSpPr>
           <p:cNvPr id="2" name="Rectangle 1"/>
@@ -15804,6 +16339,7 @@
           <a:lstStyle/>
           <a:p>
             <a:pPr algn="ctr"/>
+            <a:endParaRPr/>
           </a:p>
         </p:txBody>
       </p:sp>
@@ -15848,6 +16384,7 @@
           <a:lstStyle/>
           <a:p>
             <a:pPr algn="ctr"/>
+            <a:endParaRPr/>
           </a:p>
         </p:txBody>
       </p:sp>
@@ -15892,6 +16429,7 @@
           <a:lstStyle/>
           <a:p>
             <a:pPr algn="ctr"/>
+            <a:endParaRPr/>
           </a:p>
         </p:txBody>
       </p:sp>
@@ -15994,7 +16532,7 @@
 </file>
 
 <file path=ppt/slides/slide3.xml><?xml version="1.0" encoding="utf-8"?>
-<p:sld xmlns:a="http://schemas.openxmlformats.org/drawingml/2006/main" xmlns:p="http://schemas.openxmlformats.org/presentationml/2006/main" xmlns:r="http://schemas.openxmlformats.org/officeDocument/2006/relationships">
+<p:sld xmlns:a="http://schemas.openxmlformats.org/drawingml/2006/main" xmlns:r="http://schemas.openxmlformats.org/officeDocument/2006/relationships" xmlns:p="http://schemas.openxmlformats.org/presentationml/2006/main">
   <p:cSld>
     <p:spTree>
       <p:nvGrpSpPr>
@@ -16002,7 +16540,14 @@
         <p:cNvGrpSpPr/>
         <p:nvPr/>
       </p:nvGrpSpPr>
-      <p:grpSpPr/>
+      <p:grpSpPr>
+        <a:xfrm>
+          <a:off x="0" y="0"/>
+          <a:ext cx="0" cy="0"/>
+          <a:chOff x="0" y="0"/>
+          <a:chExt cx="0" cy="0"/>
+        </a:xfrm>
+      </p:grpSpPr>
       <p:sp>
         <p:nvSpPr>
           <p:cNvPr id="2" name="Rectangle 1"/>
@@ -16044,6 +16589,7 @@
           <a:lstStyle/>
           <a:p>
             <a:pPr algn="ctr"/>
+            <a:endParaRPr/>
           </a:p>
         </p:txBody>
       </p:sp>
@@ -16088,6 +16634,7 @@
           <a:lstStyle/>
           <a:p>
             <a:pPr algn="ctr"/>
+            <a:endParaRPr/>
           </a:p>
         </p:txBody>
       </p:sp>
@@ -16202,6 +16749,7 @@
           <a:lstStyle/>
           <a:p>
             <a:pPr algn="ctr"/>
+            <a:endParaRPr/>
           </a:p>
         </p:txBody>
       </p:sp>
@@ -16246,6 +16794,7 @@
           <a:lstStyle/>
           <a:p>
             <a:pPr algn="ctr"/>
+            <a:endParaRPr/>
           </a:p>
         </p:txBody>
       </p:sp>
@@ -16362,6 +16911,7 @@
           <a:lstStyle/>
           <a:p>
             <a:pPr algn="ctr"/>
+            <a:endParaRPr/>
           </a:p>
         </p:txBody>
       </p:sp>
@@ -16511,6 +17061,7 @@
           <a:lstStyle/>
           <a:p>
             <a:pPr algn="ctr"/>
+            <a:endParaRPr/>
           </a:p>
         </p:txBody>
       </p:sp>
@@ -16557,6 +17108,7 @@
           <a:lstStyle/>
           <a:p>
             <a:pPr algn="ctr"/>
+            <a:endParaRPr/>
           </a:p>
         </p:txBody>
       </p:sp>
@@ -16706,6 +17258,7 @@
           <a:lstStyle/>
           <a:p>
             <a:pPr algn="ctr"/>
+            <a:endParaRPr/>
           </a:p>
         </p:txBody>
       </p:sp>
@@ -16752,6 +17305,7 @@
           <a:lstStyle/>
           <a:p>
             <a:pPr algn="ctr"/>
+            <a:endParaRPr/>
           </a:p>
         </p:txBody>
       </p:sp>
@@ -16901,6 +17455,7 @@
           <a:lstStyle/>
           <a:p>
             <a:pPr algn="ctr"/>
+            <a:endParaRPr/>
           </a:p>
         </p:txBody>
       </p:sp>
@@ -16947,6 +17502,7 @@
           <a:lstStyle/>
           <a:p>
             <a:pPr algn="ctr"/>
+            <a:endParaRPr/>
           </a:p>
         </p:txBody>
       </p:sp>
@@ -17096,6 +17652,7 @@
           <a:lstStyle/>
           <a:p>
             <a:pPr algn="ctr"/>
+            <a:endParaRPr/>
           </a:p>
         </p:txBody>
       </p:sp>
@@ -17142,6 +17699,7 @@
           <a:lstStyle/>
           <a:p>
             <a:pPr algn="ctr"/>
+            <a:endParaRPr/>
           </a:p>
         </p:txBody>
       </p:sp>
@@ -17291,6 +17849,7 @@
           <a:lstStyle/>
           <a:p>
             <a:pPr algn="ctr"/>
+            <a:endParaRPr/>
           </a:p>
         </p:txBody>
       </p:sp>
@@ -17337,6 +17896,7 @@
           <a:lstStyle/>
           <a:p>
             <a:pPr algn="ctr"/>
+            <a:endParaRPr/>
           </a:p>
         </p:txBody>
       </p:sp>
@@ -17681,7 +18241,7 @@
 </file>
 
 <file path=ppt/slides/slide4.xml><?xml version="1.0" encoding="utf-8"?>
-<p:sld xmlns:a="http://schemas.openxmlformats.org/drawingml/2006/main" xmlns:p="http://schemas.openxmlformats.org/presentationml/2006/main" xmlns:r="http://schemas.openxmlformats.org/officeDocument/2006/relationships">
+<p:sld xmlns:a="http://schemas.openxmlformats.org/drawingml/2006/main" xmlns:r="http://schemas.openxmlformats.org/officeDocument/2006/relationships" xmlns:p="http://schemas.openxmlformats.org/presentationml/2006/main">
   <p:cSld>
     <p:spTree>
       <p:nvGrpSpPr>
@@ -17689,7 +18249,14 @@
         <p:cNvGrpSpPr/>
         <p:nvPr/>
       </p:nvGrpSpPr>
-      <p:grpSpPr/>
+      <p:grpSpPr>
+        <a:xfrm>
+          <a:off x="0" y="0"/>
+          <a:ext cx="0" cy="0"/>
+          <a:chOff x="0" y="0"/>
+          <a:chExt cx="0" cy="0"/>
+        </a:xfrm>
+      </p:grpSpPr>
       <p:sp>
         <p:nvSpPr>
           <p:cNvPr id="2" name="Rectangle 1"/>
@@ -17731,6 +18298,7 @@
           <a:lstStyle/>
           <a:p>
             <a:pPr algn="ctr"/>
+            <a:endParaRPr/>
           </a:p>
         </p:txBody>
       </p:sp>
@@ -17775,6 +18343,7 @@
           <a:lstStyle/>
           <a:p>
             <a:pPr algn="ctr"/>
+            <a:endParaRPr/>
           </a:p>
         </p:txBody>
       </p:sp>
@@ -17819,6 +18388,7 @@
           <a:lstStyle/>
           <a:p>
             <a:pPr algn="ctr"/>
+            <a:endParaRPr/>
           </a:p>
         </p:txBody>
       </p:sp>
@@ -17936,7 +18506,7 @@
 </file>
 
 <file path=ppt/slides/slide5.xml><?xml version="1.0" encoding="utf-8"?>
-<p:sld xmlns:a="http://schemas.openxmlformats.org/drawingml/2006/main" xmlns:p="http://schemas.openxmlformats.org/presentationml/2006/main" xmlns:r="http://schemas.openxmlformats.org/officeDocument/2006/relationships">
+<p:sld xmlns:a="http://schemas.openxmlformats.org/drawingml/2006/main" xmlns:r="http://schemas.openxmlformats.org/officeDocument/2006/relationships" xmlns:p="http://schemas.openxmlformats.org/presentationml/2006/main">
   <p:cSld>
     <p:spTree>
       <p:nvGrpSpPr>
@@ -17944,7 +18514,14 @@
         <p:cNvGrpSpPr/>
         <p:nvPr/>
       </p:nvGrpSpPr>
-      <p:grpSpPr/>
+      <p:grpSpPr>
+        <a:xfrm>
+          <a:off x="0" y="0"/>
+          <a:ext cx="0" cy="0"/>
+          <a:chOff x="0" y="0"/>
+          <a:chExt cx="0" cy="0"/>
+        </a:xfrm>
+      </p:grpSpPr>
       <p:sp>
         <p:nvSpPr>
           <p:cNvPr id="2" name="Rectangle 1"/>
@@ -17986,6 +18563,7 @@
           <a:lstStyle/>
           <a:p>
             <a:pPr algn="ctr"/>
+            <a:endParaRPr/>
           </a:p>
         </p:txBody>
       </p:sp>
@@ -18030,6 +18608,7 @@
           <a:lstStyle/>
           <a:p>
             <a:pPr algn="ctr"/>
+            <a:endParaRPr/>
           </a:p>
         </p:txBody>
       </p:sp>
@@ -18144,6 +18723,7 @@
           <a:lstStyle/>
           <a:p>
             <a:pPr algn="ctr"/>
+            <a:endParaRPr/>
           </a:p>
         </p:txBody>
       </p:sp>
@@ -18188,6 +18768,7 @@
           <a:lstStyle/>
           <a:p>
             <a:pPr algn="ctr"/>
+            <a:endParaRPr/>
           </a:p>
         </p:txBody>
       </p:sp>
@@ -18511,6 +19092,7 @@
           <a:lstStyle/>
           <a:p>
             <a:pPr algn="ctr"/>
+            <a:endParaRPr/>
           </a:p>
         </p:txBody>
       </p:sp>
@@ -18706,7 +19288,7 @@
 </file>
 
 <file path=ppt/slides/slide6.xml><?xml version="1.0" encoding="utf-8"?>
-<p:sld xmlns:a="http://schemas.openxmlformats.org/drawingml/2006/main" xmlns:p="http://schemas.openxmlformats.org/presentationml/2006/main" xmlns:r="http://schemas.openxmlformats.org/officeDocument/2006/relationships">
+<p:sld xmlns:a="http://schemas.openxmlformats.org/drawingml/2006/main" xmlns:r="http://schemas.openxmlformats.org/officeDocument/2006/relationships" xmlns:p="http://schemas.openxmlformats.org/presentationml/2006/main">
   <p:cSld>
     <p:spTree>
       <p:nvGrpSpPr>
@@ -18714,7 +19296,14 @@
         <p:cNvGrpSpPr/>
         <p:nvPr/>
       </p:nvGrpSpPr>
-      <p:grpSpPr/>
+      <p:grpSpPr>
+        <a:xfrm>
+          <a:off x="0" y="0"/>
+          <a:ext cx="0" cy="0"/>
+          <a:chOff x="0" y="0"/>
+          <a:chExt cx="0" cy="0"/>
+        </a:xfrm>
+      </p:grpSpPr>
       <p:sp>
         <p:nvSpPr>
           <p:cNvPr id="2" name="Rectangle 1"/>
@@ -18756,6 +19345,7 @@
           <a:lstStyle/>
           <a:p>
             <a:pPr algn="ctr"/>
+            <a:endParaRPr/>
           </a:p>
         </p:txBody>
       </p:sp>
@@ -18800,6 +19390,7 @@
           <a:lstStyle/>
           <a:p>
             <a:pPr algn="ctr"/>
+            <a:endParaRPr/>
           </a:p>
         </p:txBody>
       </p:sp>
@@ -18914,6 +19505,7 @@
           <a:lstStyle/>
           <a:p>
             <a:pPr algn="ctr"/>
+            <a:endParaRPr/>
           </a:p>
         </p:txBody>
       </p:sp>
@@ -18958,6 +19550,7 @@
           <a:lstStyle/>
           <a:p>
             <a:pPr algn="ctr"/>
+            <a:endParaRPr/>
           </a:p>
         </p:txBody>
       </p:sp>
@@ -19081,16 +19674,34 @@
         <a:graphic>
           <a:graphicData uri="http://schemas.openxmlformats.org/drawingml/2006/table">
             <a:tbl>
-              <a:tblPr firstRow="0" bandRow="0"/>
+              <a:tblPr/>
               <a:tblGrid>
-                <a:gridCol w="2935705"/>
-                <a:gridCol w="1321067"/>
-                <a:gridCol w="1321067"/>
+                <a:gridCol w="2935705">
+                  <a:extLst>
+                    <a:ext uri="{9D8B030D-6E8A-4147-A177-3AD203B41FA5}">
+                      <a16:colId xmlns:a16="http://schemas.microsoft.com/office/drawing/2014/main" val="20000"/>
+                    </a:ext>
+                  </a:extLst>
+                </a:gridCol>
+                <a:gridCol w="1321067">
+                  <a:extLst>
+                    <a:ext uri="{9D8B030D-6E8A-4147-A177-3AD203B41FA5}">
+                      <a16:colId xmlns:a16="http://schemas.microsoft.com/office/drawing/2014/main" val="20001"/>
+                    </a:ext>
+                  </a:extLst>
+                </a:gridCol>
+                <a:gridCol w="1321067">
+                  <a:extLst>
+                    <a:ext uri="{9D8B030D-6E8A-4147-A177-3AD203B41FA5}">
+                      <a16:colId xmlns:a16="http://schemas.microsoft.com/office/drawing/2014/main" val="20002"/>
+                    </a:ext>
+                  </a:extLst>
+                </a:gridCol>
               </a:tblGrid>
               <a:tr h="384048">
                 <a:tc>
                   <a:txBody>
-                    <a:bodyPr wrap="square"/>
+                    <a:bodyPr/>
                     <a:lstStyle/>
                     <a:p>
                       <a:pPr algn="l"/>
@@ -19113,7 +19724,7 @@
                 </a:tc>
                 <a:tc>
                   <a:txBody>
-                    <a:bodyPr wrap="square"/>
+                    <a:bodyPr/>
                     <a:lstStyle/>
                     <a:p>
                       <a:pPr algn="ctr"/>
@@ -19136,7 +19747,7 @@
                 </a:tc>
                 <a:tc>
                   <a:txBody>
-                    <a:bodyPr wrap="square"/>
+                    <a:bodyPr/>
                     <a:lstStyle/>
                     <a:p>
                       <a:pPr algn="ctr"/>
@@ -19157,11 +19768,16 @@
                     </a:solidFill>
                   </a:tcPr>
                 </a:tc>
+                <a:extLst>
+                  <a:ext uri="{0D108BD9-81ED-4DB2-BD59-A6C34878D82A}">
+                    <a16:rowId xmlns:a16="http://schemas.microsoft.com/office/drawing/2014/main" val="10000"/>
+                  </a:ext>
+                </a:extLst>
               </a:tr>
               <a:tr h="384048">
                 <a:tc>
                   <a:txBody>
-                    <a:bodyPr wrap="square"/>
+                    <a:bodyPr/>
                     <a:lstStyle/>
                     <a:p>
                       <a:pPr algn="l"/>
@@ -19184,12 +19800,12 @@
                 </a:tc>
                 <a:tc>
                   <a:txBody>
-                    <a:bodyPr wrap="square"/>
+                    <a:bodyPr/>
                     <a:lstStyle/>
                     <a:p>
                       <a:pPr algn="ctr"/>
                       <a:r>
-                        <a:rPr sz="1250" b="0" i="0">
+                        <a:rPr sz="1250" b="0" i="0" dirty="0">
                           <a:solidFill>
                             <a:srgbClr val="111827"/>
                           </a:solidFill>
@@ -19207,7 +19823,7 @@
                 </a:tc>
                 <a:tc>
                   <a:txBody>
-                    <a:bodyPr wrap="square"/>
+                    <a:bodyPr/>
                     <a:lstStyle/>
                     <a:p>
                       <a:pPr algn="ctr"/>
@@ -19228,11 +19844,16 @@
                     </a:solidFill>
                   </a:tcPr>
                 </a:tc>
+                <a:extLst>
+                  <a:ext uri="{0D108BD9-81ED-4DB2-BD59-A6C34878D82A}">
+                    <a16:rowId xmlns:a16="http://schemas.microsoft.com/office/drawing/2014/main" val="10001"/>
+                  </a:ext>
+                </a:extLst>
               </a:tr>
               <a:tr h="384048">
                 <a:tc>
                   <a:txBody>
-                    <a:bodyPr wrap="square"/>
+                    <a:bodyPr/>
                     <a:lstStyle/>
                     <a:p>
                       <a:pPr algn="l"/>
@@ -19255,12 +19876,12 @@
                 </a:tc>
                 <a:tc>
                   <a:txBody>
-                    <a:bodyPr wrap="square"/>
+                    <a:bodyPr/>
                     <a:lstStyle/>
                     <a:p>
                       <a:pPr algn="ctr"/>
                       <a:r>
-                        <a:rPr sz="1250" b="0" i="0">
+                        <a:rPr sz="1250" b="0" i="0" dirty="0">
                           <a:solidFill>
                             <a:srgbClr val="111827"/>
                           </a:solidFill>
@@ -19278,7 +19899,7 @@
                 </a:tc>
                 <a:tc>
                   <a:txBody>
-                    <a:bodyPr wrap="square"/>
+                    <a:bodyPr/>
                     <a:lstStyle/>
                     <a:p>
                       <a:pPr algn="ctr"/>
@@ -19299,11 +19920,16 @@
                     </a:solidFill>
                   </a:tcPr>
                 </a:tc>
+                <a:extLst>
+                  <a:ext uri="{0D108BD9-81ED-4DB2-BD59-A6C34878D82A}">
+                    <a16:rowId xmlns:a16="http://schemas.microsoft.com/office/drawing/2014/main" val="10002"/>
+                  </a:ext>
+                </a:extLst>
               </a:tr>
               <a:tr h="384048">
                 <a:tc>
                   <a:txBody>
-                    <a:bodyPr wrap="square"/>
+                    <a:bodyPr/>
                     <a:lstStyle/>
                     <a:p>
                       <a:pPr algn="l"/>
@@ -19326,7 +19952,7 @@
                 </a:tc>
                 <a:tc>
                   <a:txBody>
-                    <a:bodyPr wrap="square"/>
+                    <a:bodyPr/>
                     <a:lstStyle/>
                     <a:p>
                       <a:pPr algn="ctr"/>
@@ -19349,7 +19975,7 @@
                 </a:tc>
                 <a:tc>
                   <a:txBody>
-                    <a:bodyPr wrap="square"/>
+                    <a:bodyPr/>
                     <a:lstStyle/>
                     <a:p>
                       <a:pPr algn="ctr"/>
@@ -19370,11 +19996,16 @@
                     </a:solidFill>
                   </a:tcPr>
                 </a:tc>
+                <a:extLst>
+                  <a:ext uri="{0D108BD9-81ED-4DB2-BD59-A6C34878D82A}">
+                    <a16:rowId xmlns:a16="http://schemas.microsoft.com/office/drawing/2014/main" val="10003"/>
+                  </a:ext>
+                </a:extLst>
               </a:tr>
               <a:tr h="384048">
                 <a:tc>
                   <a:txBody>
-                    <a:bodyPr wrap="square"/>
+                    <a:bodyPr/>
                     <a:lstStyle/>
                     <a:p>
                       <a:pPr algn="l"/>
@@ -19397,7 +20028,7 @@
                 </a:tc>
                 <a:tc>
                   <a:txBody>
-                    <a:bodyPr wrap="square"/>
+                    <a:bodyPr/>
                     <a:lstStyle/>
                     <a:p>
                       <a:pPr algn="ctr"/>
@@ -19420,7 +20051,7 @@
                 </a:tc>
                 <a:tc>
                   <a:txBody>
-                    <a:bodyPr wrap="square"/>
+                    <a:bodyPr/>
                     <a:lstStyle/>
                     <a:p>
                       <a:pPr algn="ctr"/>
@@ -19441,11 +20072,16 @@
                     </a:solidFill>
                   </a:tcPr>
                 </a:tc>
+                <a:extLst>
+                  <a:ext uri="{0D108BD9-81ED-4DB2-BD59-A6C34878D82A}">
+                    <a16:rowId xmlns:a16="http://schemas.microsoft.com/office/drawing/2014/main" val="10004"/>
+                  </a:ext>
+                </a:extLst>
               </a:tr>
               <a:tr h="384048">
                 <a:tc>
                   <a:txBody>
-                    <a:bodyPr wrap="square"/>
+                    <a:bodyPr/>
                     <a:lstStyle/>
                     <a:p>
                       <a:pPr algn="l"/>
@@ -19468,7 +20104,7 @@
                 </a:tc>
                 <a:tc>
                   <a:txBody>
-                    <a:bodyPr wrap="square"/>
+                    <a:bodyPr/>
                     <a:lstStyle/>
                     <a:p>
                       <a:pPr algn="ctr"/>
@@ -19491,7 +20127,7 @@
                 </a:tc>
                 <a:tc>
                   <a:txBody>
-                    <a:bodyPr wrap="square"/>
+                    <a:bodyPr/>
                     <a:lstStyle/>
                     <a:p>
                       <a:pPr algn="ctr"/>
@@ -19512,11 +20148,16 @@
                     </a:solidFill>
                   </a:tcPr>
                 </a:tc>
+                <a:extLst>
+                  <a:ext uri="{0D108BD9-81ED-4DB2-BD59-A6C34878D82A}">
+                    <a16:rowId xmlns:a16="http://schemas.microsoft.com/office/drawing/2014/main" val="10005"/>
+                  </a:ext>
+                </a:extLst>
               </a:tr>
               <a:tr h="384048">
                 <a:tc>
                   <a:txBody>
-                    <a:bodyPr wrap="square"/>
+                    <a:bodyPr/>
                     <a:lstStyle/>
                     <a:p>
                       <a:pPr algn="l"/>
@@ -19539,7 +20180,7 @@
                 </a:tc>
                 <a:tc>
                   <a:txBody>
-                    <a:bodyPr wrap="square"/>
+                    <a:bodyPr/>
                     <a:lstStyle/>
                     <a:p>
                       <a:pPr algn="ctr"/>
@@ -19562,7 +20203,7 @@
                 </a:tc>
                 <a:tc>
                   <a:txBody>
-                    <a:bodyPr wrap="square"/>
+                    <a:bodyPr/>
                     <a:lstStyle/>
                     <a:p>
                       <a:pPr algn="ctr"/>
@@ -19583,11 +20224,16 @@
                     </a:solidFill>
                   </a:tcPr>
                 </a:tc>
+                <a:extLst>
+                  <a:ext uri="{0D108BD9-81ED-4DB2-BD59-A6C34878D82A}">
+                    <a16:rowId xmlns:a16="http://schemas.microsoft.com/office/drawing/2014/main" val="10006"/>
+                  </a:ext>
+                </a:extLst>
               </a:tr>
               <a:tr h="384048">
                 <a:tc>
                   <a:txBody>
-                    <a:bodyPr wrap="square"/>
+                    <a:bodyPr/>
                     <a:lstStyle/>
                     <a:p>
                       <a:pPr algn="l"/>
@@ -19610,7 +20256,7 @@
                 </a:tc>
                 <a:tc>
                   <a:txBody>
-                    <a:bodyPr wrap="square"/>
+                    <a:bodyPr/>
                     <a:lstStyle/>
                     <a:p>
                       <a:pPr algn="ctr"/>
@@ -19633,12 +20279,12 @@
                 </a:tc>
                 <a:tc>
                   <a:txBody>
-                    <a:bodyPr wrap="square"/>
+                    <a:bodyPr/>
                     <a:lstStyle/>
                     <a:p>
                       <a:pPr algn="ctr"/>
                       <a:r>
-                        <a:rPr sz="1250" b="0" i="0">
+                        <a:rPr sz="1250" b="0" i="0" dirty="0">
                           <a:solidFill>
                             <a:srgbClr val="111827"/>
                           </a:solidFill>
@@ -19654,6 +20300,11 @@
                     </a:solidFill>
                   </a:tcPr>
                 </a:tc>
+                <a:extLst>
+                  <a:ext uri="{0D108BD9-81ED-4DB2-BD59-A6C34878D82A}">
+                    <a16:rowId xmlns:a16="http://schemas.microsoft.com/office/drawing/2014/main" val="10007"/>
+                  </a:ext>
+                </a:extLst>
               </a:tr>
             </a:tbl>
           </a:graphicData>
@@ -19816,7 +20467,7 @@
 </file>
 
 <file path=ppt/slides/slide7.xml><?xml version="1.0" encoding="utf-8"?>
-<p:sld xmlns:a="http://schemas.openxmlformats.org/drawingml/2006/main" xmlns:p="http://schemas.openxmlformats.org/presentationml/2006/main" xmlns:r="http://schemas.openxmlformats.org/officeDocument/2006/relationships">
+<p:sld xmlns:a="http://schemas.openxmlformats.org/drawingml/2006/main" xmlns:r="http://schemas.openxmlformats.org/officeDocument/2006/relationships" xmlns:p="http://schemas.openxmlformats.org/presentationml/2006/main">
   <p:cSld>
     <p:spTree>
       <p:nvGrpSpPr>
@@ -19824,7 +20475,14 @@
         <p:cNvGrpSpPr/>
         <p:nvPr/>
       </p:nvGrpSpPr>
-      <p:grpSpPr/>
+      <p:grpSpPr>
+        <a:xfrm>
+          <a:off x="0" y="0"/>
+          <a:ext cx="0" cy="0"/>
+          <a:chOff x="0" y="0"/>
+          <a:chExt cx="0" cy="0"/>
+        </a:xfrm>
+      </p:grpSpPr>
       <p:sp>
         <p:nvSpPr>
           <p:cNvPr id="2" name="Rectangle 1"/>
@@ -19866,6 +20524,7 @@
           <a:lstStyle/>
           <a:p>
             <a:pPr algn="ctr"/>
+            <a:endParaRPr/>
           </a:p>
         </p:txBody>
       </p:sp>
@@ -19910,6 +20569,7 @@
           <a:lstStyle/>
           <a:p>
             <a:pPr algn="ctr"/>
+            <a:endParaRPr/>
           </a:p>
         </p:txBody>
       </p:sp>
@@ -20024,6 +20684,7 @@
           <a:lstStyle/>
           <a:p>
             <a:pPr algn="ctr"/>
+            <a:endParaRPr/>
           </a:p>
         </p:txBody>
       </p:sp>
@@ -20068,6 +20729,7 @@
           <a:lstStyle/>
           <a:p>
             <a:pPr algn="ctr"/>
+            <a:endParaRPr/>
           </a:p>
         </p:txBody>
       </p:sp>
@@ -20221,6 +20883,7 @@
           <a:lstStyle/>
           <a:p>
             <a:pPr algn="ctr"/>
+            <a:endParaRPr/>
           </a:p>
         </p:txBody>
       </p:sp>
@@ -20359,6 +21022,7 @@
           <a:lstStyle/>
           <a:p>
             <a:pPr algn="ctr"/>
+            <a:endParaRPr/>
           </a:p>
         </p:txBody>
       </p:sp>
@@ -20497,6 +21161,7 @@
           <a:lstStyle/>
           <a:p>
             <a:pPr algn="ctr"/>
+            <a:endParaRPr/>
           </a:p>
         </p:txBody>
       </p:sp>
@@ -20564,7 +21229,7 @@
 </file>
 
 <file path=ppt/slides/slide8.xml><?xml version="1.0" encoding="utf-8"?>
-<p:sld xmlns:a="http://schemas.openxmlformats.org/drawingml/2006/main" xmlns:p="http://schemas.openxmlformats.org/presentationml/2006/main" xmlns:r="http://schemas.openxmlformats.org/officeDocument/2006/relationships">
+<p:sld xmlns:a="http://schemas.openxmlformats.org/drawingml/2006/main" xmlns:r="http://schemas.openxmlformats.org/officeDocument/2006/relationships" xmlns:p="http://schemas.openxmlformats.org/presentationml/2006/main">
   <p:cSld>
     <p:spTree>
       <p:nvGrpSpPr>
@@ -20572,7 +21237,14 @@
         <p:cNvGrpSpPr/>
         <p:nvPr/>
       </p:nvGrpSpPr>
-      <p:grpSpPr/>
+      <p:grpSpPr>
+        <a:xfrm>
+          <a:off x="0" y="0"/>
+          <a:ext cx="0" cy="0"/>
+          <a:chOff x="0" y="0"/>
+          <a:chExt cx="0" cy="0"/>
+        </a:xfrm>
+      </p:grpSpPr>
       <p:sp>
         <p:nvSpPr>
           <p:cNvPr id="2" name="Rectangle 1"/>
@@ -20614,6 +21286,7 @@
           <a:lstStyle/>
           <a:p>
             <a:pPr algn="ctr"/>
+            <a:endParaRPr/>
           </a:p>
         </p:txBody>
       </p:sp>
@@ -20658,6 +21331,7 @@
           <a:lstStyle/>
           <a:p>
             <a:pPr algn="ctr"/>
+            <a:endParaRPr/>
           </a:p>
         </p:txBody>
       </p:sp>
@@ -20772,6 +21446,7 @@
           <a:lstStyle/>
           <a:p>
             <a:pPr algn="ctr"/>
+            <a:endParaRPr/>
           </a:p>
         </p:txBody>
       </p:sp>
@@ -20816,6 +21491,7 @@
           <a:lstStyle/>
           <a:p>
             <a:pPr algn="ctr"/>
+            <a:endParaRPr/>
           </a:p>
         </p:txBody>
       </p:sp>
@@ -20969,6 +21645,7 @@
           <a:lstStyle/>
           <a:p>
             <a:pPr algn="ctr"/>
+            <a:endParaRPr/>
           </a:p>
         </p:txBody>
       </p:sp>
@@ -21123,6 +21800,7 @@
           <a:lstStyle/>
           <a:p>
             <a:pPr algn="ctr"/>
+            <a:endParaRPr/>
           </a:p>
         </p:txBody>
       </p:sp>
@@ -21240,6 +21918,7 @@
           <a:lstStyle/>
           <a:p>
             <a:pPr algn="ctr"/>
+            <a:endParaRPr/>
           </a:p>
         </p:txBody>
       </p:sp>
@@ -21307,7 +21986,7 @@
 </file>
 
 <file path=ppt/slides/slide9.xml><?xml version="1.0" encoding="utf-8"?>
-<p:sld xmlns:a="http://schemas.openxmlformats.org/drawingml/2006/main" xmlns:p="http://schemas.openxmlformats.org/presentationml/2006/main" xmlns:r="http://schemas.openxmlformats.org/officeDocument/2006/relationships">
+<p:sld xmlns:a="http://schemas.openxmlformats.org/drawingml/2006/main" xmlns:r="http://schemas.openxmlformats.org/officeDocument/2006/relationships" xmlns:p="http://schemas.openxmlformats.org/presentationml/2006/main">
   <p:cSld>
     <p:spTree>
       <p:nvGrpSpPr>
@@ -21315,7 +21994,14 @@
         <p:cNvGrpSpPr/>
         <p:nvPr/>
       </p:nvGrpSpPr>
-      <p:grpSpPr/>
+      <p:grpSpPr>
+        <a:xfrm>
+          <a:off x="0" y="0"/>
+          <a:ext cx="0" cy="0"/>
+          <a:chOff x="0" y="0"/>
+          <a:chExt cx="0" cy="0"/>
+        </a:xfrm>
+      </p:grpSpPr>
       <p:sp>
         <p:nvSpPr>
           <p:cNvPr id="2" name="Rectangle 1"/>
@@ -21357,6 +22043,7 @@
           <a:lstStyle/>
           <a:p>
             <a:pPr algn="ctr"/>
+            <a:endParaRPr/>
           </a:p>
         </p:txBody>
       </p:sp>
@@ -21401,6 +22088,7 @@
           <a:lstStyle/>
           <a:p>
             <a:pPr algn="ctr"/>
+            <a:endParaRPr/>
           </a:p>
         </p:txBody>
       </p:sp>
@@ -21515,6 +22203,7 @@
           <a:lstStyle/>
           <a:p>
             <a:pPr algn="ctr"/>
+            <a:endParaRPr/>
           </a:p>
         </p:txBody>
       </p:sp>
@@ -21559,6 +22248,7 @@
           <a:lstStyle/>
           <a:p>
             <a:pPr algn="ctr"/>
+            <a:endParaRPr/>
           </a:p>
         </p:txBody>
       </p:sp>
@@ -21780,15 +22470,27 @@
         <a:graphic>
           <a:graphicData uri="http://schemas.openxmlformats.org/drawingml/2006/table">
             <a:tbl>
-              <a:tblPr firstRow="0" bandRow="0"/>
+              <a:tblPr/>
               <a:tblGrid>
-                <a:gridCol w="1407056"/>
-                <a:gridCol w="3896463"/>
+                <a:gridCol w="1407056">
+                  <a:extLst>
+                    <a:ext uri="{9D8B030D-6E8A-4147-A177-3AD203B41FA5}">
+                      <a16:colId xmlns:a16="http://schemas.microsoft.com/office/drawing/2014/main" val="20000"/>
+                    </a:ext>
+                  </a:extLst>
+                </a:gridCol>
+                <a:gridCol w="3896463">
+                  <a:extLst>
+                    <a:ext uri="{9D8B030D-6E8A-4147-A177-3AD203B41FA5}">
+                      <a16:colId xmlns:a16="http://schemas.microsoft.com/office/drawing/2014/main" val="20001"/>
+                    </a:ext>
+                  </a:extLst>
+                </a:gridCol>
               </a:tblGrid>
               <a:tr h="502920">
                 <a:tc>
                   <a:txBody>
-                    <a:bodyPr wrap="square"/>
+                    <a:bodyPr/>
                     <a:lstStyle/>
                     <a:p>
                       <a:pPr algn="l"/>
@@ -21811,7 +22513,7 @@
                 </a:tc>
                 <a:tc>
                   <a:txBody>
-                    <a:bodyPr wrap="square"/>
+                    <a:bodyPr/>
                     <a:lstStyle/>
                     <a:p>
                       <a:pPr algn="ctr"/>
@@ -21832,11 +22534,16 @@
                     </a:solidFill>
                   </a:tcPr>
                 </a:tc>
+                <a:extLst>
+                  <a:ext uri="{0D108BD9-81ED-4DB2-BD59-A6C34878D82A}">
+                    <a16:rowId xmlns:a16="http://schemas.microsoft.com/office/drawing/2014/main" val="10000"/>
+                  </a:ext>
+                </a:extLst>
               </a:tr>
               <a:tr h="502920">
                 <a:tc>
                   <a:txBody>
-                    <a:bodyPr wrap="square"/>
+                    <a:bodyPr/>
                     <a:lstStyle/>
                     <a:p>
                       <a:pPr algn="l"/>
@@ -21859,7 +22566,7 @@
                 </a:tc>
                 <a:tc>
                   <a:txBody>
-                    <a:bodyPr wrap="square"/>
+                    <a:bodyPr/>
                     <a:lstStyle/>
                     <a:p>
                       <a:pPr algn="ctr"/>
@@ -21880,11 +22587,16 @@
                     </a:solidFill>
                   </a:tcPr>
                 </a:tc>
+                <a:extLst>
+                  <a:ext uri="{0D108BD9-81ED-4DB2-BD59-A6C34878D82A}">
+                    <a16:rowId xmlns:a16="http://schemas.microsoft.com/office/drawing/2014/main" val="10001"/>
+                  </a:ext>
+                </a:extLst>
               </a:tr>
               <a:tr h="502920">
                 <a:tc>
                   <a:txBody>
-                    <a:bodyPr wrap="square"/>
+                    <a:bodyPr/>
                     <a:lstStyle/>
                     <a:p>
                       <a:pPr algn="l"/>
@@ -21907,7 +22619,7 @@
                 </a:tc>
                 <a:tc>
                   <a:txBody>
-                    <a:bodyPr wrap="square"/>
+                    <a:bodyPr/>
                     <a:lstStyle/>
                     <a:p>
                       <a:pPr algn="ctr"/>
@@ -21928,6 +22640,11 @@
                     </a:solidFill>
                   </a:tcPr>
                 </a:tc>
+                <a:extLst>
+                  <a:ext uri="{0D108BD9-81ED-4DB2-BD59-A6C34878D82A}">
+                    <a16:rowId xmlns:a16="http://schemas.microsoft.com/office/drawing/2014/main" val="10002"/>
+                  </a:ext>
+                </a:extLst>
               </a:tr>
             </a:tbl>
           </a:graphicData>
@@ -21941,7 +22658,7 @@
         </p:nvSpPr>
         <p:spPr>
           <a:xfrm>
-            <a:off x="6355080" y="3063240"/>
+            <a:off x="6382512" y="5006340"/>
             <a:ext cx="5303520" cy="1234440"/>
           </a:xfrm>
           <a:prstGeom prst="roundRect">
@@ -21978,6 +22695,7 @@
           <a:lstStyle/>
           <a:p>
             <a:pPr algn="ctr"/>
+            <a:endParaRPr/>
           </a:p>
         </p:txBody>
       </p:sp>
@@ -21989,7 +22707,7 @@
         </p:nvSpPr>
         <p:spPr>
           <a:xfrm>
-            <a:off x="6583680" y="3172968"/>
+            <a:off x="6560819" y="5184648"/>
             <a:ext cx="4892040" cy="1005840"/>
           </a:xfrm>
           <a:prstGeom prst="rect">
@@ -22009,7 +22727,7 @@
               </a:spcAft>
             </a:pPr>
             <a:r>
-              <a:rPr sz="1200" b="1" i="0">
+              <a:rPr sz="1200" b="1" i="0" dirty="0">
                 <a:solidFill>
                   <a:srgbClr val="2563EB"/>
                 </a:solidFill>
@@ -22025,7 +22743,7 @@
               </a:spcAft>
             </a:pPr>
             <a:r>
-              <a:rPr sz="1250" b="0" i="0">
+              <a:rPr sz="1250" b="0" i="0" dirty="0">
                 <a:solidFill>
                   <a:srgbClr val="111827"/>
                 </a:solidFill>
@@ -22041,7 +22759,7 @@
               </a:spcAft>
             </a:pPr>
             <a:r>
-              <a:rPr sz="1250" b="0" i="0">
+              <a:rPr sz="1250" b="0" i="0" dirty="0">
                 <a:solidFill>
                   <a:srgbClr val="111827"/>
                 </a:solidFill>

</xml_diff>